<commit_message>
Add blockchain-primary-ledger row to comparison table
Answers whether the blockchain is the legally authoritative ledger for
each fund: No for BENJI/BUIDL/USTB/USCC/WTGXX (the transfer agent's
off-chain record controls in every documented case), Not disclosed for
OUSG.

Co-Authored-By: Claude Sonnet 5 <noreply@anthropic.com>
Claude-Session: https://claude.ai/code/session_01XLt1ze3JWdaihuSAsk6TrZ
</commit_message>
<xml_diff>
--- a/docs/presentations/Tokenized_Funds_Comparative_Analysis.pptx
+++ b/docs/presentations/Tokenized_Funds_Comparative_Analysis.pptx
@@ -21841,6 +21841,484 @@
                           <a:ea typeface="Calibri" pitchFamily="34" charset="-122"/>
                           <a:cs typeface="Calibri" pitchFamily="34" charset="-120"/>
                         </a:rPr>
+                        <a:t>Blockchain is primary ledger?</a:t>
+                      </a:r>
+                      <a:endParaRPr lang="en-US" sz="830" dirty="0">
+                        <a:latin typeface="Calibri" charset="0"/>
+                        <a:ea typeface="Calibri" charset="0"/>
+                        <a:cs typeface="Calibri" charset="0"/>
+                      </a:endParaRPr>
+                    </a:p>
+                  </a:txBody>
+                  <a:tcPr marL="76200" marR="76200" marT="38100" marB="38100" anchor="ctr">
+                    <a:lnL w="9525" cap="flat" cmpd="sng" algn="ctr">
+                      <a:solidFill>
+                        <a:srgbClr val="D7E1F5"/>
+                      </a:solidFill>
+                      <a:prstDash val="solid"/>
+                      <a:round/>
+                      <a:headEnd type="none" w="med" len="med"/>
+                      <a:tailEnd type="none" w="med" len="med"/>
+                    </a:lnL>
+                    <a:lnR w="9525" cap="flat" cmpd="sng" algn="ctr">
+                      <a:solidFill>
+                        <a:srgbClr val="D7E1F5"/>
+                      </a:solidFill>
+                      <a:prstDash val="solid"/>
+                      <a:round/>
+                      <a:headEnd type="none" w="med" len="med"/>
+                      <a:tailEnd type="none" w="med" len="med"/>
+                    </a:lnR>
+                    <a:lnT w="9525" cap="flat" cmpd="sng" algn="ctr">
+                      <a:solidFill>
+                        <a:srgbClr val="D7E1F5"/>
+                      </a:solidFill>
+                      <a:prstDash val="solid"/>
+                      <a:round/>
+                      <a:headEnd type="none" w="med" len="med"/>
+                      <a:tailEnd type="none" w="med" len="med"/>
+                    </a:lnT>
+                    <a:lnB w="9525" cap="flat" cmpd="sng" algn="ctr">
+                      <a:solidFill>
+                        <a:srgbClr val="D7E1F5"/>
+                      </a:solidFill>
+                      <a:prstDash val="solid"/>
+                      <a:round/>
+                      <a:headEnd type="none" w="med" len="med"/>
+                      <a:tailEnd type="none" w="med" len="med"/>
+                    </a:lnB>
+                    <a:solidFill>
+                      <a:srgbClr val="FFFFFF"/>
+                    </a:solidFill>
+                  </a:tcPr>
+                </a:tc>
+                <a:tc>
+                  <a:txBody>
+                    <a:bodyPr/>
+                    <a:lstStyle/>
+                    <a:p>
+                      <a:pPr algn="ctr" indent="0" marL="0">
+                        <a:buNone/>
+                      </a:pPr>
+                      <a:r>
+                        <a:rPr lang="en-US" sz="830" dirty="0">
+                          <a:solidFill>
+                            <a:srgbClr val="3A4566"/>
+                          </a:solidFill>
+                          <a:latin typeface="Calibri" pitchFamily="34" charset="0"/>
+                          <a:ea typeface="Calibri" pitchFamily="34" charset="-122"/>
+                          <a:cs typeface="Calibri" pitchFamily="34" charset="-120"/>
+                        </a:rPr>
+                        <a:t>No — secondary record</a:t>
+                      </a:r>
+                      <a:endParaRPr lang="en-US" sz="830" dirty="0">
+                        <a:latin typeface="Calibri" charset="0"/>
+                        <a:ea typeface="Calibri" charset="0"/>
+                        <a:cs typeface="Calibri" charset="0"/>
+                      </a:endParaRPr>
+                    </a:p>
+                  </a:txBody>
+                  <a:tcPr marL="76200" marR="76200" marT="38100" marB="38100" anchor="ctr">
+                    <a:lnL w="9525" cap="flat" cmpd="sng" algn="ctr">
+                      <a:solidFill>
+                        <a:srgbClr val="D7E1F5"/>
+                      </a:solidFill>
+                      <a:prstDash val="solid"/>
+                      <a:round/>
+                      <a:headEnd type="none" w="med" len="med"/>
+                      <a:tailEnd type="none" w="med" len="med"/>
+                    </a:lnL>
+                    <a:lnR w="9525" cap="flat" cmpd="sng" algn="ctr">
+                      <a:solidFill>
+                        <a:srgbClr val="D7E1F5"/>
+                      </a:solidFill>
+                      <a:prstDash val="solid"/>
+                      <a:round/>
+                      <a:headEnd type="none" w="med" len="med"/>
+                      <a:tailEnd type="none" w="med" len="med"/>
+                    </a:lnR>
+                    <a:lnT w="9525" cap="flat" cmpd="sng" algn="ctr">
+                      <a:solidFill>
+                        <a:srgbClr val="D7E1F5"/>
+                      </a:solidFill>
+                      <a:prstDash val="solid"/>
+                      <a:round/>
+                      <a:headEnd type="none" w="med" len="med"/>
+                      <a:tailEnd type="none" w="med" len="med"/>
+                    </a:lnT>
+                    <a:lnB w="9525" cap="flat" cmpd="sng" algn="ctr">
+                      <a:solidFill>
+                        <a:srgbClr val="D7E1F5"/>
+                      </a:solidFill>
+                      <a:prstDash val="solid"/>
+                      <a:round/>
+                      <a:headEnd type="none" w="med" len="med"/>
+                      <a:tailEnd type="none" w="med" len="med"/>
+                    </a:lnB>
+                    <a:solidFill>
+                      <a:srgbClr val="FFFFFF"/>
+                    </a:solidFill>
+                  </a:tcPr>
+                </a:tc>
+                <a:tc>
+                  <a:txBody>
+                    <a:bodyPr/>
+                    <a:lstStyle/>
+                    <a:p>
+                      <a:pPr algn="ctr" indent="0" marL="0">
+                        <a:buNone/>
+                      </a:pPr>
+                      <a:r>
+                        <a:rPr lang="en-US" sz="830" dirty="0">
+                          <a:solidFill>
+                            <a:srgbClr val="3A4566"/>
+                          </a:solidFill>
+                          <a:latin typeface="Calibri" pitchFamily="34" charset="0"/>
+                          <a:ea typeface="Calibri" pitchFamily="34" charset="-122"/>
+                          <a:cs typeface="Calibri" pitchFamily="34" charset="-120"/>
+                        </a:rPr>
+                        <a:t>No — TA record controls</a:t>
+                      </a:r>
+                      <a:endParaRPr lang="en-US" sz="830" dirty="0">
+                        <a:latin typeface="Calibri" charset="0"/>
+                        <a:ea typeface="Calibri" charset="0"/>
+                        <a:cs typeface="Calibri" charset="0"/>
+                      </a:endParaRPr>
+                    </a:p>
+                  </a:txBody>
+                  <a:tcPr marL="76200" marR="76200" marT="38100" marB="38100" anchor="ctr">
+                    <a:lnL w="9525" cap="flat" cmpd="sng" algn="ctr">
+                      <a:solidFill>
+                        <a:srgbClr val="D7E1F5"/>
+                      </a:solidFill>
+                      <a:prstDash val="solid"/>
+                      <a:round/>
+                      <a:headEnd type="none" w="med" len="med"/>
+                      <a:tailEnd type="none" w="med" len="med"/>
+                    </a:lnL>
+                    <a:lnR w="9525" cap="flat" cmpd="sng" algn="ctr">
+                      <a:solidFill>
+                        <a:srgbClr val="D7E1F5"/>
+                      </a:solidFill>
+                      <a:prstDash val="solid"/>
+                      <a:round/>
+                      <a:headEnd type="none" w="med" len="med"/>
+                      <a:tailEnd type="none" w="med" len="med"/>
+                    </a:lnR>
+                    <a:lnT w="9525" cap="flat" cmpd="sng" algn="ctr">
+                      <a:solidFill>
+                        <a:srgbClr val="D7E1F5"/>
+                      </a:solidFill>
+                      <a:prstDash val="solid"/>
+                      <a:round/>
+                      <a:headEnd type="none" w="med" len="med"/>
+                      <a:tailEnd type="none" w="med" len="med"/>
+                    </a:lnT>
+                    <a:lnB w="9525" cap="flat" cmpd="sng" algn="ctr">
+                      <a:solidFill>
+                        <a:srgbClr val="D7E1F5"/>
+                      </a:solidFill>
+                      <a:prstDash val="solid"/>
+                      <a:round/>
+                      <a:headEnd type="none" w="med" len="med"/>
+                      <a:tailEnd type="none" w="med" len="med"/>
+                    </a:lnB>
+                    <a:solidFill>
+                      <a:srgbClr val="FFFFFF"/>
+                    </a:solidFill>
+                  </a:tcPr>
+                </a:tc>
+                <a:tc>
+                  <a:txBody>
+                    <a:bodyPr/>
+                    <a:lstStyle/>
+                    <a:p>
+                      <a:pPr algn="ctr" indent="0" marL="0">
+                        <a:buNone/>
+                      </a:pPr>
+                      <a:r>
+                        <a:rPr lang="en-US" sz="830" dirty="0">
+                          <a:solidFill>
+                            <a:srgbClr val="3A4566"/>
+                          </a:solidFill>
+                          <a:latin typeface="Calibri" pitchFamily="34" charset="0"/>
+                          <a:ea typeface="Calibri" pitchFamily="34" charset="-122"/>
+                          <a:cs typeface="Calibri" pitchFamily="34" charset="-120"/>
+                        </a:rPr>
+                        <a:t>No — TA record controls</a:t>
+                      </a:r>
+                      <a:endParaRPr lang="en-US" sz="830" dirty="0">
+                        <a:latin typeface="Calibri" charset="0"/>
+                        <a:ea typeface="Calibri" charset="0"/>
+                        <a:cs typeface="Calibri" charset="0"/>
+                      </a:endParaRPr>
+                    </a:p>
+                  </a:txBody>
+                  <a:tcPr marL="76200" marR="76200" marT="38100" marB="38100" anchor="ctr">
+                    <a:lnL w="9525" cap="flat" cmpd="sng" algn="ctr">
+                      <a:solidFill>
+                        <a:srgbClr val="D7E1F5"/>
+                      </a:solidFill>
+                      <a:prstDash val="solid"/>
+                      <a:round/>
+                      <a:headEnd type="none" w="med" len="med"/>
+                      <a:tailEnd type="none" w="med" len="med"/>
+                    </a:lnL>
+                    <a:lnR w="9525" cap="flat" cmpd="sng" algn="ctr">
+                      <a:solidFill>
+                        <a:srgbClr val="D7E1F5"/>
+                      </a:solidFill>
+                      <a:prstDash val="solid"/>
+                      <a:round/>
+                      <a:headEnd type="none" w="med" len="med"/>
+                      <a:tailEnd type="none" w="med" len="med"/>
+                    </a:lnR>
+                    <a:lnT w="9525" cap="flat" cmpd="sng" algn="ctr">
+                      <a:solidFill>
+                        <a:srgbClr val="D7E1F5"/>
+                      </a:solidFill>
+                      <a:prstDash val="solid"/>
+                      <a:round/>
+                      <a:headEnd type="none" w="med" len="med"/>
+                      <a:tailEnd type="none" w="med" len="med"/>
+                    </a:lnT>
+                    <a:lnB w="9525" cap="flat" cmpd="sng" algn="ctr">
+                      <a:solidFill>
+                        <a:srgbClr val="D7E1F5"/>
+                      </a:solidFill>
+                      <a:prstDash val="solid"/>
+                      <a:round/>
+                      <a:headEnd type="none" w="med" len="med"/>
+                      <a:tailEnd type="none" w="med" len="med"/>
+                    </a:lnB>
+                    <a:solidFill>
+                      <a:srgbClr val="FFFFFF"/>
+                    </a:solidFill>
+                  </a:tcPr>
+                </a:tc>
+                <a:tc>
+                  <a:txBody>
+                    <a:bodyPr/>
+                    <a:lstStyle/>
+                    <a:p>
+                      <a:pPr algn="ctr" indent="0" marL="0">
+                        <a:buNone/>
+                      </a:pPr>
+                      <a:r>
+                        <a:rPr lang="en-US" sz="830" dirty="0">
+                          <a:solidFill>
+                            <a:srgbClr val="3A4566"/>
+                          </a:solidFill>
+                          <a:latin typeface="Calibri" pitchFamily="34" charset="0"/>
+                          <a:ea typeface="Calibri" pitchFamily="34" charset="-122"/>
+                          <a:cs typeface="Calibri" pitchFamily="34" charset="-120"/>
+                        </a:rPr>
+                        <a:t>No — TA record controls</a:t>
+                      </a:r>
+                      <a:endParaRPr lang="en-US" sz="830" dirty="0">
+                        <a:latin typeface="Calibri" charset="0"/>
+                        <a:ea typeface="Calibri" charset="0"/>
+                        <a:cs typeface="Calibri" charset="0"/>
+                      </a:endParaRPr>
+                    </a:p>
+                  </a:txBody>
+                  <a:tcPr marL="76200" marR="76200" marT="38100" marB="38100" anchor="ctr">
+                    <a:lnL w="9525" cap="flat" cmpd="sng" algn="ctr">
+                      <a:solidFill>
+                        <a:srgbClr val="D7E1F5"/>
+                      </a:solidFill>
+                      <a:prstDash val="solid"/>
+                      <a:round/>
+                      <a:headEnd type="none" w="med" len="med"/>
+                      <a:tailEnd type="none" w="med" len="med"/>
+                    </a:lnL>
+                    <a:lnR w="9525" cap="flat" cmpd="sng" algn="ctr">
+                      <a:solidFill>
+                        <a:srgbClr val="D7E1F5"/>
+                      </a:solidFill>
+                      <a:prstDash val="solid"/>
+                      <a:round/>
+                      <a:headEnd type="none" w="med" len="med"/>
+                      <a:tailEnd type="none" w="med" len="med"/>
+                    </a:lnR>
+                    <a:lnT w="9525" cap="flat" cmpd="sng" algn="ctr">
+                      <a:solidFill>
+                        <a:srgbClr val="D7E1F5"/>
+                      </a:solidFill>
+                      <a:prstDash val="solid"/>
+                      <a:round/>
+                      <a:headEnd type="none" w="med" len="med"/>
+                      <a:tailEnd type="none" w="med" len="med"/>
+                    </a:lnT>
+                    <a:lnB w="9525" cap="flat" cmpd="sng" algn="ctr">
+                      <a:solidFill>
+                        <a:srgbClr val="D7E1F5"/>
+                      </a:solidFill>
+                      <a:prstDash val="solid"/>
+                      <a:round/>
+                      <a:headEnd type="none" w="med" len="med"/>
+                      <a:tailEnd type="none" w="med" len="med"/>
+                    </a:lnB>
+                    <a:solidFill>
+                      <a:srgbClr val="FFFFFF"/>
+                    </a:solidFill>
+                  </a:tcPr>
+                </a:tc>
+                <a:tc>
+                  <a:txBody>
+                    <a:bodyPr/>
+                    <a:lstStyle/>
+                    <a:p>
+                      <a:pPr algn="ctr" indent="0" marL="0">
+                        <a:buNone/>
+                      </a:pPr>
+                      <a:r>
+                        <a:rPr lang="en-US" sz="830" dirty="0">
+                          <a:solidFill>
+                            <a:srgbClr val="3A4566"/>
+                          </a:solidFill>
+                          <a:latin typeface="Calibri" pitchFamily="34" charset="0"/>
+                          <a:ea typeface="Calibri" pitchFamily="34" charset="-122"/>
+                          <a:cs typeface="Calibri" pitchFamily="34" charset="-120"/>
+                        </a:rPr>
+                        <a:t>Not disclosed</a:t>
+                      </a:r>
+                      <a:endParaRPr lang="en-US" sz="830" dirty="0">
+                        <a:latin typeface="Calibri" charset="0"/>
+                        <a:ea typeface="Calibri" charset="0"/>
+                        <a:cs typeface="Calibri" charset="0"/>
+                      </a:endParaRPr>
+                    </a:p>
+                  </a:txBody>
+                  <a:tcPr marL="76200" marR="76200" marT="38100" marB="38100" anchor="ctr">
+                    <a:lnL w="9525" cap="flat" cmpd="sng" algn="ctr">
+                      <a:solidFill>
+                        <a:srgbClr val="D7E1F5"/>
+                      </a:solidFill>
+                      <a:prstDash val="solid"/>
+                      <a:round/>
+                      <a:headEnd type="none" w="med" len="med"/>
+                      <a:tailEnd type="none" w="med" len="med"/>
+                    </a:lnL>
+                    <a:lnR w="9525" cap="flat" cmpd="sng" algn="ctr">
+                      <a:solidFill>
+                        <a:srgbClr val="D7E1F5"/>
+                      </a:solidFill>
+                      <a:prstDash val="solid"/>
+                      <a:round/>
+                      <a:headEnd type="none" w="med" len="med"/>
+                      <a:tailEnd type="none" w="med" len="med"/>
+                    </a:lnR>
+                    <a:lnT w="9525" cap="flat" cmpd="sng" algn="ctr">
+                      <a:solidFill>
+                        <a:srgbClr val="D7E1F5"/>
+                      </a:solidFill>
+                      <a:prstDash val="solid"/>
+                      <a:round/>
+                      <a:headEnd type="none" w="med" len="med"/>
+                      <a:tailEnd type="none" w="med" len="med"/>
+                    </a:lnT>
+                    <a:lnB w="9525" cap="flat" cmpd="sng" algn="ctr">
+                      <a:solidFill>
+                        <a:srgbClr val="D7E1F5"/>
+                      </a:solidFill>
+                      <a:prstDash val="solid"/>
+                      <a:round/>
+                      <a:headEnd type="none" w="med" len="med"/>
+                      <a:tailEnd type="none" w="med" len="med"/>
+                    </a:lnB>
+                    <a:solidFill>
+                      <a:srgbClr val="FFFFFF"/>
+                    </a:solidFill>
+                  </a:tcPr>
+                </a:tc>
+                <a:tc>
+                  <a:txBody>
+                    <a:bodyPr/>
+                    <a:lstStyle/>
+                    <a:p>
+                      <a:pPr algn="ctr" indent="0" marL="0">
+                        <a:buNone/>
+                      </a:pPr>
+                      <a:r>
+                        <a:rPr lang="en-US" sz="830" dirty="0">
+                          <a:solidFill>
+                            <a:srgbClr val="3A4566"/>
+                          </a:solidFill>
+                          <a:latin typeface="Calibri" pitchFamily="34" charset="0"/>
+                          <a:ea typeface="Calibri" pitchFamily="34" charset="-122"/>
+                          <a:cs typeface="Calibri" pitchFamily="34" charset="-120"/>
+                        </a:rPr>
+                        <a:t>No — secondary record</a:t>
+                      </a:r>
+                      <a:endParaRPr lang="en-US" sz="830" dirty="0">
+                        <a:latin typeface="Calibri" charset="0"/>
+                        <a:ea typeface="Calibri" charset="0"/>
+                        <a:cs typeface="Calibri" charset="0"/>
+                      </a:endParaRPr>
+                    </a:p>
+                  </a:txBody>
+                  <a:tcPr marL="76200" marR="76200" marT="38100" marB="38100" anchor="ctr">
+                    <a:lnL w="9525" cap="flat" cmpd="sng" algn="ctr">
+                      <a:solidFill>
+                        <a:srgbClr val="D7E1F5"/>
+                      </a:solidFill>
+                      <a:prstDash val="solid"/>
+                      <a:round/>
+                      <a:headEnd type="none" w="med" len="med"/>
+                      <a:tailEnd type="none" w="med" len="med"/>
+                    </a:lnL>
+                    <a:lnR w="9525" cap="flat" cmpd="sng" algn="ctr">
+                      <a:solidFill>
+                        <a:srgbClr val="D7E1F5"/>
+                      </a:solidFill>
+                      <a:prstDash val="solid"/>
+                      <a:round/>
+                      <a:headEnd type="none" w="med" len="med"/>
+                      <a:tailEnd type="none" w="med" len="med"/>
+                    </a:lnR>
+                    <a:lnT w="9525" cap="flat" cmpd="sng" algn="ctr">
+                      <a:solidFill>
+                        <a:srgbClr val="D7E1F5"/>
+                      </a:solidFill>
+                      <a:prstDash val="solid"/>
+                      <a:round/>
+                      <a:headEnd type="none" w="med" len="med"/>
+                      <a:tailEnd type="none" w="med" len="med"/>
+                    </a:lnT>
+                    <a:lnB w="9525" cap="flat" cmpd="sng" algn="ctr">
+                      <a:solidFill>
+                        <a:srgbClr val="D7E1F5"/>
+                      </a:solidFill>
+                      <a:prstDash val="solid"/>
+                      <a:round/>
+                      <a:headEnd type="none" w="med" len="med"/>
+                      <a:tailEnd type="none" w="med" len="med"/>
+                    </a:lnB>
+                    <a:solidFill>
+                      <a:srgbClr val="FFFFFF"/>
+                    </a:solidFill>
+                  </a:tcPr>
+                </a:tc>
+              </a:tr>
+              <a:tr h="0">
+                <a:tc>
+                  <a:txBody>
+                    <a:bodyPr/>
+                    <a:lstStyle/>
+                    <a:p>
+                      <a:pPr algn="l" indent="0" marL="0">
+                        <a:buNone/>
+                      </a:pPr>
+                      <a:r>
+                        <a:rPr lang="en-US" sz="830" b="1" dirty="0">
+                          <a:solidFill>
+                            <a:srgbClr val="1E2761"/>
+                          </a:solidFill>
+                          <a:latin typeface="Calibri" pitchFamily="34" charset="0"/>
+                          <a:ea typeface="Calibri" pitchFamily="34" charset="-122"/>
+                          <a:cs typeface="Calibri" pitchFamily="34" charset="-120"/>
+                        </a:rPr>
                         <a:t>Settlement rail</a:t>
                       </a:r>
                       <a:endParaRPr lang="en-US" sz="830" dirty="0">
@@ -21888,7 +22366,7 @@
                       <a:tailEnd type="none" w="med" len="med"/>
                     </a:lnB>
                     <a:solidFill>
-                      <a:srgbClr val="FFFFFF"/>
+                      <a:srgbClr val="F5F8FD"/>
                     </a:solidFill>
                   </a:tcPr>
                 </a:tc>
@@ -21956,7 +22434,7 @@
                       <a:tailEnd type="none" w="med" len="med"/>
                     </a:lnB>
                     <a:solidFill>
-                      <a:srgbClr val="FFFFFF"/>
+                      <a:srgbClr val="F5F8FD"/>
                     </a:solidFill>
                   </a:tcPr>
                 </a:tc>
@@ -22024,7 +22502,7 @@
                       <a:tailEnd type="none" w="med" len="med"/>
                     </a:lnB>
                     <a:solidFill>
-                      <a:srgbClr val="FFFFFF"/>
+                      <a:srgbClr val="F5F8FD"/>
                     </a:solidFill>
                   </a:tcPr>
                 </a:tc>
@@ -22092,7 +22570,7 @@
                       <a:tailEnd type="none" w="med" len="med"/>
                     </a:lnB>
                     <a:solidFill>
-                      <a:srgbClr val="FFFFFF"/>
+                      <a:srgbClr val="F5F8FD"/>
                     </a:solidFill>
                   </a:tcPr>
                 </a:tc>
@@ -22160,7 +22638,7 @@
                       <a:tailEnd type="none" w="med" len="med"/>
                     </a:lnB>
                     <a:solidFill>
-                      <a:srgbClr val="FFFFFF"/>
+                      <a:srgbClr val="F5F8FD"/>
                     </a:solidFill>
                   </a:tcPr>
                 </a:tc>
@@ -22228,7 +22706,7 @@
                       <a:tailEnd type="none" w="med" len="med"/>
                     </a:lnB>
                     <a:solidFill>
-                      <a:srgbClr val="FFFFFF"/>
+                      <a:srgbClr val="F5F8FD"/>
                     </a:solidFill>
                   </a:tcPr>
                 </a:tc>
@@ -22296,7 +22774,7 @@
                       <a:tailEnd type="none" w="med" len="med"/>
                     </a:lnB>
                     <a:solidFill>
-                      <a:srgbClr val="FFFFFF"/>
+                      <a:srgbClr val="F5F8FD"/>
                     </a:solidFill>
                   </a:tcPr>
                 </a:tc>
@@ -22366,7 +22844,7 @@
                       <a:tailEnd type="none" w="med" len="med"/>
                     </a:lnB>
                     <a:solidFill>
-                      <a:srgbClr val="F5F8FD"/>
+                      <a:srgbClr val="FFFFFF"/>
                     </a:solidFill>
                   </a:tcPr>
                 </a:tc>
@@ -22434,7 +22912,7 @@
                       <a:tailEnd type="none" w="med" len="med"/>
                     </a:lnB>
                     <a:solidFill>
-                      <a:srgbClr val="F5F8FD"/>
+                      <a:srgbClr val="FFFFFF"/>
                     </a:solidFill>
                   </a:tcPr>
                 </a:tc>
@@ -22502,7 +22980,7 @@
                       <a:tailEnd type="none" w="med" len="med"/>
                     </a:lnB>
                     <a:solidFill>
-                      <a:srgbClr val="F5F8FD"/>
+                      <a:srgbClr val="FFFFFF"/>
                     </a:solidFill>
                   </a:tcPr>
                 </a:tc>
@@ -22570,7 +23048,7 @@
                       <a:tailEnd type="none" w="med" len="med"/>
                     </a:lnB>
                     <a:solidFill>
-                      <a:srgbClr val="F5F8FD"/>
+                      <a:srgbClr val="FFFFFF"/>
                     </a:solidFill>
                   </a:tcPr>
                 </a:tc>
@@ -22638,7 +23116,7 @@
                       <a:tailEnd type="none" w="med" len="med"/>
                     </a:lnB>
                     <a:solidFill>
-                      <a:srgbClr val="F5F8FD"/>
+                      <a:srgbClr val="FFFFFF"/>
                     </a:solidFill>
                   </a:tcPr>
                 </a:tc>
@@ -22706,7 +23184,7 @@
                       <a:tailEnd type="none" w="med" len="med"/>
                     </a:lnB>
                     <a:solidFill>
-                      <a:srgbClr val="F5F8FD"/>
+                      <a:srgbClr val="FFFFFF"/>
                     </a:solidFill>
                   </a:tcPr>
                 </a:tc>
@@ -22774,7 +23252,7 @@
                       <a:tailEnd type="none" w="med" len="med"/>
                     </a:lnB>
                     <a:solidFill>
-                      <a:srgbClr val="F5F8FD"/>
+                      <a:srgbClr val="FFFFFF"/>
                     </a:solidFill>
                   </a:tcPr>
                 </a:tc>

</xml_diff>

<commit_message>
Correct BUIDL's blockchain-primary-ledger answer
Securitize's own regulatory filings for BUIDL explicitly describe the
blockchain as "the primary ledger to record asset ownership and
transactions" under its TA function (docs/tokenized-funds/02-buidl-blackrock.md
sec. 4) — a materially different claim than BENJI/WTGXX's explicitly
"secondary, non-authoritative" framing. USTB/USCC's filings describe a
hybrid on-chain/off-chain master file but never use "primary ledger"
language, so they're marked Hybrid rather than grouped with BUIDL's Yes.

Co-Authored-By: Claude Sonnet 5 <noreply@anthropic.com>
Claude-Session: https://claude.ai/code/session_01XLt1ze3JWdaihuSAsk6TrZ
</commit_message>
<xml_diff>
--- a/docs/presentations/Tokenized_Funds_Comparative_Analysis.pptx
+++ b/docs/presentations/Tokenized_Funds_Comparative_Analysis.pptx
@@ -21977,7 +21977,7 @@
                           <a:ea typeface="Calibri" pitchFamily="34" charset="-122"/>
                           <a:cs typeface="Calibri" pitchFamily="34" charset="-120"/>
                         </a:rPr>
-                        <a:t>No — TA record controls</a:t>
+                        <a:t>Yes — per TA's own filings</a:t>
                       </a:r>
                       <a:endParaRPr lang="en-US" sz="830" dirty="0">
                         <a:latin typeface="Calibri" charset="0"/>
@@ -22045,7 +22045,7 @@
                           <a:ea typeface="Calibri" pitchFamily="34" charset="-122"/>
                           <a:cs typeface="Calibri" pitchFamily="34" charset="-120"/>
                         </a:rPr>
-                        <a:t>No — TA record controls</a:t>
+                        <a:t>Hybrid — no such claim found</a:t>
                       </a:r>
                       <a:endParaRPr lang="en-US" sz="830" dirty="0">
                         <a:latin typeface="Calibri" charset="0"/>
@@ -22113,7 +22113,7 @@
                           <a:ea typeface="Calibri" pitchFamily="34" charset="-122"/>
                           <a:cs typeface="Calibri" pitchFamily="34" charset="-120"/>
                         </a:rPr>
-                        <a:t>No — TA record controls</a:t>
+                        <a:t>Hybrid — no such claim found</a:t>
                       </a:r>
                       <a:endParaRPr lang="en-US" sz="830" dirty="0">
                         <a:latin typeface="Calibri" charset="0"/>

</xml_diff>

<commit_message>
Add TA-legally-required row tied to legal wrapper and SEC status
New row answers whether a registered transfer agent is legally required
for each fund, based on Exchange Act §17A(c): mutual fund equity
securities of registered '40 Act funds (BENJI, WTGXX) are a "qualifying
security" so a registered TA is mandatory. Private 3(c)(7)/Reg D funds
(BUIDL, USCC, OUSG) don't meet that definition, so their TA registration
is voluntary. USTB is flagged as transitioning since it's mid-conversion
from 3(c)(7) to a registered 2a-7 fund.

Co-Authored-By: Claude Sonnet 5 <noreply@anthropic.com>
Claude-Session: https://claude.ai/code/session_01XLt1ze3JWdaihuSAsk6TrZ
</commit_message>
<xml_diff>
--- a/docs/presentations/Tokenized_Funds_Comparative_Analysis.pptx
+++ b/docs/presentations/Tokenized_Funds_Comparative_Analysis.pptx
@@ -18495,6 +18495,484 @@
                           <a:ea typeface="Calibri" pitchFamily="34" charset="-122"/>
                           <a:cs typeface="Calibri" pitchFamily="34" charset="-120"/>
                         </a:rPr>
+                        <a:t>TA legally required?</a:t>
+                      </a:r>
+                      <a:endParaRPr lang="en-US" sz="830" dirty="0">
+                        <a:latin typeface="Calibri" charset="0"/>
+                        <a:ea typeface="Calibri" charset="0"/>
+                        <a:cs typeface="Calibri" charset="0"/>
+                      </a:endParaRPr>
+                    </a:p>
+                  </a:txBody>
+                  <a:tcPr marL="76200" marR="76200" marT="38100" marB="38100" anchor="ctr">
+                    <a:lnL w="9525" cap="flat" cmpd="sng" algn="ctr">
+                      <a:solidFill>
+                        <a:srgbClr val="D7E1F5"/>
+                      </a:solidFill>
+                      <a:prstDash val="solid"/>
+                      <a:round/>
+                      <a:headEnd type="none" w="med" len="med"/>
+                      <a:tailEnd type="none" w="med" len="med"/>
+                    </a:lnL>
+                    <a:lnR w="9525" cap="flat" cmpd="sng" algn="ctr">
+                      <a:solidFill>
+                        <a:srgbClr val="D7E1F5"/>
+                      </a:solidFill>
+                      <a:prstDash val="solid"/>
+                      <a:round/>
+                      <a:headEnd type="none" w="med" len="med"/>
+                      <a:tailEnd type="none" w="med" len="med"/>
+                    </a:lnR>
+                    <a:lnT w="9525" cap="flat" cmpd="sng" algn="ctr">
+                      <a:solidFill>
+                        <a:srgbClr val="D7E1F5"/>
+                      </a:solidFill>
+                      <a:prstDash val="solid"/>
+                      <a:round/>
+                      <a:headEnd type="none" w="med" len="med"/>
+                      <a:tailEnd type="none" w="med" len="med"/>
+                    </a:lnT>
+                    <a:lnB w="9525" cap="flat" cmpd="sng" algn="ctr">
+                      <a:solidFill>
+                        <a:srgbClr val="D7E1F5"/>
+                      </a:solidFill>
+                      <a:prstDash val="solid"/>
+                      <a:round/>
+                      <a:headEnd type="none" w="med" len="med"/>
+                      <a:tailEnd type="none" w="med" len="med"/>
+                    </a:lnB>
+                    <a:solidFill>
+                      <a:srgbClr val="F5F8FD"/>
+                    </a:solidFill>
+                  </a:tcPr>
+                </a:tc>
+                <a:tc>
+                  <a:txBody>
+                    <a:bodyPr/>
+                    <a:lstStyle/>
+                    <a:p>
+                      <a:pPr algn="ctr" indent="0" marL="0">
+                        <a:buNone/>
+                      </a:pPr>
+                      <a:r>
+                        <a:rPr lang="en-US" sz="830" dirty="0">
+                          <a:solidFill>
+                            <a:srgbClr val="3A4566"/>
+                          </a:solidFill>
+                          <a:latin typeface="Calibri" pitchFamily="34" charset="0"/>
+                          <a:ea typeface="Calibri" pitchFamily="34" charset="-122"/>
+                          <a:cs typeface="Calibri" pitchFamily="34" charset="-120"/>
+                        </a:rPr>
+                        <a:t>Yes — qualifying security</a:t>
+                      </a:r>
+                      <a:endParaRPr lang="en-US" sz="830" dirty="0">
+                        <a:latin typeface="Calibri" charset="0"/>
+                        <a:ea typeface="Calibri" charset="0"/>
+                        <a:cs typeface="Calibri" charset="0"/>
+                      </a:endParaRPr>
+                    </a:p>
+                  </a:txBody>
+                  <a:tcPr marL="76200" marR="76200" marT="38100" marB="38100" anchor="ctr">
+                    <a:lnL w="9525" cap="flat" cmpd="sng" algn="ctr">
+                      <a:solidFill>
+                        <a:srgbClr val="D7E1F5"/>
+                      </a:solidFill>
+                      <a:prstDash val="solid"/>
+                      <a:round/>
+                      <a:headEnd type="none" w="med" len="med"/>
+                      <a:tailEnd type="none" w="med" len="med"/>
+                    </a:lnL>
+                    <a:lnR w="9525" cap="flat" cmpd="sng" algn="ctr">
+                      <a:solidFill>
+                        <a:srgbClr val="D7E1F5"/>
+                      </a:solidFill>
+                      <a:prstDash val="solid"/>
+                      <a:round/>
+                      <a:headEnd type="none" w="med" len="med"/>
+                      <a:tailEnd type="none" w="med" len="med"/>
+                    </a:lnR>
+                    <a:lnT w="9525" cap="flat" cmpd="sng" algn="ctr">
+                      <a:solidFill>
+                        <a:srgbClr val="D7E1F5"/>
+                      </a:solidFill>
+                      <a:prstDash val="solid"/>
+                      <a:round/>
+                      <a:headEnd type="none" w="med" len="med"/>
+                      <a:tailEnd type="none" w="med" len="med"/>
+                    </a:lnT>
+                    <a:lnB w="9525" cap="flat" cmpd="sng" algn="ctr">
+                      <a:solidFill>
+                        <a:srgbClr val="D7E1F5"/>
+                      </a:solidFill>
+                      <a:prstDash val="solid"/>
+                      <a:round/>
+                      <a:headEnd type="none" w="med" len="med"/>
+                      <a:tailEnd type="none" w="med" len="med"/>
+                    </a:lnB>
+                    <a:solidFill>
+                      <a:srgbClr val="F5F8FD"/>
+                    </a:solidFill>
+                  </a:tcPr>
+                </a:tc>
+                <a:tc>
+                  <a:txBody>
+                    <a:bodyPr/>
+                    <a:lstStyle/>
+                    <a:p>
+                      <a:pPr algn="ctr" indent="0" marL="0">
+                        <a:buNone/>
+                      </a:pPr>
+                      <a:r>
+                        <a:rPr lang="en-US" sz="830" dirty="0">
+                          <a:solidFill>
+                            <a:srgbClr val="3A4566"/>
+                          </a:solidFill>
+                          <a:latin typeface="Calibri" pitchFamily="34" charset="0"/>
+                          <a:ea typeface="Calibri" pitchFamily="34" charset="-122"/>
+                          <a:cs typeface="Calibri" pitchFamily="34" charset="-120"/>
+                        </a:rPr>
+                        <a:t>No — voluntary (3(c)(7))</a:t>
+                      </a:r>
+                      <a:endParaRPr lang="en-US" sz="830" dirty="0">
+                        <a:latin typeface="Calibri" charset="0"/>
+                        <a:ea typeface="Calibri" charset="0"/>
+                        <a:cs typeface="Calibri" charset="0"/>
+                      </a:endParaRPr>
+                    </a:p>
+                  </a:txBody>
+                  <a:tcPr marL="76200" marR="76200" marT="38100" marB="38100" anchor="ctr">
+                    <a:lnL w="9525" cap="flat" cmpd="sng" algn="ctr">
+                      <a:solidFill>
+                        <a:srgbClr val="D7E1F5"/>
+                      </a:solidFill>
+                      <a:prstDash val="solid"/>
+                      <a:round/>
+                      <a:headEnd type="none" w="med" len="med"/>
+                      <a:tailEnd type="none" w="med" len="med"/>
+                    </a:lnL>
+                    <a:lnR w="9525" cap="flat" cmpd="sng" algn="ctr">
+                      <a:solidFill>
+                        <a:srgbClr val="D7E1F5"/>
+                      </a:solidFill>
+                      <a:prstDash val="solid"/>
+                      <a:round/>
+                      <a:headEnd type="none" w="med" len="med"/>
+                      <a:tailEnd type="none" w="med" len="med"/>
+                    </a:lnR>
+                    <a:lnT w="9525" cap="flat" cmpd="sng" algn="ctr">
+                      <a:solidFill>
+                        <a:srgbClr val="D7E1F5"/>
+                      </a:solidFill>
+                      <a:prstDash val="solid"/>
+                      <a:round/>
+                      <a:headEnd type="none" w="med" len="med"/>
+                      <a:tailEnd type="none" w="med" len="med"/>
+                    </a:lnT>
+                    <a:lnB w="9525" cap="flat" cmpd="sng" algn="ctr">
+                      <a:solidFill>
+                        <a:srgbClr val="D7E1F5"/>
+                      </a:solidFill>
+                      <a:prstDash val="solid"/>
+                      <a:round/>
+                      <a:headEnd type="none" w="med" len="med"/>
+                      <a:tailEnd type="none" w="med" len="med"/>
+                    </a:lnB>
+                    <a:solidFill>
+                      <a:srgbClr val="F5F8FD"/>
+                    </a:solidFill>
+                  </a:tcPr>
+                </a:tc>
+                <a:tc>
+                  <a:txBody>
+                    <a:bodyPr/>
+                    <a:lstStyle/>
+                    <a:p>
+                      <a:pPr algn="ctr" indent="0" marL="0">
+                        <a:buNone/>
+                      </a:pPr>
+                      <a:r>
+                        <a:rPr lang="en-US" sz="830" dirty="0">
+                          <a:solidFill>
+                            <a:srgbClr val="3A4566"/>
+                          </a:solidFill>
+                          <a:latin typeface="Calibri" pitchFamily="34" charset="0"/>
+                          <a:ea typeface="Calibri" pitchFamily="34" charset="-122"/>
+                          <a:cs typeface="Calibri" pitchFamily="34" charset="-120"/>
+                        </a:rPr>
+                        <a:t>No now → Yes (converting)</a:t>
+                      </a:r>
+                      <a:endParaRPr lang="en-US" sz="830" dirty="0">
+                        <a:latin typeface="Calibri" charset="0"/>
+                        <a:ea typeface="Calibri" charset="0"/>
+                        <a:cs typeface="Calibri" charset="0"/>
+                      </a:endParaRPr>
+                    </a:p>
+                  </a:txBody>
+                  <a:tcPr marL="76200" marR="76200" marT="38100" marB="38100" anchor="ctr">
+                    <a:lnL w="9525" cap="flat" cmpd="sng" algn="ctr">
+                      <a:solidFill>
+                        <a:srgbClr val="D7E1F5"/>
+                      </a:solidFill>
+                      <a:prstDash val="solid"/>
+                      <a:round/>
+                      <a:headEnd type="none" w="med" len="med"/>
+                      <a:tailEnd type="none" w="med" len="med"/>
+                    </a:lnL>
+                    <a:lnR w="9525" cap="flat" cmpd="sng" algn="ctr">
+                      <a:solidFill>
+                        <a:srgbClr val="D7E1F5"/>
+                      </a:solidFill>
+                      <a:prstDash val="solid"/>
+                      <a:round/>
+                      <a:headEnd type="none" w="med" len="med"/>
+                      <a:tailEnd type="none" w="med" len="med"/>
+                    </a:lnR>
+                    <a:lnT w="9525" cap="flat" cmpd="sng" algn="ctr">
+                      <a:solidFill>
+                        <a:srgbClr val="D7E1F5"/>
+                      </a:solidFill>
+                      <a:prstDash val="solid"/>
+                      <a:round/>
+                      <a:headEnd type="none" w="med" len="med"/>
+                      <a:tailEnd type="none" w="med" len="med"/>
+                    </a:lnT>
+                    <a:lnB w="9525" cap="flat" cmpd="sng" algn="ctr">
+                      <a:solidFill>
+                        <a:srgbClr val="D7E1F5"/>
+                      </a:solidFill>
+                      <a:prstDash val="solid"/>
+                      <a:round/>
+                      <a:headEnd type="none" w="med" len="med"/>
+                      <a:tailEnd type="none" w="med" len="med"/>
+                    </a:lnB>
+                    <a:solidFill>
+                      <a:srgbClr val="F5F8FD"/>
+                    </a:solidFill>
+                  </a:tcPr>
+                </a:tc>
+                <a:tc>
+                  <a:txBody>
+                    <a:bodyPr/>
+                    <a:lstStyle/>
+                    <a:p>
+                      <a:pPr algn="ctr" indent="0" marL="0">
+                        <a:buNone/>
+                      </a:pPr>
+                      <a:r>
+                        <a:rPr lang="en-US" sz="830" dirty="0">
+                          <a:solidFill>
+                            <a:srgbClr val="3A4566"/>
+                          </a:solidFill>
+                          <a:latin typeface="Calibri" pitchFamily="34" charset="0"/>
+                          <a:ea typeface="Calibri" pitchFamily="34" charset="-122"/>
+                          <a:cs typeface="Calibri" pitchFamily="34" charset="-120"/>
+                        </a:rPr>
+                        <a:t>No — voluntary (3(c)(7))</a:t>
+                      </a:r>
+                      <a:endParaRPr lang="en-US" sz="830" dirty="0">
+                        <a:latin typeface="Calibri" charset="0"/>
+                        <a:ea typeface="Calibri" charset="0"/>
+                        <a:cs typeface="Calibri" charset="0"/>
+                      </a:endParaRPr>
+                    </a:p>
+                  </a:txBody>
+                  <a:tcPr marL="76200" marR="76200" marT="38100" marB="38100" anchor="ctr">
+                    <a:lnL w="9525" cap="flat" cmpd="sng" algn="ctr">
+                      <a:solidFill>
+                        <a:srgbClr val="D7E1F5"/>
+                      </a:solidFill>
+                      <a:prstDash val="solid"/>
+                      <a:round/>
+                      <a:headEnd type="none" w="med" len="med"/>
+                      <a:tailEnd type="none" w="med" len="med"/>
+                    </a:lnL>
+                    <a:lnR w="9525" cap="flat" cmpd="sng" algn="ctr">
+                      <a:solidFill>
+                        <a:srgbClr val="D7E1F5"/>
+                      </a:solidFill>
+                      <a:prstDash val="solid"/>
+                      <a:round/>
+                      <a:headEnd type="none" w="med" len="med"/>
+                      <a:tailEnd type="none" w="med" len="med"/>
+                    </a:lnR>
+                    <a:lnT w="9525" cap="flat" cmpd="sng" algn="ctr">
+                      <a:solidFill>
+                        <a:srgbClr val="D7E1F5"/>
+                      </a:solidFill>
+                      <a:prstDash val="solid"/>
+                      <a:round/>
+                      <a:headEnd type="none" w="med" len="med"/>
+                      <a:tailEnd type="none" w="med" len="med"/>
+                    </a:lnT>
+                    <a:lnB w="9525" cap="flat" cmpd="sng" algn="ctr">
+                      <a:solidFill>
+                        <a:srgbClr val="D7E1F5"/>
+                      </a:solidFill>
+                      <a:prstDash val="solid"/>
+                      <a:round/>
+                      <a:headEnd type="none" w="med" len="med"/>
+                      <a:tailEnd type="none" w="med" len="med"/>
+                    </a:lnB>
+                    <a:solidFill>
+                      <a:srgbClr val="F5F8FD"/>
+                    </a:solidFill>
+                  </a:tcPr>
+                </a:tc>
+                <a:tc>
+                  <a:txBody>
+                    <a:bodyPr/>
+                    <a:lstStyle/>
+                    <a:p>
+                      <a:pPr algn="ctr" indent="0" marL="0">
+                        <a:buNone/>
+                      </a:pPr>
+                      <a:r>
+                        <a:rPr lang="en-US" sz="830" dirty="0">
+                          <a:solidFill>
+                            <a:srgbClr val="3A4566"/>
+                          </a:solidFill>
+                          <a:latin typeface="Calibri" pitchFamily="34" charset="0"/>
+                          <a:ea typeface="Calibri" pitchFamily="34" charset="-122"/>
+                          <a:cs typeface="Calibri" pitchFamily="34" charset="-120"/>
+                        </a:rPr>
+                        <a:t>No — voluntary (3(c)(7))</a:t>
+                      </a:r>
+                      <a:endParaRPr lang="en-US" sz="830" dirty="0">
+                        <a:latin typeface="Calibri" charset="0"/>
+                        <a:ea typeface="Calibri" charset="0"/>
+                        <a:cs typeface="Calibri" charset="0"/>
+                      </a:endParaRPr>
+                    </a:p>
+                  </a:txBody>
+                  <a:tcPr marL="76200" marR="76200" marT="38100" marB="38100" anchor="ctr">
+                    <a:lnL w="9525" cap="flat" cmpd="sng" algn="ctr">
+                      <a:solidFill>
+                        <a:srgbClr val="D7E1F5"/>
+                      </a:solidFill>
+                      <a:prstDash val="solid"/>
+                      <a:round/>
+                      <a:headEnd type="none" w="med" len="med"/>
+                      <a:tailEnd type="none" w="med" len="med"/>
+                    </a:lnL>
+                    <a:lnR w="9525" cap="flat" cmpd="sng" algn="ctr">
+                      <a:solidFill>
+                        <a:srgbClr val="D7E1F5"/>
+                      </a:solidFill>
+                      <a:prstDash val="solid"/>
+                      <a:round/>
+                      <a:headEnd type="none" w="med" len="med"/>
+                      <a:tailEnd type="none" w="med" len="med"/>
+                    </a:lnR>
+                    <a:lnT w="9525" cap="flat" cmpd="sng" algn="ctr">
+                      <a:solidFill>
+                        <a:srgbClr val="D7E1F5"/>
+                      </a:solidFill>
+                      <a:prstDash val="solid"/>
+                      <a:round/>
+                      <a:headEnd type="none" w="med" len="med"/>
+                      <a:tailEnd type="none" w="med" len="med"/>
+                    </a:lnT>
+                    <a:lnB w="9525" cap="flat" cmpd="sng" algn="ctr">
+                      <a:solidFill>
+                        <a:srgbClr val="D7E1F5"/>
+                      </a:solidFill>
+                      <a:prstDash val="solid"/>
+                      <a:round/>
+                      <a:headEnd type="none" w="med" len="med"/>
+                      <a:tailEnd type="none" w="med" len="med"/>
+                    </a:lnB>
+                    <a:solidFill>
+                      <a:srgbClr val="F5F8FD"/>
+                    </a:solidFill>
+                  </a:tcPr>
+                </a:tc>
+                <a:tc>
+                  <a:txBody>
+                    <a:bodyPr/>
+                    <a:lstStyle/>
+                    <a:p>
+                      <a:pPr algn="ctr" indent="0" marL="0">
+                        <a:buNone/>
+                      </a:pPr>
+                      <a:r>
+                        <a:rPr lang="en-US" sz="830" dirty="0">
+                          <a:solidFill>
+                            <a:srgbClr val="3A4566"/>
+                          </a:solidFill>
+                          <a:latin typeface="Calibri" pitchFamily="34" charset="0"/>
+                          <a:ea typeface="Calibri" pitchFamily="34" charset="-122"/>
+                          <a:cs typeface="Calibri" pitchFamily="34" charset="-120"/>
+                        </a:rPr>
+                        <a:t>Yes — qualifying security</a:t>
+                      </a:r>
+                      <a:endParaRPr lang="en-US" sz="830" dirty="0">
+                        <a:latin typeface="Calibri" charset="0"/>
+                        <a:ea typeface="Calibri" charset="0"/>
+                        <a:cs typeface="Calibri" charset="0"/>
+                      </a:endParaRPr>
+                    </a:p>
+                  </a:txBody>
+                  <a:tcPr marL="76200" marR="76200" marT="38100" marB="38100" anchor="ctr">
+                    <a:lnL w="9525" cap="flat" cmpd="sng" algn="ctr">
+                      <a:solidFill>
+                        <a:srgbClr val="D7E1F5"/>
+                      </a:solidFill>
+                      <a:prstDash val="solid"/>
+                      <a:round/>
+                      <a:headEnd type="none" w="med" len="med"/>
+                      <a:tailEnd type="none" w="med" len="med"/>
+                    </a:lnL>
+                    <a:lnR w="9525" cap="flat" cmpd="sng" algn="ctr">
+                      <a:solidFill>
+                        <a:srgbClr val="D7E1F5"/>
+                      </a:solidFill>
+                      <a:prstDash val="solid"/>
+                      <a:round/>
+                      <a:headEnd type="none" w="med" len="med"/>
+                      <a:tailEnd type="none" w="med" len="med"/>
+                    </a:lnR>
+                    <a:lnT w="9525" cap="flat" cmpd="sng" algn="ctr">
+                      <a:solidFill>
+                        <a:srgbClr val="D7E1F5"/>
+                      </a:solidFill>
+                      <a:prstDash val="solid"/>
+                      <a:round/>
+                      <a:headEnd type="none" w="med" len="med"/>
+                      <a:tailEnd type="none" w="med" len="med"/>
+                    </a:lnT>
+                    <a:lnB w="9525" cap="flat" cmpd="sng" algn="ctr">
+                      <a:solidFill>
+                        <a:srgbClr val="D7E1F5"/>
+                      </a:solidFill>
+                      <a:prstDash val="solid"/>
+                      <a:round/>
+                      <a:headEnd type="none" w="med" len="med"/>
+                      <a:tailEnd type="none" w="med" len="med"/>
+                    </a:lnB>
+                    <a:solidFill>
+                      <a:srgbClr val="F5F8FD"/>
+                    </a:solidFill>
+                  </a:tcPr>
+                </a:tc>
+              </a:tr>
+              <a:tr h="0">
+                <a:tc>
+                  <a:txBody>
+                    <a:bodyPr/>
+                    <a:lstStyle/>
+                    <a:p>
+                      <a:pPr algn="l" indent="0" marL="0">
+                        <a:buNone/>
+                      </a:pPr>
+                      <a:r>
+                        <a:rPr lang="en-US" sz="830" b="1" dirty="0">
+                          <a:solidFill>
+                            <a:srgbClr val="1E2761"/>
+                          </a:solidFill>
+                          <a:latin typeface="Calibri" pitchFamily="34" charset="0"/>
+                          <a:ea typeface="Calibri" pitchFamily="34" charset="-122"/>
+                          <a:cs typeface="Calibri" pitchFamily="34" charset="-120"/>
+                        </a:rPr>
                         <a:t>Eligible investors</a:t>
                       </a:r>
                       <a:endParaRPr lang="en-US" sz="830" dirty="0">
@@ -18542,7 +19020,7 @@
                       <a:tailEnd type="none" w="med" len="med"/>
                     </a:lnB>
                     <a:solidFill>
-                      <a:srgbClr val="F5F8FD"/>
+                      <a:srgbClr val="FFFFFF"/>
                     </a:solidFill>
                   </a:tcPr>
                 </a:tc>
@@ -18610,7 +19088,7 @@
                       <a:tailEnd type="none" w="med" len="med"/>
                     </a:lnB>
                     <a:solidFill>
-                      <a:srgbClr val="F5F8FD"/>
+                      <a:srgbClr val="FFFFFF"/>
                     </a:solidFill>
                   </a:tcPr>
                 </a:tc>
@@ -18678,7 +19156,7 @@
                       <a:tailEnd type="none" w="med" len="med"/>
                     </a:lnB>
                     <a:solidFill>
-                      <a:srgbClr val="F5F8FD"/>
+                      <a:srgbClr val="FFFFFF"/>
                     </a:solidFill>
                   </a:tcPr>
                 </a:tc>
@@ -18746,7 +19224,7 @@
                       <a:tailEnd type="none" w="med" len="med"/>
                     </a:lnB>
                     <a:solidFill>
-                      <a:srgbClr val="F5F8FD"/>
+                      <a:srgbClr val="FFFFFF"/>
                     </a:solidFill>
                   </a:tcPr>
                 </a:tc>
@@ -18814,7 +19292,7 @@
                       <a:tailEnd type="none" w="med" len="med"/>
                     </a:lnB>
                     <a:solidFill>
-                      <a:srgbClr val="F5F8FD"/>
+                      <a:srgbClr val="FFFFFF"/>
                     </a:solidFill>
                   </a:tcPr>
                 </a:tc>
@@ -18882,7 +19360,7 @@
                       <a:tailEnd type="none" w="med" len="med"/>
                     </a:lnB>
                     <a:solidFill>
-                      <a:srgbClr val="F5F8FD"/>
+                      <a:srgbClr val="FFFFFF"/>
                     </a:solidFill>
                   </a:tcPr>
                 </a:tc>
@@ -18950,7 +19428,7 @@
                       <a:tailEnd type="none" w="med" len="med"/>
                     </a:lnB>
                     <a:solidFill>
-                      <a:srgbClr val="F5F8FD"/>
+                      <a:srgbClr val="FFFFFF"/>
                     </a:solidFill>
                   </a:tcPr>
                 </a:tc>
@@ -19020,7 +19498,7 @@
                       <a:tailEnd type="none" w="med" len="med"/>
                     </a:lnB>
                     <a:solidFill>
-                      <a:srgbClr val="FFFFFF"/>
+                      <a:srgbClr val="F5F8FD"/>
                     </a:solidFill>
                   </a:tcPr>
                 </a:tc>
@@ -19088,7 +19566,7 @@
                       <a:tailEnd type="none" w="med" len="med"/>
                     </a:lnB>
                     <a:solidFill>
-                      <a:srgbClr val="FFFFFF"/>
+                      <a:srgbClr val="F5F8FD"/>
                     </a:solidFill>
                   </a:tcPr>
                 </a:tc>
@@ -19156,7 +19634,7 @@
                       <a:tailEnd type="none" w="med" len="med"/>
                     </a:lnB>
                     <a:solidFill>
-                      <a:srgbClr val="FFFFFF"/>
+                      <a:srgbClr val="F5F8FD"/>
                     </a:solidFill>
                   </a:tcPr>
                 </a:tc>
@@ -19224,7 +19702,7 @@
                       <a:tailEnd type="none" w="med" len="med"/>
                     </a:lnB>
                     <a:solidFill>
-                      <a:srgbClr val="FFFFFF"/>
+                      <a:srgbClr val="F5F8FD"/>
                     </a:solidFill>
                   </a:tcPr>
                 </a:tc>
@@ -19292,7 +19770,7 @@
                       <a:tailEnd type="none" w="med" len="med"/>
                     </a:lnB>
                     <a:solidFill>
-                      <a:srgbClr val="FFFFFF"/>
+                      <a:srgbClr val="F5F8FD"/>
                     </a:solidFill>
                   </a:tcPr>
                 </a:tc>
@@ -19360,7 +19838,7 @@
                       <a:tailEnd type="none" w="med" len="med"/>
                     </a:lnB>
                     <a:solidFill>
-                      <a:srgbClr val="FFFFFF"/>
+                      <a:srgbClr val="F5F8FD"/>
                     </a:solidFill>
                   </a:tcPr>
                 </a:tc>
@@ -19428,7 +19906,7 @@
                       <a:tailEnd type="none" w="med" len="med"/>
                     </a:lnB>
                     <a:solidFill>
-                      <a:srgbClr val="FFFFFF"/>
+                      <a:srgbClr val="F5F8FD"/>
                     </a:solidFill>
                   </a:tcPr>
                 </a:tc>
@@ -19498,7 +19976,7 @@
                       <a:tailEnd type="none" w="med" len="med"/>
                     </a:lnB>
                     <a:solidFill>
-                      <a:srgbClr val="F5F8FD"/>
+                      <a:srgbClr val="FFFFFF"/>
                     </a:solidFill>
                   </a:tcPr>
                 </a:tc>
@@ -19566,7 +20044,7 @@
                       <a:tailEnd type="none" w="med" len="med"/>
                     </a:lnB>
                     <a:solidFill>
-                      <a:srgbClr val="F5F8FD"/>
+                      <a:srgbClr val="FFFFFF"/>
                     </a:solidFill>
                   </a:tcPr>
                 </a:tc>
@@ -19634,7 +20112,7 @@
                       <a:tailEnd type="none" w="med" len="med"/>
                     </a:lnB>
                     <a:solidFill>
-                      <a:srgbClr val="F5F8FD"/>
+                      <a:srgbClr val="FFFFFF"/>
                     </a:solidFill>
                   </a:tcPr>
                 </a:tc>
@@ -19702,7 +20180,7 @@
                       <a:tailEnd type="none" w="med" len="med"/>
                     </a:lnB>
                     <a:solidFill>
-                      <a:srgbClr val="F5F8FD"/>
+                      <a:srgbClr val="FFFFFF"/>
                     </a:solidFill>
                   </a:tcPr>
                 </a:tc>
@@ -19770,7 +20248,7 @@
                       <a:tailEnd type="none" w="med" len="med"/>
                     </a:lnB>
                     <a:solidFill>
-                      <a:srgbClr val="F5F8FD"/>
+                      <a:srgbClr val="FFFFFF"/>
                     </a:solidFill>
                   </a:tcPr>
                 </a:tc>
@@ -19838,7 +20316,7 @@
                       <a:tailEnd type="none" w="med" len="med"/>
                     </a:lnB>
                     <a:solidFill>
-                      <a:srgbClr val="F5F8FD"/>
+                      <a:srgbClr val="FFFFFF"/>
                     </a:solidFill>
                   </a:tcPr>
                 </a:tc>
@@ -19906,7 +20384,7 @@
                       <a:tailEnd type="none" w="med" len="med"/>
                     </a:lnB>
                     <a:solidFill>
-                      <a:srgbClr val="F5F8FD"/>
+                      <a:srgbClr val="FFFFFF"/>
                     </a:solidFill>
                   </a:tcPr>
                 </a:tc>
@@ -19976,6 +20454,484 @@
                       <a:tailEnd type="none" w="med" len="med"/>
                     </a:lnB>
                     <a:solidFill>
+                      <a:srgbClr val="F5F8FD"/>
+                    </a:solidFill>
+                  </a:tcPr>
+                </a:tc>
+                <a:tc>
+                  <a:txBody>
+                    <a:bodyPr/>
+                    <a:lstStyle/>
+                    <a:p>
+                      <a:pPr algn="ctr" indent="0" marL="0">
+                        <a:buNone/>
+                      </a:pPr>
+                      <a:r>
+                        <a:rPr lang="en-US" sz="830" dirty="0">
+                          <a:solidFill>
+                            <a:srgbClr val="3A4566"/>
+                          </a:solidFill>
+                          <a:latin typeface="Calibri" pitchFamily="34" charset="0"/>
+                          <a:ea typeface="Calibri" pitchFamily="34" charset="-122"/>
+                          <a:cs typeface="Calibri" pitchFamily="34" charset="-120"/>
+                        </a:rPr>
+                        <a:t>FT Services/JPMorgan</a:t>
+                      </a:r>
+                      <a:endParaRPr lang="en-US" sz="830" dirty="0">
+                        <a:latin typeface="Calibri" charset="0"/>
+                        <a:ea typeface="Calibri" charset="0"/>
+                        <a:cs typeface="Calibri" charset="0"/>
+                      </a:endParaRPr>
+                    </a:p>
+                  </a:txBody>
+                  <a:tcPr marL="76200" marR="76200" marT="38100" marB="38100" anchor="ctr">
+                    <a:lnL w="9525" cap="flat" cmpd="sng" algn="ctr">
+                      <a:solidFill>
+                        <a:srgbClr val="D7E1F5"/>
+                      </a:solidFill>
+                      <a:prstDash val="solid"/>
+                      <a:round/>
+                      <a:headEnd type="none" w="med" len="med"/>
+                      <a:tailEnd type="none" w="med" len="med"/>
+                    </a:lnL>
+                    <a:lnR w="9525" cap="flat" cmpd="sng" algn="ctr">
+                      <a:solidFill>
+                        <a:srgbClr val="D7E1F5"/>
+                      </a:solidFill>
+                      <a:prstDash val="solid"/>
+                      <a:round/>
+                      <a:headEnd type="none" w="med" len="med"/>
+                      <a:tailEnd type="none" w="med" len="med"/>
+                    </a:lnR>
+                    <a:lnT w="9525" cap="flat" cmpd="sng" algn="ctr">
+                      <a:solidFill>
+                        <a:srgbClr val="D7E1F5"/>
+                      </a:solidFill>
+                      <a:prstDash val="solid"/>
+                      <a:round/>
+                      <a:headEnd type="none" w="med" len="med"/>
+                      <a:tailEnd type="none" w="med" len="med"/>
+                    </a:lnT>
+                    <a:lnB w="9525" cap="flat" cmpd="sng" algn="ctr">
+                      <a:solidFill>
+                        <a:srgbClr val="D7E1F5"/>
+                      </a:solidFill>
+                      <a:prstDash val="solid"/>
+                      <a:round/>
+                      <a:headEnd type="none" w="med" len="med"/>
+                      <a:tailEnd type="none" w="med" len="med"/>
+                    </a:lnB>
+                    <a:solidFill>
+                      <a:srgbClr val="F5F8FD"/>
+                    </a:solidFill>
+                  </a:tcPr>
+                </a:tc>
+                <a:tc>
+                  <a:txBody>
+                    <a:bodyPr/>
+                    <a:lstStyle/>
+                    <a:p>
+                      <a:pPr algn="ctr" indent="0" marL="0">
+                        <a:buNone/>
+                      </a:pPr>
+                      <a:r>
+                        <a:rPr lang="en-US" sz="830" dirty="0">
+                          <a:solidFill>
+                            <a:srgbClr val="3A4566"/>
+                          </a:solidFill>
+                          <a:latin typeface="Calibri" pitchFamily="34" charset="0"/>
+                          <a:ea typeface="Calibri" pitchFamily="34" charset="-122"/>
+                          <a:cs typeface="Calibri" pitchFamily="34" charset="-120"/>
+                        </a:rPr>
+                        <a:t>BNY Mellon</a:t>
+                      </a:r>
+                      <a:endParaRPr lang="en-US" sz="830" dirty="0">
+                        <a:latin typeface="Calibri" charset="0"/>
+                        <a:ea typeface="Calibri" charset="0"/>
+                        <a:cs typeface="Calibri" charset="0"/>
+                      </a:endParaRPr>
+                    </a:p>
+                  </a:txBody>
+                  <a:tcPr marL="76200" marR="76200" marT="38100" marB="38100" anchor="ctr">
+                    <a:lnL w="9525" cap="flat" cmpd="sng" algn="ctr">
+                      <a:solidFill>
+                        <a:srgbClr val="D7E1F5"/>
+                      </a:solidFill>
+                      <a:prstDash val="solid"/>
+                      <a:round/>
+                      <a:headEnd type="none" w="med" len="med"/>
+                      <a:tailEnd type="none" w="med" len="med"/>
+                    </a:lnL>
+                    <a:lnR w="9525" cap="flat" cmpd="sng" algn="ctr">
+                      <a:solidFill>
+                        <a:srgbClr val="D7E1F5"/>
+                      </a:solidFill>
+                      <a:prstDash val="solid"/>
+                      <a:round/>
+                      <a:headEnd type="none" w="med" len="med"/>
+                      <a:tailEnd type="none" w="med" len="med"/>
+                    </a:lnR>
+                    <a:lnT w="9525" cap="flat" cmpd="sng" algn="ctr">
+                      <a:solidFill>
+                        <a:srgbClr val="D7E1F5"/>
+                      </a:solidFill>
+                      <a:prstDash val="solid"/>
+                      <a:round/>
+                      <a:headEnd type="none" w="med" len="med"/>
+                      <a:tailEnd type="none" w="med" len="med"/>
+                    </a:lnT>
+                    <a:lnB w="9525" cap="flat" cmpd="sng" algn="ctr">
+                      <a:solidFill>
+                        <a:srgbClr val="D7E1F5"/>
+                      </a:solidFill>
+                      <a:prstDash val="solid"/>
+                      <a:round/>
+                      <a:headEnd type="none" w="med" len="med"/>
+                      <a:tailEnd type="none" w="med" len="med"/>
+                    </a:lnB>
+                    <a:solidFill>
+                      <a:srgbClr val="F5F8FD"/>
+                    </a:solidFill>
+                  </a:tcPr>
+                </a:tc>
+                <a:tc>
+                  <a:txBody>
+                    <a:bodyPr/>
+                    <a:lstStyle/>
+                    <a:p>
+                      <a:pPr algn="ctr" indent="0" marL="0">
+                        <a:buNone/>
+                      </a:pPr>
+                      <a:r>
+                        <a:rPr lang="en-US" sz="830" dirty="0">
+                          <a:solidFill>
+                            <a:srgbClr val="3A4566"/>
+                          </a:solidFill>
+                          <a:latin typeface="Calibri" pitchFamily="34" charset="0"/>
+                          <a:ea typeface="Calibri" pitchFamily="34" charset="-122"/>
+                          <a:cs typeface="Calibri" pitchFamily="34" charset="-120"/>
+                        </a:rPr>
+                        <a:t>Not confirmed</a:t>
+                      </a:r>
+                      <a:endParaRPr lang="en-US" sz="830" dirty="0">
+                        <a:latin typeface="Calibri" charset="0"/>
+                        <a:ea typeface="Calibri" charset="0"/>
+                        <a:cs typeface="Calibri" charset="0"/>
+                      </a:endParaRPr>
+                    </a:p>
+                  </a:txBody>
+                  <a:tcPr marL="76200" marR="76200" marT="38100" marB="38100" anchor="ctr">
+                    <a:lnL w="9525" cap="flat" cmpd="sng" algn="ctr">
+                      <a:solidFill>
+                        <a:srgbClr val="D7E1F5"/>
+                      </a:solidFill>
+                      <a:prstDash val="solid"/>
+                      <a:round/>
+                      <a:headEnd type="none" w="med" len="med"/>
+                      <a:tailEnd type="none" w="med" len="med"/>
+                    </a:lnL>
+                    <a:lnR w="9525" cap="flat" cmpd="sng" algn="ctr">
+                      <a:solidFill>
+                        <a:srgbClr val="D7E1F5"/>
+                      </a:solidFill>
+                      <a:prstDash val="solid"/>
+                      <a:round/>
+                      <a:headEnd type="none" w="med" len="med"/>
+                      <a:tailEnd type="none" w="med" len="med"/>
+                    </a:lnR>
+                    <a:lnT w="9525" cap="flat" cmpd="sng" algn="ctr">
+                      <a:solidFill>
+                        <a:srgbClr val="D7E1F5"/>
+                      </a:solidFill>
+                      <a:prstDash val="solid"/>
+                      <a:round/>
+                      <a:headEnd type="none" w="med" len="med"/>
+                      <a:tailEnd type="none" w="med" len="med"/>
+                    </a:lnT>
+                    <a:lnB w="9525" cap="flat" cmpd="sng" algn="ctr">
+                      <a:solidFill>
+                        <a:srgbClr val="D7E1F5"/>
+                      </a:solidFill>
+                      <a:prstDash val="solid"/>
+                      <a:round/>
+                      <a:headEnd type="none" w="med" len="med"/>
+                      <a:tailEnd type="none" w="med" len="med"/>
+                    </a:lnB>
+                    <a:solidFill>
+                      <a:srgbClr val="F5F8FD"/>
+                    </a:solidFill>
+                  </a:tcPr>
+                </a:tc>
+                <a:tc>
+                  <a:txBody>
+                    <a:bodyPr/>
+                    <a:lstStyle/>
+                    <a:p>
+                      <a:pPr algn="ctr" indent="0" marL="0">
+                        <a:buNone/>
+                      </a:pPr>
+                      <a:r>
+                        <a:rPr lang="en-US" sz="830" dirty="0">
+                          <a:solidFill>
+                            <a:srgbClr val="3A4566"/>
+                          </a:solidFill>
+                          <a:latin typeface="Calibri" pitchFamily="34" charset="0"/>
+                          <a:ea typeface="Calibri" pitchFamily="34" charset="-122"/>
+                          <a:cs typeface="Calibri" pitchFamily="34" charset="-120"/>
+                        </a:rPr>
+                        <a:t>Not confirmed</a:t>
+                      </a:r>
+                      <a:endParaRPr lang="en-US" sz="830" dirty="0">
+                        <a:latin typeface="Calibri" charset="0"/>
+                        <a:ea typeface="Calibri" charset="0"/>
+                        <a:cs typeface="Calibri" charset="0"/>
+                      </a:endParaRPr>
+                    </a:p>
+                  </a:txBody>
+                  <a:tcPr marL="76200" marR="76200" marT="38100" marB="38100" anchor="ctr">
+                    <a:lnL w="9525" cap="flat" cmpd="sng" algn="ctr">
+                      <a:solidFill>
+                        <a:srgbClr val="D7E1F5"/>
+                      </a:solidFill>
+                      <a:prstDash val="solid"/>
+                      <a:round/>
+                      <a:headEnd type="none" w="med" len="med"/>
+                      <a:tailEnd type="none" w="med" len="med"/>
+                    </a:lnL>
+                    <a:lnR w="9525" cap="flat" cmpd="sng" algn="ctr">
+                      <a:solidFill>
+                        <a:srgbClr val="D7E1F5"/>
+                      </a:solidFill>
+                      <a:prstDash val="solid"/>
+                      <a:round/>
+                      <a:headEnd type="none" w="med" len="med"/>
+                      <a:tailEnd type="none" w="med" len="med"/>
+                    </a:lnR>
+                    <a:lnT w="9525" cap="flat" cmpd="sng" algn="ctr">
+                      <a:solidFill>
+                        <a:srgbClr val="D7E1F5"/>
+                      </a:solidFill>
+                      <a:prstDash val="solid"/>
+                      <a:round/>
+                      <a:headEnd type="none" w="med" len="med"/>
+                      <a:tailEnd type="none" w="med" len="med"/>
+                    </a:lnT>
+                    <a:lnB w="9525" cap="flat" cmpd="sng" algn="ctr">
+                      <a:solidFill>
+                        <a:srgbClr val="D7E1F5"/>
+                      </a:solidFill>
+                      <a:prstDash val="solid"/>
+                      <a:round/>
+                      <a:headEnd type="none" w="med" len="med"/>
+                      <a:tailEnd type="none" w="med" len="med"/>
+                    </a:lnB>
+                    <a:solidFill>
+                      <a:srgbClr val="F5F8FD"/>
+                    </a:solidFill>
+                  </a:tcPr>
+                </a:tc>
+                <a:tc>
+                  <a:txBody>
+                    <a:bodyPr/>
+                    <a:lstStyle/>
+                    <a:p>
+                      <a:pPr algn="ctr" indent="0" marL="0">
+                        <a:buNone/>
+                      </a:pPr>
+                      <a:r>
+                        <a:rPr lang="en-US" sz="830" dirty="0">
+                          <a:solidFill>
+                            <a:srgbClr val="3A4566"/>
+                          </a:solidFill>
+                          <a:latin typeface="Calibri" pitchFamily="34" charset="0"/>
+                          <a:ea typeface="Calibri" pitchFamily="34" charset="-122"/>
+                          <a:cs typeface="Calibri" pitchFamily="34" charset="-120"/>
+                        </a:rPr>
+                        <a:t>NAV Consulting</a:t>
+                      </a:r>
+                      <a:endParaRPr lang="en-US" sz="830" dirty="0">
+                        <a:latin typeface="Calibri" charset="0"/>
+                        <a:ea typeface="Calibri" charset="0"/>
+                        <a:cs typeface="Calibri" charset="0"/>
+                      </a:endParaRPr>
+                    </a:p>
+                  </a:txBody>
+                  <a:tcPr marL="76200" marR="76200" marT="38100" marB="38100" anchor="ctr">
+                    <a:lnL w="9525" cap="flat" cmpd="sng" algn="ctr">
+                      <a:solidFill>
+                        <a:srgbClr val="D7E1F5"/>
+                      </a:solidFill>
+                      <a:prstDash val="solid"/>
+                      <a:round/>
+                      <a:headEnd type="none" w="med" len="med"/>
+                      <a:tailEnd type="none" w="med" len="med"/>
+                    </a:lnL>
+                    <a:lnR w="9525" cap="flat" cmpd="sng" algn="ctr">
+                      <a:solidFill>
+                        <a:srgbClr val="D7E1F5"/>
+                      </a:solidFill>
+                      <a:prstDash val="solid"/>
+                      <a:round/>
+                      <a:headEnd type="none" w="med" len="med"/>
+                      <a:tailEnd type="none" w="med" len="med"/>
+                    </a:lnR>
+                    <a:lnT w="9525" cap="flat" cmpd="sng" algn="ctr">
+                      <a:solidFill>
+                        <a:srgbClr val="D7E1F5"/>
+                      </a:solidFill>
+                      <a:prstDash val="solid"/>
+                      <a:round/>
+                      <a:headEnd type="none" w="med" len="med"/>
+                      <a:tailEnd type="none" w="med" len="med"/>
+                    </a:lnT>
+                    <a:lnB w="9525" cap="flat" cmpd="sng" algn="ctr">
+                      <a:solidFill>
+                        <a:srgbClr val="D7E1F5"/>
+                      </a:solidFill>
+                      <a:prstDash val="solid"/>
+                      <a:round/>
+                      <a:headEnd type="none" w="med" len="med"/>
+                      <a:tailEnd type="none" w="med" len="med"/>
+                    </a:lnB>
+                    <a:solidFill>
+                      <a:srgbClr val="F5F8FD"/>
+                    </a:solidFill>
+                  </a:tcPr>
+                </a:tc>
+                <a:tc>
+                  <a:txBody>
+                    <a:bodyPr/>
+                    <a:lstStyle/>
+                    <a:p>
+                      <a:pPr algn="ctr" indent="0" marL="0">
+                        <a:buNone/>
+                      </a:pPr>
+                      <a:r>
+                        <a:rPr lang="en-US" sz="830" dirty="0">
+                          <a:solidFill>
+                            <a:srgbClr val="3A4566"/>
+                          </a:solidFill>
+                          <a:latin typeface="Calibri" pitchFamily="34" charset="0"/>
+                          <a:ea typeface="Calibri" pitchFamily="34" charset="-122"/>
+                          <a:cs typeface="Calibri" pitchFamily="34" charset="-120"/>
+                        </a:rPr>
+                        <a:t>Not confirmed</a:t>
+                      </a:r>
+                      <a:endParaRPr lang="en-US" sz="830" dirty="0">
+                        <a:latin typeface="Calibri" charset="0"/>
+                        <a:ea typeface="Calibri" charset="0"/>
+                        <a:cs typeface="Calibri" charset="0"/>
+                      </a:endParaRPr>
+                    </a:p>
+                  </a:txBody>
+                  <a:tcPr marL="76200" marR="76200" marT="38100" marB="38100" anchor="ctr">
+                    <a:lnL w="9525" cap="flat" cmpd="sng" algn="ctr">
+                      <a:solidFill>
+                        <a:srgbClr val="D7E1F5"/>
+                      </a:solidFill>
+                      <a:prstDash val="solid"/>
+                      <a:round/>
+                      <a:headEnd type="none" w="med" len="med"/>
+                      <a:tailEnd type="none" w="med" len="med"/>
+                    </a:lnL>
+                    <a:lnR w="9525" cap="flat" cmpd="sng" algn="ctr">
+                      <a:solidFill>
+                        <a:srgbClr val="D7E1F5"/>
+                      </a:solidFill>
+                      <a:prstDash val="solid"/>
+                      <a:round/>
+                      <a:headEnd type="none" w="med" len="med"/>
+                      <a:tailEnd type="none" w="med" len="med"/>
+                    </a:lnR>
+                    <a:lnT w="9525" cap="flat" cmpd="sng" algn="ctr">
+                      <a:solidFill>
+                        <a:srgbClr val="D7E1F5"/>
+                      </a:solidFill>
+                      <a:prstDash val="solid"/>
+                      <a:round/>
+                      <a:headEnd type="none" w="med" len="med"/>
+                      <a:tailEnd type="none" w="med" len="med"/>
+                    </a:lnT>
+                    <a:lnB w="9525" cap="flat" cmpd="sng" algn="ctr">
+                      <a:solidFill>
+                        <a:srgbClr val="D7E1F5"/>
+                      </a:solidFill>
+                      <a:prstDash val="solid"/>
+                      <a:round/>
+                      <a:headEnd type="none" w="med" len="med"/>
+                      <a:tailEnd type="none" w="med" len="med"/>
+                    </a:lnB>
+                    <a:solidFill>
+                      <a:srgbClr val="F5F8FD"/>
+                    </a:solidFill>
+                  </a:tcPr>
+                </a:tc>
+              </a:tr>
+              <a:tr h="0">
+                <a:tc>
+                  <a:txBody>
+                    <a:bodyPr/>
+                    <a:lstStyle/>
+                    <a:p>
+                      <a:pPr algn="l" indent="0" marL="0">
+                        <a:buNone/>
+                      </a:pPr>
+                      <a:r>
+                        <a:rPr lang="en-US" sz="830" b="1" dirty="0">
+                          <a:solidFill>
+                            <a:srgbClr val="1E2761"/>
+                          </a:solidFill>
+                          <a:latin typeface="Calibri" pitchFamily="34" charset="0"/>
+                          <a:ea typeface="Calibri" pitchFamily="34" charset="-122"/>
+                          <a:cs typeface="Calibri" pitchFamily="34" charset="-120"/>
+                        </a:rPr>
+                        <a:t>Custodian</a:t>
+                      </a:r>
+                      <a:endParaRPr lang="en-US" sz="830" dirty="0">
+                        <a:latin typeface="Calibri" charset="0"/>
+                        <a:ea typeface="Calibri" charset="0"/>
+                        <a:cs typeface="Calibri" charset="0"/>
+                      </a:endParaRPr>
+                    </a:p>
+                  </a:txBody>
+                  <a:tcPr marL="76200" marR="76200" marT="38100" marB="38100" anchor="ctr">
+                    <a:lnL w="9525" cap="flat" cmpd="sng" algn="ctr">
+                      <a:solidFill>
+                        <a:srgbClr val="D7E1F5"/>
+                      </a:solidFill>
+                      <a:prstDash val="solid"/>
+                      <a:round/>
+                      <a:headEnd type="none" w="med" len="med"/>
+                      <a:tailEnd type="none" w="med" len="med"/>
+                    </a:lnL>
+                    <a:lnR w="9525" cap="flat" cmpd="sng" algn="ctr">
+                      <a:solidFill>
+                        <a:srgbClr val="D7E1F5"/>
+                      </a:solidFill>
+                      <a:prstDash val="solid"/>
+                      <a:round/>
+                      <a:headEnd type="none" w="med" len="med"/>
+                      <a:tailEnd type="none" w="med" len="med"/>
+                    </a:lnR>
+                    <a:lnT w="9525" cap="flat" cmpd="sng" algn="ctr">
+                      <a:solidFill>
+                        <a:srgbClr val="D7E1F5"/>
+                      </a:solidFill>
+                      <a:prstDash val="solid"/>
+                      <a:round/>
+                      <a:headEnd type="none" w="med" len="med"/>
+                      <a:tailEnd type="none" w="med" len="med"/>
+                    </a:lnT>
+                    <a:lnB w="9525" cap="flat" cmpd="sng" algn="ctr">
+                      <a:solidFill>
+                        <a:srgbClr val="D7E1F5"/>
+                      </a:solidFill>
+                      <a:prstDash val="solid"/>
+                      <a:round/>
+                      <a:headEnd type="none" w="med" len="med"/>
+                      <a:tailEnd type="none" w="med" len="med"/>
+                    </a:lnB>
+                    <a:solidFill>
                       <a:srgbClr val="FFFFFF"/>
                     </a:solidFill>
                   </a:tcPr>
@@ -19997,7 +20953,7 @@
                           <a:ea typeface="Calibri" pitchFamily="34" charset="-122"/>
                           <a:cs typeface="Calibri" pitchFamily="34" charset="-120"/>
                         </a:rPr>
-                        <a:t>FT Services/JPMorgan</a:t>
+                        <a:t>JPMorgan Chase</a:t>
                       </a:r>
                       <a:endParaRPr lang="en-US" sz="830" dirty="0">
                         <a:latin typeface="Calibri" charset="0"/>
@@ -20269,7 +21225,7 @@
                           <a:ea typeface="Calibri" pitchFamily="34" charset="-122"/>
                           <a:cs typeface="Calibri" pitchFamily="34" charset="-120"/>
                         </a:rPr>
-                        <a:t>NAV Consulting</a:t>
+                        <a:t>Not confirmed</a:t>
                       </a:r>
                       <a:endParaRPr lang="en-US" sz="830" dirty="0">
                         <a:latin typeface="Calibri" charset="0"/>
@@ -20407,7 +21363,7 @@
                           <a:ea typeface="Calibri" pitchFamily="34" charset="-122"/>
                           <a:cs typeface="Calibri" pitchFamily="34" charset="-120"/>
                         </a:rPr>
-                        <a:t>Custodian</a:t>
+                        <a:t>Auditor</a:t>
                       </a:r>
                       <a:endParaRPr lang="en-US" sz="830" dirty="0">
                         <a:latin typeface="Calibri" charset="0"/>
@@ -20475,7 +21431,7 @@
                           <a:ea typeface="Calibri" pitchFamily="34" charset="-122"/>
                           <a:cs typeface="Calibri" pitchFamily="34" charset="-120"/>
                         </a:rPr>
-                        <a:t>JPMorgan Chase</a:t>
+                        <a:t>PwC</a:t>
                       </a:r>
                       <a:endParaRPr lang="en-US" sz="830" dirty="0">
                         <a:latin typeface="Calibri" charset="0"/>
@@ -20543,7 +21499,7 @@
                           <a:ea typeface="Calibri" pitchFamily="34" charset="-122"/>
                           <a:cs typeface="Calibri" pitchFamily="34" charset="-120"/>
                         </a:rPr>
-                        <a:t>BNY Mellon</a:t>
+                        <a:t>PwC</a:t>
                       </a:r>
                       <a:endParaRPr lang="en-US" sz="830" dirty="0">
                         <a:latin typeface="Calibri" charset="0"/>
@@ -20679,7 +21635,7 @@
                           <a:ea typeface="Calibri" pitchFamily="34" charset="-122"/>
                           <a:cs typeface="Calibri" pitchFamily="34" charset="-120"/>
                         </a:rPr>
-                        <a:t>Not confirmed</a:t>
+                        <a:t>EY (secondary)</a:t>
                       </a:r>
                       <a:endParaRPr lang="en-US" sz="830" dirty="0">
                         <a:latin typeface="Calibri" charset="0"/>
@@ -20885,484 +21841,6 @@
                           <a:ea typeface="Calibri" pitchFamily="34" charset="-122"/>
                           <a:cs typeface="Calibri" pitchFamily="34" charset="-120"/>
                         </a:rPr>
-                        <a:t>Auditor</a:t>
-                      </a:r>
-                      <a:endParaRPr lang="en-US" sz="830" dirty="0">
-                        <a:latin typeface="Calibri" charset="0"/>
-                        <a:ea typeface="Calibri" charset="0"/>
-                        <a:cs typeface="Calibri" charset="0"/>
-                      </a:endParaRPr>
-                    </a:p>
-                  </a:txBody>
-                  <a:tcPr marL="76200" marR="76200" marT="38100" marB="38100" anchor="ctr">
-                    <a:lnL w="9525" cap="flat" cmpd="sng" algn="ctr">
-                      <a:solidFill>
-                        <a:srgbClr val="D7E1F5"/>
-                      </a:solidFill>
-                      <a:prstDash val="solid"/>
-                      <a:round/>
-                      <a:headEnd type="none" w="med" len="med"/>
-                      <a:tailEnd type="none" w="med" len="med"/>
-                    </a:lnL>
-                    <a:lnR w="9525" cap="flat" cmpd="sng" algn="ctr">
-                      <a:solidFill>
-                        <a:srgbClr val="D7E1F5"/>
-                      </a:solidFill>
-                      <a:prstDash val="solid"/>
-                      <a:round/>
-                      <a:headEnd type="none" w="med" len="med"/>
-                      <a:tailEnd type="none" w="med" len="med"/>
-                    </a:lnR>
-                    <a:lnT w="9525" cap="flat" cmpd="sng" algn="ctr">
-                      <a:solidFill>
-                        <a:srgbClr val="D7E1F5"/>
-                      </a:solidFill>
-                      <a:prstDash val="solid"/>
-                      <a:round/>
-                      <a:headEnd type="none" w="med" len="med"/>
-                      <a:tailEnd type="none" w="med" len="med"/>
-                    </a:lnT>
-                    <a:lnB w="9525" cap="flat" cmpd="sng" algn="ctr">
-                      <a:solidFill>
-                        <a:srgbClr val="D7E1F5"/>
-                      </a:solidFill>
-                      <a:prstDash val="solid"/>
-                      <a:round/>
-                      <a:headEnd type="none" w="med" len="med"/>
-                      <a:tailEnd type="none" w="med" len="med"/>
-                    </a:lnB>
-                    <a:solidFill>
-                      <a:srgbClr val="FFFFFF"/>
-                    </a:solidFill>
-                  </a:tcPr>
-                </a:tc>
-                <a:tc>
-                  <a:txBody>
-                    <a:bodyPr/>
-                    <a:lstStyle/>
-                    <a:p>
-                      <a:pPr algn="ctr" indent="0" marL="0">
-                        <a:buNone/>
-                      </a:pPr>
-                      <a:r>
-                        <a:rPr lang="en-US" sz="830" dirty="0">
-                          <a:solidFill>
-                            <a:srgbClr val="3A4566"/>
-                          </a:solidFill>
-                          <a:latin typeface="Calibri" pitchFamily="34" charset="0"/>
-                          <a:ea typeface="Calibri" pitchFamily="34" charset="-122"/>
-                          <a:cs typeface="Calibri" pitchFamily="34" charset="-120"/>
-                        </a:rPr>
-                        <a:t>PwC</a:t>
-                      </a:r>
-                      <a:endParaRPr lang="en-US" sz="830" dirty="0">
-                        <a:latin typeface="Calibri" charset="0"/>
-                        <a:ea typeface="Calibri" charset="0"/>
-                        <a:cs typeface="Calibri" charset="0"/>
-                      </a:endParaRPr>
-                    </a:p>
-                  </a:txBody>
-                  <a:tcPr marL="76200" marR="76200" marT="38100" marB="38100" anchor="ctr">
-                    <a:lnL w="9525" cap="flat" cmpd="sng" algn="ctr">
-                      <a:solidFill>
-                        <a:srgbClr val="D7E1F5"/>
-                      </a:solidFill>
-                      <a:prstDash val="solid"/>
-                      <a:round/>
-                      <a:headEnd type="none" w="med" len="med"/>
-                      <a:tailEnd type="none" w="med" len="med"/>
-                    </a:lnL>
-                    <a:lnR w="9525" cap="flat" cmpd="sng" algn="ctr">
-                      <a:solidFill>
-                        <a:srgbClr val="D7E1F5"/>
-                      </a:solidFill>
-                      <a:prstDash val="solid"/>
-                      <a:round/>
-                      <a:headEnd type="none" w="med" len="med"/>
-                      <a:tailEnd type="none" w="med" len="med"/>
-                    </a:lnR>
-                    <a:lnT w="9525" cap="flat" cmpd="sng" algn="ctr">
-                      <a:solidFill>
-                        <a:srgbClr val="D7E1F5"/>
-                      </a:solidFill>
-                      <a:prstDash val="solid"/>
-                      <a:round/>
-                      <a:headEnd type="none" w="med" len="med"/>
-                      <a:tailEnd type="none" w="med" len="med"/>
-                    </a:lnT>
-                    <a:lnB w="9525" cap="flat" cmpd="sng" algn="ctr">
-                      <a:solidFill>
-                        <a:srgbClr val="D7E1F5"/>
-                      </a:solidFill>
-                      <a:prstDash val="solid"/>
-                      <a:round/>
-                      <a:headEnd type="none" w="med" len="med"/>
-                      <a:tailEnd type="none" w="med" len="med"/>
-                    </a:lnB>
-                    <a:solidFill>
-                      <a:srgbClr val="FFFFFF"/>
-                    </a:solidFill>
-                  </a:tcPr>
-                </a:tc>
-                <a:tc>
-                  <a:txBody>
-                    <a:bodyPr/>
-                    <a:lstStyle/>
-                    <a:p>
-                      <a:pPr algn="ctr" indent="0" marL="0">
-                        <a:buNone/>
-                      </a:pPr>
-                      <a:r>
-                        <a:rPr lang="en-US" sz="830" dirty="0">
-                          <a:solidFill>
-                            <a:srgbClr val="3A4566"/>
-                          </a:solidFill>
-                          <a:latin typeface="Calibri" pitchFamily="34" charset="0"/>
-                          <a:ea typeface="Calibri" pitchFamily="34" charset="-122"/>
-                          <a:cs typeface="Calibri" pitchFamily="34" charset="-120"/>
-                        </a:rPr>
-                        <a:t>PwC</a:t>
-                      </a:r>
-                      <a:endParaRPr lang="en-US" sz="830" dirty="0">
-                        <a:latin typeface="Calibri" charset="0"/>
-                        <a:ea typeface="Calibri" charset="0"/>
-                        <a:cs typeface="Calibri" charset="0"/>
-                      </a:endParaRPr>
-                    </a:p>
-                  </a:txBody>
-                  <a:tcPr marL="76200" marR="76200" marT="38100" marB="38100" anchor="ctr">
-                    <a:lnL w="9525" cap="flat" cmpd="sng" algn="ctr">
-                      <a:solidFill>
-                        <a:srgbClr val="D7E1F5"/>
-                      </a:solidFill>
-                      <a:prstDash val="solid"/>
-                      <a:round/>
-                      <a:headEnd type="none" w="med" len="med"/>
-                      <a:tailEnd type="none" w="med" len="med"/>
-                    </a:lnL>
-                    <a:lnR w="9525" cap="flat" cmpd="sng" algn="ctr">
-                      <a:solidFill>
-                        <a:srgbClr val="D7E1F5"/>
-                      </a:solidFill>
-                      <a:prstDash val="solid"/>
-                      <a:round/>
-                      <a:headEnd type="none" w="med" len="med"/>
-                      <a:tailEnd type="none" w="med" len="med"/>
-                    </a:lnR>
-                    <a:lnT w="9525" cap="flat" cmpd="sng" algn="ctr">
-                      <a:solidFill>
-                        <a:srgbClr val="D7E1F5"/>
-                      </a:solidFill>
-                      <a:prstDash val="solid"/>
-                      <a:round/>
-                      <a:headEnd type="none" w="med" len="med"/>
-                      <a:tailEnd type="none" w="med" len="med"/>
-                    </a:lnT>
-                    <a:lnB w="9525" cap="flat" cmpd="sng" algn="ctr">
-                      <a:solidFill>
-                        <a:srgbClr val="D7E1F5"/>
-                      </a:solidFill>
-                      <a:prstDash val="solid"/>
-                      <a:round/>
-                      <a:headEnd type="none" w="med" len="med"/>
-                      <a:tailEnd type="none" w="med" len="med"/>
-                    </a:lnB>
-                    <a:solidFill>
-                      <a:srgbClr val="FFFFFF"/>
-                    </a:solidFill>
-                  </a:tcPr>
-                </a:tc>
-                <a:tc>
-                  <a:txBody>
-                    <a:bodyPr/>
-                    <a:lstStyle/>
-                    <a:p>
-                      <a:pPr algn="ctr" indent="0" marL="0">
-                        <a:buNone/>
-                      </a:pPr>
-                      <a:r>
-                        <a:rPr lang="en-US" sz="830" dirty="0">
-                          <a:solidFill>
-                            <a:srgbClr val="3A4566"/>
-                          </a:solidFill>
-                          <a:latin typeface="Calibri" pitchFamily="34" charset="0"/>
-                          <a:ea typeface="Calibri" pitchFamily="34" charset="-122"/>
-                          <a:cs typeface="Calibri" pitchFamily="34" charset="-120"/>
-                        </a:rPr>
-                        <a:t>Not confirmed</a:t>
-                      </a:r>
-                      <a:endParaRPr lang="en-US" sz="830" dirty="0">
-                        <a:latin typeface="Calibri" charset="0"/>
-                        <a:ea typeface="Calibri" charset="0"/>
-                        <a:cs typeface="Calibri" charset="0"/>
-                      </a:endParaRPr>
-                    </a:p>
-                  </a:txBody>
-                  <a:tcPr marL="76200" marR="76200" marT="38100" marB="38100" anchor="ctr">
-                    <a:lnL w="9525" cap="flat" cmpd="sng" algn="ctr">
-                      <a:solidFill>
-                        <a:srgbClr val="D7E1F5"/>
-                      </a:solidFill>
-                      <a:prstDash val="solid"/>
-                      <a:round/>
-                      <a:headEnd type="none" w="med" len="med"/>
-                      <a:tailEnd type="none" w="med" len="med"/>
-                    </a:lnL>
-                    <a:lnR w="9525" cap="flat" cmpd="sng" algn="ctr">
-                      <a:solidFill>
-                        <a:srgbClr val="D7E1F5"/>
-                      </a:solidFill>
-                      <a:prstDash val="solid"/>
-                      <a:round/>
-                      <a:headEnd type="none" w="med" len="med"/>
-                      <a:tailEnd type="none" w="med" len="med"/>
-                    </a:lnR>
-                    <a:lnT w="9525" cap="flat" cmpd="sng" algn="ctr">
-                      <a:solidFill>
-                        <a:srgbClr val="D7E1F5"/>
-                      </a:solidFill>
-                      <a:prstDash val="solid"/>
-                      <a:round/>
-                      <a:headEnd type="none" w="med" len="med"/>
-                      <a:tailEnd type="none" w="med" len="med"/>
-                    </a:lnT>
-                    <a:lnB w="9525" cap="flat" cmpd="sng" algn="ctr">
-                      <a:solidFill>
-                        <a:srgbClr val="D7E1F5"/>
-                      </a:solidFill>
-                      <a:prstDash val="solid"/>
-                      <a:round/>
-                      <a:headEnd type="none" w="med" len="med"/>
-                      <a:tailEnd type="none" w="med" len="med"/>
-                    </a:lnB>
-                    <a:solidFill>
-                      <a:srgbClr val="FFFFFF"/>
-                    </a:solidFill>
-                  </a:tcPr>
-                </a:tc>
-                <a:tc>
-                  <a:txBody>
-                    <a:bodyPr/>
-                    <a:lstStyle/>
-                    <a:p>
-                      <a:pPr algn="ctr" indent="0" marL="0">
-                        <a:buNone/>
-                      </a:pPr>
-                      <a:r>
-                        <a:rPr lang="en-US" sz="830" dirty="0">
-                          <a:solidFill>
-                            <a:srgbClr val="3A4566"/>
-                          </a:solidFill>
-                          <a:latin typeface="Calibri" pitchFamily="34" charset="0"/>
-                          <a:ea typeface="Calibri" pitchFamily="34" charset="-122"/>
-                          <a:cs typeface="Calibri" pitchFamily="34" charset="-120"/>
-                        </a:rPr>
-                        <a:t>EY (secondary)</a:t>
-                      </a:r>
-                      <a:endParaRPr lang="en-US" sz="830" dirty="0">
-                        <a:latin typeface="Calibri" charset="0"/>
-                        <a:ea typeface="Calibri" charset="0"/>
-                        <a:cs typeface="Calibri" charset="0"/>
-                      </a:endParaRPr>
-                    </a:p>
-                  </a:txBody>
-                  <a:tcPr marL="76200" marR="76200" marT="38100" marB="38100" anchor="ctr">
-                    <a:lnL w="9525" cap="flat" cmpd="sng" algn="ctr">
-                      <a:solidFill>
-                        <a:srgbClr val="D7E1F5"/>
-                      </a:solidFill>
-                      <a:prstDash val="solid"/>
-                      <a:round/>
-                      <a:headEnd type="none" w="med" len="med"/>
-                      <a:tailEnd type="none" w="med" len="med"/>
-                    </a:lnL>
-                    <a:lnR w="9525" cap="flat" cmpd="sng" algn="ctr">
-                      <a:solidFill>
-                        <a:srgbClr val="D7E1F5"/>
-                      </a:solidFill>
-                      <a:prstDash val="solid"/>
-                      <a:round/>
-                      <a:headEnd type="none" w="med" len="med"/>
-                      <a:tailEnd type="none" w="med" len="med"/>
-                    </a:lnR>
-                    <a:lnT w="9525" cap="flat" cmpd="sng" algn="ctr">
-                      <a:solidFill>
-                        <a:srgbClr val="D7E1F5"/>
-                      </a:solidFill>
-                      <a:prstDash val="solid"/>
-                      <a:round/>
-                      <a:headEnd type="none" w="med" len="med"/>
-                      <a:tailEnd type="none" w="med" len="med"/>
-                    </a:lnT>
-                    <a:lnB w="9525" cap="flat" cmpd="sng" algn="ctr">
-                      <a:solidFill>
-                        <a:srgbClr val="D7E1F5"/>
-                      </a:solidFill>
-                      <a:prstDash val="solid"/>
-                      <a:round/>
-                      <a:headEnd type="none" w="med" len="med"/>
-                      <a:tailEnd type="none" w="med" len="med"/>
-                    </a:lnB>
-                    <a:solidFill>
-                      <a:srgbClr val="FFFFFF"/>
-                    </a:solidFill>
-                  </a:tcPr>
-                </a:tc>
-                <a:tc>
-                  <a:txBody>
-                    <a:bodyPr/>
-                    <a:lstStyle/>
-                    <a:p>
-                      <a:pPr algn="ctr" indent="0" marL="0">
-                        <a:buNone/>
-                      </a:pPr>
-                      <a:r>
-                        <a:rPr lang="en-US" sz="830" dirty="0">
-                          <a:solidFill>
-                            <a:srgbClr val="3A4566"/>
-                          </a:solidFill>
-                          <a:latin typeface="Calibri" pitchFamily="34" charset="0"/>
-                          <a:ea typeface="Calibri" pitchFamily="34" charset="-122"/>
-                          <a:cs typeface="Calibri" pitchFamily="34" charset="-120"/>
-                        </a:rPr>
-                        <a:t>Not confirmed</a:t>
-                      </a:r>
-                      <a:endParaRPr lang="en-US" sz="830" dirty="0">
-                        <a:latin typeface="Calibri" charset="0"/>
-                        <a:ea typeface="Calibri" charset="0"/>
-                        <a:cs typeface="Calibri" charset="0"/>
-                      </a:endParaRPr>
-                    </a:p>
-                  </a:txBody>
-                  <a:tcPr marL="76200" marR="76200" marT="38100" marB="38100" anchor="ctr">
-                    <a:lnL w="9525" cap="flat" cmpd="sng" algn="ctr">
-                      <a:solidFill>
-                        <a:srgbClr val="D7E1F5"/>
-                      </a:solidFill>
-                      <a:prstDash val="solid"/>
-                      <a:round/>
-                      <a:headEnd type="none" w="med" len="med"/>
-                      <a:tailEnd type="none" w="med" len="med"/>
-                    </a:lnL>
-                    <a:lnR w="9525" cap="flat" cmpd="sng" algn="ctr">
-                      <a:solidFill>
-                        <a:srgbClr val="D7E1F5"/>
-                      </a:solidFill>
-                      <a:prstDash val="solid"/>
-                      <a:round/>
-                      <a:headEnd type="none" w="med" len="med"/>
-                      <a:tailEnd type="none" w="med" len="med"/>
-                    </a:lnR>
-                    <a:lnT w="9525" cap="flat" cmpd="sng" algn="ctr">
-                      <a:solidFill>
-                        <a:srgbClr val="D7E1F5"/>
-                      </a:solidFill>
-                      <a:prstDash val="solid"/>
-                      <a:round/>
-                      <a:headEnd type="none" w="med" len="med"/>
-                      <a:tailEnd type="none" w="med" len="med"/>
-                    </a:lnT>
-                    <a:lnB w="9525" cap="flat" cmpd="sng" algn="ctr">
-                      <a:solidFill>
-                        <a:srgbClr val="D7E1F5"/>
-                      </a:solidFill>
-                      <a:prstDash val="solid"/>
-                      <a:round/>
-                      <a:headEnd type="none" w="med" len="med"/>
-                      <a:tailEnd type="none" w="med" len="med"/>
-                    </a:lnB>
-                    <a:solidFill>
-                      <a:srgbClr val="FFFFFF"/>
-                    </a:solidFill>
-                  </a:tcPr>
-                </a:tc>
-                <a:tc>
-                  <a:txBody>
-                    <a:bodyPr/>
-                    <a:lstStyle/>
-                    <a:p>
-                      <a:pPr algn="ctr" indent="0" marL="0">
-                        <a:buNone/>
-                      </a:pPr>
-                      <a:r>
-                        <a:rPr lang="en-US" sz="830" dirty="0">
-                          <a:solidFill>
-                            <a:srgbClr val="3A4566"/>
-                          </a:solidFill>
-                          <a:latin typeface="Calibri" pitchFamily="34" charset="0"/>
-                          <a:ea typeface="Calibri" pitchFamily="34" charset="-122"/>
-                          <a:cs typeface="Calibri" pitchFamily="34" charset="-120"/>
-                        </a:rPr>
-                        <a:t>Not confirmed</a:t>
-                      </a:r>
-                      <a:endParaRPr lang="en-US" sz="830" dirty="0">
-                        <a:latin typeface="Calibri" charset="0"/>
-                        <a:ea typeface="Calibri" charset="0"/>
-                        <a:cs typeface="Calibri" charset="0"/>
-                      </a:endParaRPr>
-                    </a:p>
-                  </a:txBody>
-                  <a:tcPr marL="76200" marR="76200" marT="38100" marB="38100" anchor="ctr">
-                    <a:lnL w="9525" cap="flat" cmpd="sng" algn="ctr">
-                      <a:solidFill>
-                        <a:srgbClr val="D7E1F5"/>
-                      </a:solidFill>
-                      <a:prstDash val="solid"/>
-                      <a:round/>
-                      <a:headEnd type="none" w="med" len="med"/>
-                      <a:tailEnd type="none" w="med" len="med"/>
-                    </a:lnL>
-                    <a:lnR w="9525" cap="flat" cmpd="sng" algn="ctr">
-                      <a:solidFill>
-                        <a:srgbClr val="D7E1F5"/>
-                      </a:solidFill>
-                      <a:prstDash val="solid"/>
-                      <a:round/>
-                      <a:headEnd type="none" w="med" len="med"/>
-                      <a:tailEnd type="none" w="med" len="med"/>
-                    </a:lnR>
-                    <a:lnT w="9525" cap="flat" cmpd="sng" algn="ctr">
-                      <a:solidFill>
-                        <a:srgbClr val="D7E1F5"/>
-                      </a:solidFill>
-                      <a:prstDash val="solid"/>
-                      <a:round/>
-                      <a:headEnd type="none" w="med" len="med"/>
-                      <a:tailEnd type="none" w="med" len="med"/>
-                    </a:lnT>
-                    <a:lnB w="9525" cap="flat" cmpd="sng" algn="ctr">
-                      <a:solidFill>
-                        <a:srgbClr val="D7E1F5"/>
-                      </a:solidFill>
-                      <a:prstDash val="solid"/>
-                      <a:round/>
-                      <a:headEnd type="none" w="med" len="med"/>
-                      <a:tailEnd type="none" w="med" len="med"/>
-                    </a:lnB>
-                    <a:solidFill>
-                      <a:srgbClr val="FFFFFF"/>
-                    </a:solidFill>
-                  </a:tcPr>
-                </a:tc>
-              </a:tr>
-              <a:tr h="0">
-                <a:tc>
-                  <a:txBody>
-                    <a:bodyPr/>
-                    <a:lstStyle/>
-                    <a:p>
-                      <a:pPr algn="l" indent="0" marL="0">
-                        <a:buNone/>
-                      </a:pPr>
-                      <a:r>
-                        <a:rPr lang="en-US" sz="830" b="1" dirty="0">
-                          <a:solidFill>
-                            <a:srgbClr val="1E2761"/>
-                          </a:solidFill>
-                          <a:latin typeface="Calibri" pitchFamily="34" charset="0"/>
-                          <a:ea typeface="Calibri" pitchFamily="34" charset="-122"/>
-                          <a:cs typeface="Calibri" pitchFamily="34" charset="-120"/>
-                        </a:rPr>
                         <a:t>Primary blockchain</a:t>
                       </a:r>
                       <a:endParaRPr lang="en-US" sz="830" dirty="0">
@@ -21410,7 +21888,7 @@
                       <a:tailEnd type="none" w="med" len="med"/>
                     </a:lnB>
                     <a:solidFill>
-                      <a:srgbClr val="F5F8FD"/>
+                      <a:srgbClr val="FFFFFF"/>
                     </a:solidFill>
                   </a:tcPr>
                 </a:tc>
@@ -21478,7 +21956,7 @@
                       <a:tailEnd type="none" w="med" len="med"/>
                     </a:lnB>
                     <a:solidFill>
-                      <a:srgbClr val="F5F8FD"/>
+                      <a:srgbClr val="FFFFFF"/>
                     </a:solidFill>
                   </a:tcPr>
                 </a:tc>
@@ -21546,7 +22024,7 @@
                       <a:tailEnd type="none" w="med" len="med"/>
                     </a:lnB>
                     <a:solidFill>
-                      <a:srgbClr val="F5F8FD"/>
+                      <a:srgbClr val="FFFFFF"/>
                     </a:solidFill>
                   </a:tcPr>
                 </a:tc>
@@ -21614,7 +22092,7 @@
                       <a:tailEnd type="none" w="med" len="med"/>
                     </a:lnB>
                     <a:solidFill>
-                      <a:srgbClr val="F5F8FD"/>
+                      <a:srgbClr val="FFFFFF"/>
                     </a:solidFill>
                   </a:tcPr>
                 </a:tc>
@@ -21682,7 +22160,7 @@
                       <a:tailEnd type="none" w="med" len="med"/>
                     </a:lnB>
                     <a:solidFill>
-                      <a:srgbClr val="F5F8FD"/>
+                      <a:srgbClr val="FFFFFF"/>
                     </a:solidFill>
                   </a:tcPr>
                 </a:tc>
@@ -21750,7 +22228,7 @@
                       <a:tailEnd type="none" w="med" len="med"/>
                     </a:lnB>
                     <a:solidFill>
-                      <a:srgbClr val="F5F8FD"/>
+                      <a:srgbClr val="FFFFFF"/>
                     </a:solidFill>
                   </a:tcPr>
                 </a:tc>
@@ -21818,7 +22296,7 @@
                       <a:tailEnd type="none" w="med" len="med"/>
                     </a:lnB>
                     <a:solidFill>
-                      <a:srgbClr val="F5F8FD"/>
+                      <a:srgbClr val="FFFFFF"/>
                     </a:solidFill>
                   </a:tcPr>
                 </a:tc>
@@ -21888,7 +22366,7 @@
                       <a:tailEnd type="none" w="med" len="med"/>
                     </a:lnB>
                     <a:solidFill>
-                      <a:srgbClr val="FFFFFF"/>
+                      <a:srgbClr val="F5F8FD"/>
                     </a:solidFill>
                   </a:tcPr>
                 </a:tc>
@@ -21956,7 +22434,7 @@
                       <a:tailEnd type="none" w="med" len="med"/>
                     </a:lnB>
                     <a:solidFill>
-                      <a:srgbClr val="FFFFFF"/>
+                      <a:srgbClr val="F5F8FD"/>
                     </a:solidFill>
                   </a:tcPr>
                 </a:tc>
@@ -22024,7 +22502,7 @@
                       <a:tailEnd type="none" w="med" len="med"/>
                     </a:lnB>
                     <a:solidFill>
-                      <a:srgbClr val="FFFFFF"/>
+                      <a:srgbClr val="F5F8FD"/>
                     </a:solidFill>
                   </a:tcPr>
                 </a:tc>
@@ -22092,7 +22570,7 @@
                       <a:tailEnd type="none" w="med" len="med"/>
                     </a:lnB>
                     <a:solidFill>
-                      <a:srgbClr val="FFFFFF"/>
+                      <a:srgbClr val="F5F8FD"/>
                     </a:solidFill>
                   </a:tcPr>
                 </a:tc>
@@ -22160,7 +22638,7 @@
                       <a:tailEnd type="none" w="med" len="med"/>
                     </a:lnB>
                     <a:solidFill>
-                      <a:srgbClr val="FFFFFF"/>
+                      <a:srgbClr val="F5F8FD"/>
                     </a:solidFill>
                   </a:tcPr>
                 </a:tc>
@@ -22228,7 +22706,7 @@
                       <a:tailEnd type="none" w="med" len="med"/>
                     </a:lnB>
                     <a:solidFill>
-                      <a:srgbClr val="FFFFFF"/>
+                      <a:srgbClr val="F5F8FD"/>
                     </a:solidFill>
                   </a:tcPr>
                 </a:tc>
@@ -22296,7 +22774,7 @@
                       <a:tailEnd type="none" w="med" len="med"/>
                     </a:lnB>
                     <a:solidFill>
-                      <a:srgbClr val="FFFFFF"/>
+                      <a:srgbClr val="F5F8FD"/>
                     </a:solidFill>
                   </a:tcPr>
                 </a:tc>
@@ -22366,7 +22844,7 @@
                       <a:tailEnd type="none" w="med" len="med"/>
                     </a:lnB>
                     <a:solidFill>
-                      <a:srgbClr val="F5F8FD"/>
+                      <a:srgbClr val="FFFFFF"/>
                     </a:solidFill>
                   </a:tcPr>
                 </a:tc>
@@ -22434,7 +22912,7 @@
                       <a:tailEnd type="none" w="med" len="med"/>
                     </a:lnB>
                     <a:solidFill>
-                      <a:srgbClr val="F5F8FD"/>
+                      <a:srgbClr val="FFFFFF"/>
                     </a:solidFill>
                   </a:tcPr>
                 </a:tc>
@@ -22502,7 +22980,7 @@
                       <a:tailEnd type="none" w="med" len="med"/>
                     </a:lnB>
                     <a:solidFill>
-                      <a:srgbClr val="F5F8FD"/>
+                      <a:srgbClr val="FFFFFF"/>
                     </a:solidFill>
                   </a:tcPr>
                 </a:tc>
@@ -22570,7 +23048,7 @@
                       <a:tailEnd type="none" w="med" len="med"/>
                     </a:lnB>
                     <a:solidFill>
-                      <a:srgbClr val="F5F8FD"/>
+                      <a:srgbClr val="FFFFFF"/>
                     </a:solidFill>
                   </a:tcPr>
                 </a:tc>
@@ -22638,7 +23116,7 @@
                       <a:tailEnd type="none" w="med" len="med"/>
                     </a:lnB>
                     <a:solidFill>
-                      <a:srgbClr val="F5F8FD"/>
+                      <a:srgbClr val="FFFFFF"/>
                     </a:solidFill>
                   </a:tcPr>
                 </a:tc>
@@ -22706,7 +23184,7 @@
                       <a:tailEnd type="none" w="med" len="med"/>
                     </a:lnB>
                     <a:solidFill>
-                      <a:srgbClr val="F5F8FD"/>
+                      <a:srgbClr val="FFFFFF"/>
                     </a:solidFill>
                   </a:tcPr>
                 </a:tc>
@@ -22774,7 +23252,7 @@
                       <a:tailEnd type="none" w="med" len="med"/>
                     </a:lnB>
                     <a:solidFill>
-                      <a:srgbClr val="F5F8FD"/>
+                      <a:srgbClr val="FFFFFF"/>
                     </a:solidFill>
                   </a:tcPr>
                 </a:tc>
@@ -22844,7 +23322,7 @@
                       <a:tailEnd type="none" w="med" len="med"/>
                     </a:lnB>
                     <a:solidFill>
-                      <a:srgbClr val="FFFFFF"/>
+                      <a:srgbClr val="F5F8FD"/>
                     </a:solidFill>
                   </a:tcPr>
                 </a:tc>
@@ -22912,7 +23390,7 @@
                       <a:tailEnd type="none" w="med" len="med"/>
                     </a:lnB>
                     <a:solidFill>
-                      <a:srgbClr val="FFFFFF"/>
+                      <a:srgbClr val="F5F8FD"/>
                     </a:solidFill>
                   </a:tcPr>
                 </a:tc>
@@ -22980,7 +23458,7 @@
                       <a:tailEnd type="none" w="med" len="med"/>
                     </a:lnB>
                     <a:solidFill>
-                      <a:srgbClr val="FFFFFF"/>
+                      <a:srgbClr val="F5F8FD"/>
                     </a:solidFill>
                   </a:tcPr>
                 </a:tc>
@@ -23048,7 +23526,7 @@
                       <a:tailEnd type="none" w="med" len="med"/>
                     </a:lnB>
                     <a:solidFill>
-                      <a:srgbClr val="FFFFFF"/>
+                      <a:srgbClr val="F5F8FD"/>
                     </a:solidFill>
                   </a:tcPr>
                 </a:tc>
@@ -23116,7 +23594,7 @@
                       <a:tailEnd type="none" w="med" len="med"/>
                     </a:lnB>
                     <a:solidFill>
-                      <a:srgbClr val="FFFFFF"/>
+                      <a:srgbClr val="F5F8FD"/>
                     </a:solidFill>
                   </a:tcPr>
                 </a:tc>
@@ -23184,7 +23662,7 @@
                       <a:tailEnd type="none" w="med" len="med"/>
                     </a:lnB>
                     <a:solidFill>
-                      <a:srgbClr val="FFFFFF"/>
+                      <a:srgbClr val="F5F8FD"/>
                     </a:solidFill>
                   </a:tcPr>
                 </a:tc>
@@ -23252,7 +23730,7 @@
                       <a:tailEnd type="none" w="med" len="med"/>
                     </a:lnB>
                     <a:solidFill>
-                      <a:srgbClr val="FFFFFF"/>
+                      <a:srgbClr val="F5F8FD"/>
                     </a:solidFill>
                   </a:tcPr>
                 </a:tc>

</xml_diff>

<commit_message>
Add taxation row showing fund manager's tax-reporting obligation
New "Taxation (manager's role)" row answers both what tax regime applies
and whether the manager/TA has to act on it. In every case the answer is
yes, but the instrument differs by legal-entity classification: RIC funds
(BENJI, likely WTGXX) issue Form 1099-DIV; the PFIC fund (BUIDL) issues
annual PFIC statements; the partnership-taxed funds (USTB, USCC, OUSG)
issue Schedule K-1s reporting each investor's distributive share, whether
or not cash was actually distributed.

Co-Authored-By: Claude Sonnet 5 <noreply@anthropic.com>
Claude-Session: https://claude.ai/code/session_01XLt1ze3JWdaihuSAsk6TrZ
</commit_message>
<xml_diff>
--- a/docs/presentations/Tokenized_Funds_Comparative_Analysis.pptx
+++ b/docs/presentations/Tokenized_Funds_Comparative_Analysis.pptx
@@ -18973,6 +18973,484 @@
                           <a:ea typeface="Calibri" pitchFamily="34" charset="-122"/>
                           <a:cs typeface="Calibri" pitchFamily="34" charset="-120"/>
                         </a:rPr>
+                        <a:t>Taxation (manager's role)</a:t>
+                      </a:r>
+                      <a:endParaRPr lang="en-US" sz="830" dirty="0">
+                        <a:latin typeface="Calibri" charset="0"/>
+                        <a:ea typeface="Calibri" charset="0"/>
+                        <a:cs typeface="Calibri" charset="0"/>
+                      </a:endParaRPr>
+                    </a:p>
+                  </a:txBody>
+                  <a:tcPr marL="76200" marR="76200" marT="38100" marB="38100" anchor="ctr">
+                    <a:lnL w="9525" cap="flat" cmpd="sng" algn="ctr">
+                      <a:solidFill>
+                        <a:srgbClr val="D7E1F5"/>
+                      </a:solidFill>
+                      <a:prstDash val="solid"/>
+                      <a:round/>
+                      <a:headEnd type="none" w="med" len="med"/>
+                      <a:tailEnd type="none" w="med" len="med"/>
+                    </a:lnL>
+                    <a:lnR w="9525" cap="flat" cmpd="sng" algn="ctr">
+                      <a:solidFill>
+                        <a:srgbClr val="D7E1F5"/>
+                      </a:solidFill>
+                      <a:prstDash val="solid"/>
+                      <a:round/>
+                      <a:headEnd type="none" w="med" len="med"/>
+                      <a:tailEnd type="none" w="med" len="med"/>
+                    </a:lnR>
+                    <a:lnT w="9525" cap="flat" cmpd="sng" algn="ctr">
+                      <a:solidFill>
+                        <a:srgbClr val="D7E1F5"/>
+                      </a:solidFill>
+                      <a:prstDash val="solid"/>
+                      <a:round/>
+                      <a:headEnd type="none" w="med" len="med"/>
+                      <a:tailEnd type="none" w="med" len="med"/>
+                    </a:lnT>
+                    <a:lnB w="9525" cap="flat" cmpd="sng" algn="ctr">
+                      <a:solidFill>
+                        <a:srgbClr val="D7E1F5"/>
+                      </a:solidFill>
+                      <a:prstDash val="solid"/>
+                      <a:round/>
+                      <a:headEnd type="none" w="med" len="med"/>
+                      <a:tailEnd type="none" w="med" len="med"/>
+                    </a:lnB>
+                    <a:solidFill>
+                      <a:srgbClr val="FFFFFF"/>
+                    </a:solidFill>
+                  </a:tcPr>
+                </a:tc>
+                <a:tc>
+                  <a:txBody>
+                    <a:bodyPr/>
+                    <a:lstStyle/>
+                    <a:p>
+                      <a:pPr algn="ctr" indent="0" marL="0">
+                        <a:buNone/>
+                      </a:pPr>
+                      <a:r>
+                        <a:rPr lang="en-US" sz="830" dirty="0">
+                          <a:solidFill>
+                            <a:srgbClr val="3A4566"/>
+                          </a:solidFill>
+                          <a:latin typeface="Calibri" pitchFamily="34" charset="0"/>
+                          <a:ea typeface="Calibri" pitchFamily="34" charset="-122"/>
+                          <a:cs typeface="Calibri" pitchFamily="34" charset="-120"/>
+                        </a:rPr>
+                        <a:t>RIC — issues 1099-DIV</a:t>
+                      </a:r>
+                      <a:endParaRPr lang="en-US" sz="830" dirty="0">
+                        <a:latin typeface="Calibri" charset="0"/>
+                        <a:ea typeface="Calibri" charset="0"/>
+                        <a:cs typeface="Calibri" charset="0"/>
+                      </a:endParaRPr>
+                    </a:p>
+                  </a:txBody>
+                  <a:tcPr marL="76200" marR="76200" marT="38100" marB="38100" anchor="ctr">
+                    <a:lnL w="9525" cap="flat" cmpd="sng" algn="ctr">
+                      <a:solidFill>
+                        <a:srgbClr val="D7E1F5"/>
+                      </a:solidFill>
+                      <a:prstDash val="solid"/>
+                      <a:round/>
+                      <a:headEnd type="none" w="med" len="med"/>
+                      <a:tailEnd type="none" w="med" len="med"/>
+                    </a:lnL>
+                    <a:lnR w="9525" cap="flat" cmpd="sng" algn="ctr">
+                      <a:solidFill>
+                        <a:srgbClr val="D7E1F5"/>
+                      </a:solidFill>
+                      <a:prstDash val="solid"/>
+                      <a:round/>
+                      <a:headEnd type="none" w="med" len="med"/>
+                      <a:tailEnd type="none" w="med" len="med"/>
+                    </a:lnR>
+                    <a:lnT w="9525" cap="flat" cmpd="sng" algn="ctr">
+                      <a:solidFill>
+                        <a:srgbClr val="D7E1F5"/>
+                      </a:solidFill>
+                      <a:prstDash val="solid"/>
+                      <a:round/>
+                      <a:headEnd type="none" w="med" len="med"/>
+                      <a:tailEnd type="none" w="med" len="med"/>
+                    </a:lnT>
+                    <a:lnB w="9525" cap="flat" cmpd="sng" algn="ctr">
+                      <a:solidFill>
+                        <a:srgbClr val="D7E1F5"/>
+                      </a:solidFill>
+                      <a:prstDash val="solid"/>
+                      <a:round/>
+                      <a:headEnd type="none" w="med" len="med"/>
+                      <a:tailEnd type="none" w="med" len="med"/>
+                    </a:lnB>
+                    <a:solidFill>
+                      <a:srgbClr val="FFFFFF"/>
+                    </a:solidFill>
+                  </a:tcPr>
+                </a:tc>
+                <a:tc>
+                  <a:txBody>
+                    <a:bodyPr/>
+                    <a:lstStyle/>
+                    <a:p>
+                      <a:pPr algn="ctr" indent="0" marL="0">
+                        <a:buNone/>
+                      </a:pPr>
+                      <a:r>
+                        <a:rPr lang="en-US" sz="830" dirty="0">
+                          <a:solidFill>
+                            <a:srgbClr val="3A4566"/>
+                          </a:solidFill>
+                          <a:latin typeface="Calibri" pitchFamily="34" charset="0"/>
+                          <a:ea typeface="Calibri" pitchFamily="34" charset="-122"/>
+                          <a:cs typeface="Calibri" pitchFamily="34" charset="-120"/>
+                        </a:rPr>
+                        <a:t>PFIC — issues PFIC statement</a:t>
+                      </a:r>
+                      <a:endParaRPr lang="en-US" sz="830" dirty="0">
+                        <a:latin typeface="Calibri" charset="0"/>
+                        <a:ea typeface="Calibri" charset="0"/>
+                        <a:cs typeface="Calibri" charset="0"/>
+                      </a:endParaRPr>
+                    </a:p>
+                  </a:txBody>
+                  <a:tcPr marL="76200" marR="76200" marT="38100" marB="38100" anchor="ctr">
+                    <a:lnL w="9525" cap="flat" cmpd="sng" algn="ctr">
+                      <a:solidFill>
+                        <a:srgbClr val="D7E1F5"/>
+                      </a:solidFill>
+                      <a:prstDash val="solid"/>
+                      <a:round/>
+                      <a:headEnd type="none" w="med" len="med"/>
+                      <a:tailEnd type="none" w="med" len="med"/>
+                    </a:lnL>
+                    <a:lnR w="9525" cap="flat" cmpd="sng" algn="ctr">
+                      <a:solidFill>
+                        <a:srgbClr val="D7E1F5"/>
+                      </a:solidFill>
+                      <a:prstDash val="solid"/>
+                      <a:round/>
+                      <a:headEnd type="none" w="med" len="med"/>
+                      <a:tailEnd type="none" w="med" len="med"/>
+                    </a:lnR>
+                    <a:lnT w="9525" cap="flat" cmpd="sng" algn="ctr">
+                      <a:solidFill>
+                        <a:srgbClr val="D7E1F5"/>
+                      </a:solidFill>
+                      <a:prstDash val="solid"/>
+                      <a:round/>
+                      <a:headEnd type="none" w="med" len="med"/>
+                      <a:tailEnd type="none" w="med" len="med"/>
+                    </a:lnT>
+                    <a:lnB w="9525" cap="flat" cmpd="sng" algn="ctr">
+                      <a:solidFill>
+                        <a:srgbClr val="D7E1F5"/>
+                      </a:solidFill>
+                      <a:prstDash val="solid"/>
+                      <a:round/>
+                      <a:headEnd type="none" w="med" len="med"/>
+                      <a:tailEnd type="none" w="med" len="med"/>
+                    </a:lnB>
+                    <a:solidFill>
+                      <a:srgbClr val="FFFFFF"/>
+                    </a:solidFill>
+                  </a:tcPr>
+                </a:tc>
+                <a:tc>
+                  <a:txBody>
+                    <a:bodyPr/>
+                    <a:lstStyle/>
+                    <a:p>
+                      <a:pPr algn="ctr" indent="0" marL="0">
+                        <a:buNone/>
+                      </a:pPr>
+                      <a:r>
+                        <a:rPr lang="en-US" sz="830" dirty="0">
+                          <a:solidFill>
+                            <a:srgbClr val="3A4566"/>
+                          </a:solidFill>
+                          <a:latin typeface="Calibri" pitchFamily="34" charset="0"/>
+                          <a:ea typeface="Calibri" pitchFamily="34" charset="-122"/>
+                          <a:cs typeface="Calibri" pitchFamily="34" charset="-120"/>
+                        </a:rPr>
+                        <a:t>Partnership — issues K-1</a:t>
+                      </a:r>
+                      <a:endParaRPr lang="en-US" sz="830" dirty="0">
+                        <a:latin typeface="Calibri" charset="0"/>
+                        <a:ea typeface="Calibri" charset="0"/>
+                        <a:cs typeface="Calibri" charset="0"/>
+                      </a:endParaRPr>
+                    </a:p>
+                  </a:txBody>
+                  <a:tcPr marL="76200" marR="76200" marT="38100" marB="38100" anchor="ctr">
+                    <a:lnL w="9525" cap="flat" cmpd="sng" algn="ctr">
+                      <a:solidFill>
+                        <a:srgbClr val="D7E1F5"/>
+                      </a:solidFill>
+                      <a:prstDash val="solid"/>
+                      <a:round/>
+                      <a:headEnd type="none" w="med" len="med"/>
+                      <a:tailEnd type="none" w="med" len="med"/>
+                    </a:lnL>
+                    <a:lnR w="9525" cap="flat" cmpd="sng" algn="ctr">
+                      <a:solidFill>
+                        <a:srgbClr val="D7E1F5"/>
+                      </a:solidFill>
+                      <a:prstDash val="solid"/>
+                      <a:round/>
+                      <a:headEnd type="none" w="med" len="med"/>
+                      <a:tailEnd type="none" w="med" len="med"/>
+                    </a:lnR>
+                    <a:lnT w="9525" cap="flat" cmpd="sng" algn="ctr">
+                      <a:solidFill>
+                        <a:srgbClr val="D7E1F5"/>
+                      </a:solidFill>
+                      <a:prstDash val="solid"/>
+                      <a:round/>
+                      <a:headEnd type="none" w="med" len="med"/>
+                      <a:tailEnd type="none" w="med" len="med"/>
+                    </a:lnT>
+                    <a:lnB w="9525" cap="flat" cmpd="sng" algn="ctr">
+                      <a:solidFill>
+                        <a:srgbClr val="D7E1F5"/>
+                      </a:solidFill>
+                      <a:prstDash val="solid"/>
+                      <a:round/>
+                      <a:headEnd type="none" w="med" len="med"/>
+                      <a:tailEnd type="none" w="med" len="med"/>
+                    </a:lnB>
+                    <a:solidFill>
+                      <a:srgbClr val="FFFFFF"/>
+                    </a:solidFill>
+                  </a:tcPr>
+                </a:tc>
+                <a:tc>
+                  <a:txBody>
+                    <a:bodyPr/>
+                    <a:lstStyle/>
+                    <a:p>
+                      <a:pPr algn="ctr" indent="0" marL="0">
+                        <a:buNone/>
+                      </a:pPr>
+                      <a:r>
+                        <a:rPr lang="en-US" sz="830" dirty="0">
+                          <a:solidFill>
+                            <a:srgbClr val="3A4566"/>
+                          </a:solidFill>
+                          <a:latin typeface="Calibri" pitchFamily="34" charset="0"/>
+                          <a:ea typeface="Calibri" pitchFamily="34" charset="-122"/>
+                          <a:cs typeface="Calibri" pitchFamily="34" charset="-120"/>
+                        </a:rPr>
+                        <a:t>Partnership — issues K-1</a:t>
+                      </a:r>
+                      <a:endParaRPr lang="en-US" sz="830" dirty="0">
+                        <a:latin typeface="Calibri" charset="0"/>
+                        <a:ea typeface="Calibri" charset="0"/>
+                        <a:cs typeface="Calibri" charset="0"/>
+                      </a:endParaRPr>
+                    </a:p>
+                  </a:txBody>
+                  <a:tcPr marL="76200" marR="76200" marT="38100" marB="38100" anchor="ctr">
+                    <a:lnL w="9525" cap="flat" cmpd="sng" algn="ctr">
+                      <a:solidFill>
+                        <a:srgbClr val="D7E1F5"/>
+                      </a:solidFill>
+                      <a:prstDash val="solid"/>
+                      <a:round/>
+                      <a:headEnd type="none" w="med" len="med"/>
+                      <a:tailEnd type="none" w="med" len="med"/>
+                    </a:lnL>
+                    <a:lnR w="9525" cap="flat" cmpd="sng" algn="ctr">
+                      <a:solidFill>
+                        <a:srgbClr val="D7E1F5"/>
+                      </a:solidFill>
+                      <a:prstDash val="solid"/>
+                      <a:round/>
+                      <a:headEnd type="none" w="med" len="med"/>
+                      <a:tailEnd type="none" w="med" len="med"/>
+                    </a:lnR>
+                    <a:lnT w="9525" cap="flat" cmpd="sng" algn="ctr">
+                      <a:solidFill>
+                        <a:srgbClr val="D7E1F5"/>
+                      </a:solidFill>
+                      <a:prstDash val="solid"/>
+                      <a:round/>
+                      <a:headEnd type="none" w="med" len="med"/>
+                      <a:tailEnd type="none" w="med" len="med"/>
+                    </a:lnT>
+                    <a:lnB w="9525" cap="flat" cmpd="sng" algn="ctr">
+                      <a:solidFill>
+                        <a:srgbClr val="D7E1F5"/>
+                      </a:solidFill>
+                      <a:prstDash val="solid"/>
+                      <a:round/>
+                      <a:headEnd type="none" w="med" len="med"/>
+                      <a:tailEnd type="none" w="med" len="med"/>
+                    </a:lnB>
+                    <a:solidFill>
+                      <a:srgbClr val="FFFFFF"/>
+                    </a:solidFill>
+                  </a:tcPr>
+                </a:tc>
+                <a:tc>
+                  <a:txBody>
+                    <a:bodyPr/>
+                    <a:lstStyle/>
+                    <a:p>
+                      <a:pPr algn="ctr" indent="0" marL="0">
+                        <a:buNone/>
+                      </a:pPr>
+                      <a:r>
+                        <a:rPr lang="en-US" sz="830" dirty="0">
+                          <a:solidFill>
+                            <a:srgbClr val="3A4566"/>
+                          </a:solidFill>
+                          <a:latin typeface="Calibri" pitchFamily="34" charset="0"/>
+                          <a:ea typeface="Calibri" pitchFamily="34" charset="-122"/>
+                          <a:cs typeface="Calibri" pitchFamily="34" charset="-120"/>
+                        </a:rPr>
+                        <a:t>Partnership (inferred) — K-1</a:t>
+                      </a:r>
+                      <a:endParaRPr lang="en-US" sz="830" dirty="0">
+                        <a:latin typeface="Calibri" charset="0"/>
+                        <a:ea typeface="Calibri" charset="0"/>
+                        <a:cs typeface="Calibri" charset="0"/>
+                      </a:endParaRPr>
+                    </a:p>
+                  </a:txBody>
+                  <a:tcPr marL="76200" marR="76200" marT="38100" marB="38100" anchor="ctr">
+                    <a:lnL w="9525" cap="flat" cmpd="sng" algn="ctr">
+                      <a:solidFill>
+                        <a:srgbClr val="D7E1F5"/>
+                      </a:solidFill>
+                      <a:prstDash val="solid"/>
+                      <a:round/>
+                      <a:headEnd type="none" w="med" len="med"/>
+                      <a:tailEnd type="none" w="med" len="med"/>
+                    </a:lnL>
+                    <a:lnR w="9525" cap="flat" cmpd="sng" algn="ctr">
+                      <a:solidFill>
+                        <a:srgbClr val="D7E1F5"/>
+                      </a:solidFill>
+                      <a:prstDash val="solid"/>
+                      <a:round/>
+                      <a:headEnd type="none" w="med" len="med"/>
+                      <a:tailEnd type="none" w="med" len="med"/>
+                    </a:lnR>
+                    <a:lnT w="9525" cap="flat" cmpd="sng" algn="ctr">
+                      <a:solidFill>
+                        <a:srgbClr val="D7E1F5"/>
+                      </a:solidFill>
+                      <a:prstDash val="solid"/>
+                      <a:round/>
+                      <a:headEnd type="none" w="med" len="med"/>
+                      <a:tailEnd type="none" w="med" len="med"/>
+                    </a:lnT>
+                    <a:lnB w="9525" cap="flat" cmpd="sng" algn="ctr">
+                      <a:solidFill>
+                        <a:srgbClr val="D7E1F5"/>
+                      </a:solidFill>
+                      <a:prstDash val="solid"/>
+                      <a:round/>
+                      <a:headEnd type="none" w="med" len="med"/>
+                      <a:tailEnd type="none" w="med" len="med"/>
+                    </a:lnB>
+                    <a:solidFill>
+                      <a:srgbClr val="FFFFFF"/>
+                    </a:solidFill>
+                  </a:tcPr>
+                </a:tc>
+                <a:tc>
+                  <a:txBody>
+                    <a:bodyPr/>
+                    <a:lstStyle/>
+                    <a:p>
+                      <a:pPr algn="ctr" indent="0" marL="0">
+                        <a:buNone/>
+                      </a:pPr>
+                      <a:r>
+                        <a:rPr lang="en-US" sz="830" dirty="0">
+                          <a:solidFill>
+                            <a:srgbClr val="3A4566"/>
+                          </a:solidFill>
+                          <a:latin typeface="Calibri" pitchFamily="34" charset="0"/>
+                          <a:ea typeface="Calibri" pitchFamily="34" charset="-122"/>
+                          <a:cs typeface="Calibri" pitchFamily="34" charset="-120"/>
+                        </a:rPr>
+                        <a:t>Likely RIC — 1099-DIV (unconfirmed)</a:t>
+                      </a:r>
+                      <a:endParaRPr lang="en-US" sz="830" dirty="0">
+                        <a:latin typeface="Calibri" charset="0"/>
+                        <a:ea typeface="Calibri" charset="0"/>
+                        <a:cs typeface="Calibri" charset="0"/>
+                      </a:endParaRPr>
+                    </a:p>
+                  </a:txBody>
+                  <a:tcPr marL="76200" marR="76200" marT="38100" marB="38100" anchor="ctr">
+                    <a:lnL w="9525" cap="flat" cmpd="sng" algn="ctr">
+                      <a:solidFill>
+                        <a:srgbClr val="D7E1F5"/>
+                      </a:solidFill>
+                      <a:prstDash val="solid"/>
+                      <a:round/>
+                      <a:headEnd type="none" w="med" len="med"/>
+                      <a:tailEnd type="none" w="med" len="med"/>
+                    </a:lnL>
+                    <a:lnR w="9525" cap="flat" cmpd="sng" algn="ctr">
+                      <a:solidFill>
+                        <a:srgbClr val="D7E1F5"/>
+                      </a:solidFill>
+                      <a:prstDash val="solid"/>
+                      <a:round/>
+                      <a:headEnd type="none" w="med" len="med"/>
+                      <a:tailEnd type="none" w="med" len="med"/>
+                    </a:lnR>
+                    <a:lnT w="9525" cap="flat" cmpd="sng" algn="ctr">
+                      <a:solidFill>
+                        <a:srgbClr val="D7E1F5"/>
+                      </a:solidFill>
+                      <a:prstDash val="solid"/>
+                      <a:round/>
+                      <a:headEnd type="none" w="med" len="med"/>
+                      <a:tailEnd type="none" w="med" len="med"/>
+                    </a:lnT>
+                    <a:lnB w="9525" cap="flat" cmpd="sng" algn="ctr">
+                      <a:solidFill>
+                        <a:srgbClr val="D7E1F5"/>
+                      </a:solidFill>
+                      <a:prstDash val="solid"/>
+                      <a:round/>
+                      <a:headEnd type="none" w="med" len="med"/>
+                      <a:tailEnd type="none" w="med" len="med"/>
+                    </a:lnB>
+                    <a:solidFill>
+                      <a:srgbClr val="FFFFFF"/>
+                    </a:solidFill>
+                  </a:tcPr>
+                </a:tc>
+              </a:tr>
+              <a:tr h="0">
+                <a:tc>
+                  <a:txBody>
+                    <a:bodyPr/>
+                    <a:lstStyle/>
+                    <a:p>
+                      <a:pPr algn="l" indent="0" marL="0">
+                        <a:buNone/>
+                      </a:pPr>
+                      <a:r>
+                        <a:rPr lang="en-US" sz="830" b="1" dirty="0">
+                          <a:solidFill>
+                            <a:srgbClr val="1E2761"/>
+                          </a:solidFill>
+                          <a:latin typeface="Calibri" pitchFamily="34" charset="0"/>
+                          <a:ea typeface="Calibri" pitchFamily="34" charset="-122"/>
+                          <a:cs typeface="Calibri" pitchFamily="34" charset="-120"/>
+                        </a:rPr>
                         <a:t>Eligible investors</a:t>
                       </a:r>
                       <a:endParaRPr lang="en-US" sz="830" dirty="0">
@@ -19020,7 +19498,7 @@
                       <a:tailEnd type="none" w="med" len="med"/>
                     </a:lnB>
                     <a:solidFill>
-                      <a:srgbClr val="FFFFFF"/>
+                      <a:srgbClr val="F5F8FD"/>
                     </a:solidFill>
                   </a:tcPr>
                 </a:tc>
@@ -19088,7 +19566,7 @@
                       <a:tailEnd type="none" w="med" len="med"/>
                     </a:lnB>
                     <a:solidFill>
-                      <a:srgbClr val="FFFFFF"/>
+                      <a:srgbClr val="F5F8FD"/>
                     </a:solidFill>
                   </a:tcPr>
                 </a:tc>
@@ -19156,7 +19634,7 @@
                       <a:tailEnd type="none" w="med" len="med"/>
                     </a:lnB>
                     <a:solidFill>
-                      <a:srgbClr val="FFFFFF"/>
+                      <a:srgbClr val="F5F8FD"/>
                     </a:solidFill>
                   </a:tcPr>
                 </a:tc>
@@ -19224,7 +19702,7 @@
                       <a:tailEnd type="none" w="med" len="med"/>
                     </a:lnB>
                     <a:solidFill>
-                      <a:srgbClr val="FFFFFF"/>
+                      <a:srgbClr val="F5F8FD"/>
                     </a:solidFill>
                   </a:tcPr>
                 </a:tc>
@@ -19292,7 +19770,7 @@
                       <a:tailEnd type="none" w="med" len="med"/>
                     </a:lnB>
                     <a:solidFill>
-                      <a:srgbClr val="FFFFFF"/>
+                      <a:srgbClr val="F5F8FD"/>
                     </a:solidFill>
                   </a:tcPr>
                 </a:tc>
@@ -19360,7 +19838,7 @@
                       <a:tailEnd type="none" w="med" len="med"/>
                     </a:lnB>
                     <a:solidFill>
-                      <a:srgbClr val="FFFFFF"/>
+                      <a:srgbClr val="F5F8FD"/>
                     </a:solidFill>
                   </a:tcPr>
                 </a:tc>
@@ -19428,7 +19906,7 @@
                       <a:tailEnd type="none" w="med" len="med"/>
                     </a:lnB>
                     <a:solidFill>
-                      <a:srgbClr val="FFFFFF"/>
+                      <a:srgbClr val="F5F8FD"/>
                     </a:solidFill>
                   </a:tcPr>
                 </a:tc>
@@ -19498,7 +19976,7 @@
                       <a:tailEnd type="none" w="med" len="med"/>
                     </a:lnB>
                     <a:solidFill>
-                      <a:srgbClr val="F5F8FD"/>
+                      <a:srgbClr val="FFFFFF"/>
                     </a:solidFill>
                   </a:tcPr>
                 </a:tc>
@@ -19566,7 +20044,7 @@
                       <a:tailEnd type="none" w="med" len="med"/>
                     </a:lnB>
                     <a:solidFill>
-                      <a:srgbClr val="F5F8FD"/>
+                      <a:srgbClr val="FFFFFF"/>
                     </a:solidFill>
                   </a:tcPr>
                 </a:tc>
@@ -19634,7 +20112,7 @@
                       <a:tailEnd type="none" w="med" len="med"/>
                     </a:lnB>
                     <a:solidFill>
-                      <a:srgbClr val="F5F8FD"/>
+                      <a:srgbClr val="FFFFFF"/>
                     </a:solidFill>
                   </a:tcPr>
                 </a:tc>
@@ -19702,7 +20180,7 @@
                       <a:tailEnd type="none" w="med" len="med"/>
                     </a:lnB>
                     <a:solidFill>
-                      <a:srgbClr val="F5F8FD"/>
+                      <a:srgbClr val="FFFFFF"/>
                     </a:solidFill>
                   </a:tcPr>
                 </a:tc>
@@ -19770,7 +20248,7 @@
                       <a:tailEnd type="none" w="med" len="med"/>
                     </a:lnB>
                     <a:solidFill>
-                      <a:srgbClr val="F5F8FD"/>
+                      <a:srgbClr val="FFFFFF"/>
                     </a:solidFill>
                   </a:tcPr>
                 </a:tc>
@@ -19838,7 +20316,7 @@
                       <a:tailEnd type="none" w="med" len="med"/>
                     </a:lnB>
                     <a:solidFill>
-                      <a:srgbClr val="F5F8FD"/>
+                      <a:srgbClr val="FFFFFF"/>
                     </a:solidFill>
                   </a:tcPr>
                 </a:tc>
@@ -19906,7 +20384,7 @@
                       <a:tailEnd type="none" w="med" len="med"/>
                     </a:lnB>
                     <a:solidFill>
-                      <a:srgbClr val="F5F8FD"/>
+                      <a:srgbClr val="FFFFFF"/>
                     </a:solidFill>
                   </a:tcPr>
                 </a:tc>
@@ -19976,7 +20454,7 @@
                       <a:tailEnd type="none" w="med" len="med"/>
                     </a:lnB>
                     <a:solidFill>
-                      <a:srgbClr val="FFFFFF"/>
+                      <a:srgbClr val="F5F8FD"/>
                     </a:solidFill>
                   </a:tcPr>
                 </a:tc>
@@ -20044,7 +20522,7 @@
                       <a:tailEnd type="none" w="med" len="med"/>
                     </a:lnB>
                     <a:solidFill>
-                      <a:srgbClr val="FFFFFF"/>
+                      <a:srgbClr val="F5F8FD"/>
                     </a:solidFill>
                   </a:tcPr>
                 </a:tc>
@@ -20112,7 +20590,7 @@
                       <a:tailEnd type="none" w="med" len="med"/>
                     </a:lnB>
                     <a:solidFill>
-                      <a:srgbClr val="FFFFFF"/>
+                      <a:srgbClr val="F5F8FD"/>
                     </a:solidFill>
                   </a:tcPr>
                 </a:tc>
@@ -20180,7 +20658,7 @@
                       <a:tailEnd type="none" w="med" len="med"/>
                     </a:lnB>
                     <a:solidFill>
-                      <a:srgbClr val="FFFFFF"/>
+                      <a:srgbClr val="F5F8FD"/>
                     </a:solidFill>
                   </a:tcPr>
                 </a:tc>
@@ -20248,7 +20726,7 @@
                       <a:tailEnd type="none" w="med" len="med"/>
                     </a:lnB>
                     <a:solidFill>
-                      <a:srgbClr val="FFFFFF"/>
+                      <a:srgbClr val="F5F8FD"/>
                     </a:solidFill>
                   </a:tcPr>
                 </a:tc>
@@ -20316,7 +20794,7 @@
                       <a:tailEnd type="none" w="med" len="med"/>
                     </a:lnB>
                     <a:solidFill>
-                      <a:srgbClr val="FFFFFF"/>
+                      <a:srgbClr val="F5F8FD"/>
                     </a:solidFill>
                   </a:tcPr>
                 </a:tc>
@@ -20384,7 +20862,7 @@
                       <a:tailEnd type="none" w="med" len="med"/>
                     </a:lnB>
                     <a:solidFill>
-                      <a:srgbClr val="FFFFFF"/>
+                      <a:srgbClr val="F5F8FD"/>
                     </a:solidFill>
                   </a:tcPr>
                 </a:tc>
@@ -20454,6 +20932,484 @@
                       <a:tailEnd type="none" w="med" len="med"/>
                     </a:lnB>
                     <a:solidFill>
+                      <a:srgbClr val="FFFFFF"/>
+                    </a:solidFill>
+                  </a:tcPr>
+                </a:tc>
+                <a:tc>
+                  <a:txBody>
+                    <a:bodyPr/>
+                    <a:lstStyle/>
+                    <a:p>
+                      <a:pPr algn="ctr" indent="0" marL="0">
+                        <a:buNone/>
+                      </a:pPr>
+                      <a:r>
+                        <a:rPr lang="en-US" sz="830" dirty="0">
+                          <a:solidFill>
+                            <a:srgbClr val="3A4566"/>
+                          </a:solidFill>
+                          <a:latin typeface="Calibri" pitchFamily="34" charset="0"/>
+                          <a:ea typeface="Calibri" pitchFamily="34" charset="-122"/>
+                          <a:cs typeface="Calibri" pitchFamily="34" charset="-120"/>
+                        </a:rPr>
+                        <a:t>FT Services/JPMorgan</a:t>
+                      </a:r>
+                      <a:endParaRPr lang="en-US" sz="830" dirty="0">
+                        <a:latin typeface="Calibri" charset="0"/>
+                        <a:ea typeface="Calibri" charset="0"/>
+                        <a:cs typeface="Calibri" charset="0"/>
+                      </a:endParaRPr>
+                    </a:p>
+                  </a:txBody>
+                  <a:tcPr marL="76200" marR="76200" marT="38100" marB="38100" anchor="ctr">
+                    <a:lnL w="9525" cap="flat" cmpd="sng" algn="ctr">
+                      <a:solidFill>
+                        <a:srgbClr val="D7E1F5"/>
+                      </a:solidFill>
+                      <a:prstDash val="solid"/>
+                      <a:round/>
+                      <a:headEnd type="none" w="med" len="med"/>
+                      <a:tailEnd type="none" w="med" len="med"/>
+                    </a:lnL>
+                    <a:lnR w="9525" cap="flat" cmpd="sng" algn="ctr">
+                      <a:solidFill>
+                        <a:srgbClr val="D7E1F5"/>
+                      </a:solidFill>
+                      <a:prstDash val="solid"/>
+                      <a:round/>
+                      <a:headEnd type="none" w="med" len="med"/>
+                      <a:tailEnd type="none" w="med" len="med"/>
+                    </a:lnR>
+                    <a:lnT w="9525" cap="flat" cmpd="sng" algn="ctr">
+                      <a:solidFill>
+                        <a:srgbClr val="D7E1F5"/>
+                      </a:solidFill>
+                      <a:prstDash val="solid"/>
+                      <a:round/>
+                      <a:headEnd type="none" w="med" len="med"/>
+                      <a:tailEnd type="none" w="med" len="med"/>
+                    </a:lnT>
+                    <a:lnB w="9525" cap="flat" cmpd="sng" algn="ctr">
+                      <a:solidFill>
+                        <a:srgbClr val="D7E1F5"/>
+                      </a:solidFill>
+                      <a:prstDash val="solid"/>
+                      <a:round/>
+                      <a:headEnd type="none" w="med" len="med"/>
+                      <a:tailEnd type="none" w="med" len="med"/>
+                    </a:lnB>
+                    <a:solidFill>
+                      <a:srgbClr val="FFFFFF"/>
+                    </a:solidFill>
+                  </a:tcPr>
+                </a:tc>
+                <a:tc>
+                  <a:txBody>
+                    <a:bodyPr/>
+                    <a:lstStyle/>
+                    <a:p>
+                      <a:pPr algn="ctr" indent="0" marL="0">
+                        <a:buNone/>
+                      </a:pPr>
+                      <a:r>
+                        <a:rPr lang="en-US" sz="830" dirty="0">
+                          <a:solidFill>
+                            <a:srgbClr val="3A4566"/>
+                          </a:solidFill>
+                          <a:latin typeface="Calibri" pitchFamily="34" charset="0"/>
+                          <a:ea typeface="Calibri" pitchFamily="34" charset="-122"/>
+                          <a:cs typeface="Calibri" pitchFamily="34" charset="-120"/>
+                        </a:rPr>
+                        <a:t>BNY Mellon</a:t>
+                      </a:r>
+                      <a:endParaRPr lang="en-US" sz="830" dirty="0">
+                        <a:latin typeface="Calibri" charset="0"/>
+                        <a:ea typeface="Calibri" charset="0"/>
+                        <a:cs typeface="Calibri" charset="0"/>
+                      </a:endParaRPr>
+                    </a:p>
+                  </a:txBody>
+                  <a:tcPr marL="76200" marR="76200" marT="38100" marB="38100" anchor="ctr">
+                    <a:lnL w="9525" cap="flat" cmpd="sng" algn="ctr">
+                      <a:solidFill>
+                        <a:srgbClr val="D7E1F5"/>
+                      </a:solidFill>
+                      <a:prstDash val="solid"/>
+                      <a:round/>
+                      <a:headEnd type="none" w="med" len="med"/>
+                      <a:tailEnd type="none" w="med" len="med"/>
+                    </a:lnL>
+                    <a:lnR w="9525" cap="flat" cmpd="sng" algn="ctr">
+                      <a:solidFill>
+                        <a:srgbClr val="D7E1F5"/>
+                      </a:solidFill>
+                      <a:prstDash val="solid"/>
+                      <a:round/>
+                      <a:headEnd type="none" w="med" len="med"/>
+                      <a:tailEnd type="none" w="med" len="med"/>
+                    </a:lnR>
+                    <a:lnT w="9525" cap="flat" cmpd="sng" algn="ctr">
+                      <a:solidFill>
+                        <a:srgbClr val="D7E1F5"/>
+                      </a:solidFill>
+                      <a:prstDash val="solid"/>
+                      <a:round/>
+                      <a:headEnd type="none" w="med" len="med"/>
+                      <a:tailEnd type="none" w="med" len="med"/>
+                    </a:lnT>
+                    <a:lnB w="9525" cap="flat" cmpd="sng" algn="ctr">
+                      <a:solidFill>
+                        <a:srgbClr val="D7E1F5"/>
+                      </a:solidFill>
+                      <a:prstDash val="solid"/>
+                      <a:round/>
+                      <a:headEnd type="none" w="med" len="med"/>
+                      <a:tailEnd type="none" w="med" len="med"/>
+                    </a:lnB>
+                    <a:solidFill>
+                      <a:srgbClr val="FFFFFF"/>
+                    </a:solidFill>
+                  </a:tcPr>
+                </a:tc>
+                <a:tc>
+                  <a:txBody>
+                    <a:bodyPr/>
+                    <a:lstStyle/>
+                    <a:p>
+                      <a:pPr algn="ctr" indent="0" marL="0">
+                        <a:buNone/>
+                      </a:pPr>
+                      <a:r>
+                        <a:rPr lang="en-US" sz="830" dirty="0">
+                          <a:solidFill>
+                            <a:srgbClr val="3A4566"/>
+                          </a:solidFill>
+                          <a:latin typeface="Calibri" pitchFamily="34" charset="0"/>
+                          <a:ea typeface="Calibri" pitchFamily="34" charset="-122"/>
+                          <a:cs typeface="Calibri" pitchFamily="34" charset="-120"/>
+                        </a:rPr>
+                        <a:t>Not confirmed</a:t>
+                      </a:r>
+                      <a:endParaRPr lang="en-US" sz="830" dirty="0">
+                        <a:latin typeface="Calibri" charset="0"/>
+                        <a:ea typeface="Calibri" charset="0"/>
+                        <a:cs typeface="Calibri" charset="0"/>
+                      </a:endParaRPr>
+                    </a:p>
+                  </a:txBody>
+                  <a:tcPr marL="76200" marR="76200" marT="38100" marB="38100" anchor="ctr">
+                    <a:lnL w="9525" cap="flat" cmpd="sng" algn="ctr">
+                      <a:solidFill>
+                        <a:srgbClr val="D7E1F5"/>
+                      </a:solidFill>
+                      <a:prstDash val="solid"/>
+                      <a:round/>
+                      <a:headEnd type="none" w="med" len="med"/>
+                      <a:tailEnd type="none" w="med" len="med"/>
+                    </a:lnL>
+                    <a:lnR w="9525" cap="flat" cmpd="sng" algn="ctr">
+                      <a:solidFill>
+                        <a:srgbClr val="D7E1F5"/>
+                      </a:solidFill>
+                      <a:prstDash val="solid"/>
+                      <a:round/>
+                      <a:headEnd type="none" w="med" len="med"/>
+                      <a:tailEnd type="none" w="med" len="med"/>
+                    </a:lnR>
+                    <a:lnT w="9525" cap="flat" cmpd="sng" algn="ctr">
+                      <a:solidFill>
+                        <a:srgbClr val="D7E1F5"/>
+                      </a:solidFill>
+                      <a:prstDash val="solid"/>
+                      <a:round/>
+                      <a:headEnd type="none" w="med" len="med"/>
+                      <a:tailEnd type="none" w="med" len="med"/>
+                    </a:lnT>
+                    <a:lnB w="9525" cap="flat" cmpd="sng" algn="ctr">
+                      <a:solidFill>
+                        <a:srgbClr val="D7E1F5"/>
+                      </a:solidFill>
+                      <a:prstDash val="solid"/>
+                      <a:round/>
+                      <a:headEnd type="none" w="med" len="med"/>
+                      <a:tailEnd type="none" w="med" len="med"/>
+                    </a:lnB>
+                    <a:solidFill>
+                      <a:srgbClr val="FFFFFF"/>
+                    </a:solidFill>
+                  </a:tcPr>
+                </a:tc>
+                <a:tc>
+                  <a:txBody>
+                    <a:bodyPr/>
+                    <a:lstStyle/>
+                    <a:p>
+                      <a:pPr algn="ctr" indent="0" marL="0">
+                        <a:buNone/>
+                      </a:pPr>
+                      <a:r>
+                        <a:rPr lang="en-US" sz="830" dirty="0">
+                          <a:solidFill>
+                            <a:srgbClr val="3A4566"/>
+                          </a:solidFill>
+                          <a:latin typeface="Calibri" pitchFamily="34" charset="0"/>
+                          <a:ea typeface="Calibri" pitchFamily="34" charset="-122"/>
+                          <a:cs typeface="Calibri" pitchFamily="34" charset="-120"/>
+                        </a:rPr>
+                        <a:t>Not confirmed</a:t>
+                      </a:r>
+                      <a:endParaRPr lang="en-US" sz="830" dirty="0">
+                        <a:latin typeface="Calibri" charset="0"/>
+                        <a:ea typeface="Calibri" charset="0"/>
+                        <a:cs typeface="Calibri" charset="0"/>
+                      </a:endParaRPr>
+                    </a:p>
+                  </a:txBody>
+                  <a:tcPr marL="76200" marR="76200" marT="38100" marB="38100" anchor="ctr">
+                    <a:lnL w="9525" cap="flat" cmpd="sng" algn="ctr">
+                      <a:solidFill>
+                        <a:srgbClr val="D7E1F5"/>
+                      </a:solidFill>
+                      <a:prstDash val="solid"/>
+                      <a:round/>
+                      <a:headEnd type="none" w="med" len="med"/>
+                      <a:tailEnd type="none" w="med" len="med"/>
+                    </a:lnL>
+                    <a:lnR w="9525" cap="flat" cmpd="sng" algn="ctr">
+                      <a:solidFill>
+                        <a:srgbClr val="D7E1F5"/>
+                      </a:solidFill>
+                      <a:prstDash val="solid"/>
+                      <a:round/>
+                      <a:headEnd type="none" w="med" len="med"/>
+                      <a:tailEnd type="none" w="med" len="med"/>
+                    </a:lnR>
+                    <a:lnT w="9525" cap="flat" cmpd="sng" algn="ctr">
+                      <a:solidFill>
+                        <a:srgbClr val="D7E1F5"/>
+                      </a:solidFill>
+                      <a:prstDash val="solid"/>
+                      <a:round/>
+                      <a:headEnd type="none" w="med" len="med"/>
+                      <a:tailEnd type="none" w="med" len="med"/>
+                    </a:lnT>
+                    <a:lnB w="9525" cap="flat" cmpd="sng" algn="ctr">
+                      <a:solidFill>
+                        <a:srgbClr val="D7E1F5"/>
+                      </a:solidFill>
+                      <a:prstDash val="solid"/>
+                      <a:round/>
+                      <a:headEnd type="none" w="med" len="med"/>
+                      <a:tailEnd type="none" w="med" len="med"/>
+                    </a:lnB>
+                    <a:solidFill>
+                      <a:srgbClr val="FFFFFF"/>
+                    </a:solidFill>
+                  </a:tcPr>
+                </a:tc>
+                <a:tc>
+                  <a:txBody>
+                    <a:bodyPr/>
+                    <a:lstStyle/>
+                    <a:p>
+                      <a:pPr algn="ctr" indent="0" marL="0">
+                        <a:buNone/>
+                      </a:pPr>
+                      <a:r>
+                        <a:rPr lang="en-US" sz="830" dirty="0">
+                          <a:solidFill>
+                            <a:srgbClr val="3A4566"/>
+                          </a:solidFill>
+                          <a:latin typeface="Calibri" pitchFamily="34" charset="0"/>
+                          <a:ea typeface="Calibri" pitchFamily="34" charset="-122"/>
+                          <a:cs typeface="Calibri" pitchFamily="34" charset="-120"/>
+                        </a:rPr>
+                        <a:t>NAV Consulting</a:t>
+                      </a:r>
+                      <a:endParaRPr lang="en-US" sz="830" dirty="0">
+                        <a:latin typeface="Calibri" charset="0"/>
+                        <a:ea typeface="Calibri" charset="0"/>
+                        <a:cs typeface="Calibri" charset="0"/>
+                      </a:endParaRPr>
+                    </a:p>
+                  </a:txBody>
+                  <a:tcPr marL="76200" marR="76200" marT="38100" marB="38100" anchor="ctr">
+                    <a:lnL w="9525" cap="flat" cmpd="sng" algn="ctr">
+                      <a:solidFill>
+                        <a:srgbClr val="D7E1F5"/>
+                      </a:solidFill>
+                      <a:prstDash val="solid"/>
+                      <a:round/>
+                      <a:headEnd type="none" w="med" len="med"/>
+                      <a:tailEnd type="none" w="med" len="med"/>
+                    </a:lnL>
+                    <a:lnR w="9525" cap="flat" cmpd="sng" algn="ctr">
+                      <a:solidFill>
+                        <a:srgbClr val="D7E1F5"/>
+                      </a:solidFill>
+                      <a:prstDash val="solid"/>
+                      <a:round/>
+                      <a:headEnd type="none" w="med" len="med"/>
+                      <a:tailEnd type="none" w="med" len="med"/>
+                    </a:lnR>
+                    <a:lnT w="9525" cap="flat" cmpd="sng" algn="ctr">
+                      <a:solidFill>
+                        <a:srgbClr val="D7E1F5"/>
+                      </a:solidFill>
+                      <a:prstDash val="solid"/>
+                      <a:round/>
+                      <a:headEnd type="none" w="med" len="med"/>
+                      <a:tailEnd type="none" w="med" len="med"/>
+                    </a:lnT>
+                    <a:lnB w="9525" cap="flat" cmpd="sng" algn="ctr">
+                      <a:solidFill>
+                        <a:srgbClr val="D7E1F5"/>
+                      </a:solidFill>
+                      <a:prstDash val="solid"/>
+                      <a:round/>
+                      <a:headEnd type="none" w="med" len="med"/>
+                      <a:tailEnd type="none" w="med" len="med"/>
+                    </a:lnB>
+                    <a:solidFill>
+                      <a:srgbClr val="FFFFFF"/>
+                    </a:solidFill>
+                  </a:tcPr>
+                </a:tc>
+                <a:tc>
+                  <a:txBody>
+                    <a:bodyPr/>
+                    <a:lstStyle/>
+                    <a:p>
+                      <a:pPr algn="ctr" indent="0" marL="0">
+                        <a:buNone/>
+                      </a:pPr>
+                      <a:r>
+                        <a:rPr lang="en-US" sz="830" dirty="0">
+                          <a:solidFill>
+                            <a:srgbClr val="3A4566"/>
+                          </a:solidFill>
+                          <a:latin typeface="Calibri" pitchFamily="34" charset="0"/>
+                          <a:ea typeface="Calibri" pitchFamily="34" charset="-122"/>
+                          <a:cs typeface="Calibri" pitchFamily="34" charset="-120"/>
+                        </a:rPr>
+                        <a:t>Not confirmed</a:t>
+                      </a:r>
+                      <a:endParaRPr lang="en-US" sz="830" dirty="0">
+                        <a:latin typeface="Calibri" charset="0"/>
+                        <a:ea typeface="Calibri" charset="0"/>
+                        <a:cs typeface="Calibri" charset="0"/>
+                      </a:endParaRPr>
+                    </a:p>
+                  </a:txBody>
+                  <a:tcPr marL="76200" marR="76200" marT="38100" marB="38100" anchor="ctr">
+                    <a:lnL w="9525" cap="flat" cmpd="sng" algn="ctr">
+                      <a:solidFill>
+                        <a:srgbClr val="D7E1F5"/>
+                      </a:solidFill>
+                      <a:prstDash val="solid"/>
+                      <a:round/>
+                      <a:headEnd type="none" w="med" len="med"/>
+                      <a:tailEnd type="none" w="med" len="med"/>
+                    </a:lnL>
+                    <a:lnR w="9525" cap="flat" cmpd="sng" algn="ctr">
+                      <a:solidFill>
+                        <a:srgbClr val="D7E1F5"/>
+                      </a:solidFill>
+                      <a:prstDash val="solid"/>
+                      <a:round/>
+                      <a:headEnd type="none" w="med" len="med"/>
+                      <a:tailEnd type="none" w="med" len="med"/>
+                    </a:lnR>
+                    <a:lnT w="9525" cap="flat" cmpd="sng" algn="ctr">
+                      <a:solidFill>
+                        <a:srgbClr val="D7E1F5"/>
+                      </a:solidFill>
+                      <a:prstDash val="solid"/>
+                      <a:round/>
+                      <a:headEnd type="none" w="med" len="med"/>
+                      <a:tailEnd type="none" w="med" len="med"/>
+                    </a:lnT>
+                    <a:lnB w="9525" cap="flat" cmpd="sng" algn="ctr">
+                      <a:solidFill>
+                        <a:srgbClr val="D7E1F5"/>
+                      </a:solidFill>
+                      <a:prstDash val="solid"/>
+                      <a:round/>
+                      <a:headEnd type="none" w="med" len="med"/>
+                      <a:tailEnd type="none" w="med" len="med"/>
+                    </a:lnB>
+                    <a:solidFill>
+                      <a:srgbClr val="FFFFFF"/>
+                    </a:solidFill>
+                  </a:tcPr>
+                </a:tc>
+              </a:tr>
+              <a:tr h="0">
+                <a:tc>
+                  <a:txBody>
+                    <a:bodyPr/>
+                    <a:lstStyle/>
+                    <a:p>
+                      <a:pPr algn="l" indent="0" marL="0">
+                        <a:buNone/>
+                      </a:pPr>
+                      <a:r>
+                        <a:rPr lang="en-US" sz="830" b="1" dirty="0">
+                          <a:solidFill>
+                            <a:srgbClr val="1E2761"/>
+                          </a:solidFill>
+                          <a:latin typeface="Calibri" pitchFamily="34" charset="0"/>
+                          <a:ea typeface="Calibri" pitchFamily="34" charset="-122"/>
+                          <a:cs typeface="Calibri" pitchFamily="34" charset="-120"/>
+                        </a:rPr>
+                        <a:t>Custodian</a:t>
+                      </a:r>
+                      <a:endParaRPr lang="en-US" sz="830" dirty="0">
+                        <a:latin typeface="Calibri" charset="0"/>
+                        <a:ea typeface="Calibri" charset="0"/>
+                        <a:cs typeface="Calibri" charset="0"/>
+                      </a:endParaRPr>
+                    </a:p>
+                  </a:txBody>
+                  <a:tcPr marL="76200" marR="76200" marT="38100" marB="38100" anchor="ctr">
+                    <a:lnL w="9525" cap="flat" cmpd="sng" algn="ctr">
+                      <a:solidFill>
+                        <a:srgbClr val="D7E1F5"/>
+                      </a:solidFill>
+                      <a:prstDash val="solid"/>
+                      <a:round/>
+                      <a:headEnd type="none" w="med" len="med"/>
+                      <a:tailEnd type="none" w="med" len="med"/>
+                    </a:lnL>
+                    <a:lnR w="9525" cap="flat" cmpd="sng" algn="ctr">
+                      <a:solidFill>
+                        <a:srgbClr val="D7E1F5"/>
+                      </a:solidFill>
+                      <a:prstDash val="solid"/>
+                      <a:round/>
+                      <a:headEnd type="none" w="med" len="med"/>
+                      <a:tailEnd type="none" w="med" len="med"/>
+                    </a:lnR>
+                    <a:lnT w="9525" cap="flat" cmpd="sng" algn="ctr">
+                      <a:solidFill>
+                        <a:srgbClr val="D7E1F5"/>
+                      </a:solidFill>
+                      <a:prstDash val="solid"/>
+                      <a:round/>
+                      <a:headEnd type="none" w="med" len="med"/>
+                      <a:tailEnd type="none" w="med" len="med"/>
+                    </a:lnT>
+                    <a:lnB w="9525" cap="flat" cmpd="sng" algn="ctr">
+                      <a:solidFill>
+                        <a:srgbClr val="D7E1F5"/>
+                      </a:solidFill>
+                      <a:prstDash val="solid"/>
+                      <a:round/>
+                      <a:headEnd type="none" w="med" len="med"/>
+                      <a:tailEnd type="none" w="med" len="med"/>
+                    </a:lnB>
+                    <a:solidFill>
                       <a:srgbClr val="F5F8FD"/>
                     </a:solidFill>
                   </a:tcPr>
@@ -20475,7 +21431,7 @@
                           <a:ea typeface="Calibri" pitchFamily="34" charset="-122"/>
                           <a:cs typeface="Calibri" pitchFamily="34" charset="-120"/>
                         </a:rPr>
-                        <a:t>FT Services/JPMorgan</a:t>
+                        <a:t>JPMorgan Chase</a:t>
                       </a:r>
                       <a:endParaRPr lang="en-US" sz="830" dirty="0">
                         <a:latin typeface="Calibri" charset="0"/>
@@ -20747,7 +21703,7 @@
                           <a:ea typeface="Calibri" pitchFamily="34" charset="-122"/>
                           <a:cs typeface="Calibri" pitchFamily="34" charset="-120"/>
                         </a:rPr>
-                        <a:t>NAV Consulting</a:t>
+                        <a:t>Not confirmed</a:t>
                       </a:r>
                       <a:endParaRPr lang="en-US" sz="830" dirty="0">
                         <a:latin typeface="Calibri" charset="0"/>
@@ -20885,7 +21841,7 @@
                           <a:ea typeface="Calibri" pitchFamily="34" charset="-122"/>
                           <a:cs typeface="Calibri" pitchFamily="34" charset="-120"/>
                         </a:rPr>
-                        <a:t>Custodian</a:t>
+                        <a:t>Auditor</a:t>
                       </a:r>
                       <a:endParaRPr lang="en-US" sz="830" dirty="0">
                         <a:latin typeface="Calibri" charset="0"/>
@@ -20953,7 +21909,7 @@
                           <a:ea typeface="Calibri" pitchFamily="34" charset="-122"/>
                           <a:cs typeface="Calibri" pitchFamily="34" charset="-120"/>
                         </a:rPr>
-                        <a:t>JPMorgan Chase</a:t>
+                        <a:t>PwC</a:t>
                       </a:r>
                       <a:endParaRPr lang="en-US" sz="830" dirty="0">
                         <a:latin typeface="Calibri" charset="0"/>
@@ -21021,7 +21977,7 @@
                           <a:ea typeface="Calibri" pitchFamily="34" charset="-122"/>
                           <a:cs typeface="Calibri" pitchFamily="34" charset="-120"/>
                         </a:rPr>
-                        <a:t>BNY Mellon</a:t>
+                        <a:t>PwC</a:t>
                       </a:r>
                       <a:endParaRPr lang="en-US" sz="830" dirty="0">
                         <a:latin typeface="Calibri" charset="0"/>
@@ -21157,7 +22113,7 @@
                           <a:ea typeface="Calibri" pitchFamily="34" charset="-122"/>
                           <a:cs typeface="Calibri" pitchFamily="34" charset="-120"/>
                         </a:rPr>
-                        <a:t>Not confirmed</a:t>
+                        <a:t>EY (secondary)</a:t>
                       </a:r>
                       <a:endParaRPr lang="en-US" sz="830" dirty="0">
                         <a:latin typeface="Calibri" charset="0"/>
@@ -21363,484 +22319,6 @@
                           <a:ea typeface="Calibri" pitchFamily="34" charset="-122"/>
                           <a:cs typeface="Calibri" pitchFamily="34" charset="-120"/>
                         </a:rPr>
-                        <a:t>Auditor</a:t>
-                      </a:r>
-                      <a:endParaRPr lang="en-US" sz="830" dirty="0">
-                        <a:latin typeface="Calibri" charset="0"/>
-                        <a:ea typeface="Calibri" charset="0"/>
-                        <a:cs typeface="Calibri" charset="0"/>
-                      </a:endParaRPr>
-                    </a:p>
-                  </a:txBody>
-                  <a:tcPr marL="76200" marR="76200" marT="38100" marB="38100" anchor="ctr">
-                    <a:lnL w="9525" cap="flat" cmpd="sng" algn="ctr">
-                      <a:solidFill>
-                        <a:srgbClr val="D7E1F5"/>
-                      </a:solidFill>
-                      <a:prstDash val="solid"/>
-                      <a:round/>
-                      <a:headEnd type="none" w="med" len="med"/>
-                      <a:tailEnd type="none" w="med" len="med"/>
-                    </a:lnL>
-                    <a:lnR w="9525" cap="flat" cmpd="sng" algn="ctr">
-                      <a:solidFill>
-                        <a:srgbClr val="D7E1F5"/>
-                      </a:solidFill>
-                      <a:prstDash val="solid"/>
-                      <a:round/>
-                      <a:headEnd type="none" w="med" len="med"/>
-                      <a:tailEnd type="none" w="med" len="med"/>
-                    </a:lnR>
-                    <a:lnT w="9525" cap="flat" cmpd="sng" algn="ctr">
-                      <a:solidFill>
-                        <a:srgbClr val="D7E1F5"/>
-                      </a:solidFill>
-                      <a:prstDash val="solid"/>
-                      <a:round/>
-                      <a:headEnd type="none" w="med" len="med"/>
-                      <a:tailEnd type="none" w="med" len="med"/>
-                    </a:lnT>
-                    <a:lnB w="9525" cap="flat" cmpd="sng" algn="ctr">
-                      <a:solidFill>
-                        <a:srgbClr val="D7E1F5"/>
-                      </a:solidFill>
-                      <a:prstDash val="solid"/>
-                      <a:round/>
-                      <a:headEnd type="none" w="med" len="med"/>
-                      <a:tailEnd type="none" w="med" len="med"/>
-                    </a:lnB>
-                    <a:solidFill>
-                      <a:srgbClr val="F5F8FD"/>
-                    </a:solidFill>
-                  </a:tcPr>
-                </a:tc>
-                <a:tc>
-                  <a:txBody>
-                    <a:bodyPr/>
-                    <a:lstStyle/>
-                    <a:p>
-                      <a:pPr algn="ctr" indent="0" marL="0">
-                        <a:buNone/>
-                      </a:pPr>
-                      <a:r>
-                        <a:rPr lang="en-US" sz="830" dirty="0">
-                          <a:solidFill>
-                            <a:srgbClr val="3A4566"/>
-                          </a:solidFill>
-                          <a:latin typeface="Calibri" pitchFamily="34" charset="0"/>
-                          <a:ea typeface="Calibri" pitchFamily="34" charset="-122"/>
-                          <a:cs typeface="Calibri" pitchFamily="34" charset="-120"/>
-                        </a:rPr>
-                        <a:t>PwC</a:t>
-                      </a:r>
-                      <a:endParaRPr lang="en-US" sz="830" dirty="0">
-                        <a:latin typeface="Calibri" charset="0"/>
-                        <a:ea typeface="Calibri" charset="0"/>
-                        <a:cs typeface="Calibri" charset="0"/>
-                      </a:endParaRPr>
-                    </a:p>
-                  </a:txBody>
-                  <a:tcPr marL="76200" marR="76200" marT="38100" marB="38100" anchor="ctr">
-                    <a:lnL w="9525" cap="flat" cmpd="sng" algn="ctr">
-                      <a:solidFill>
-                        <a:srgbClr val="D7E1F5"/>
-                      </a:solidFill>
-                      <a:prstDash val="solid"/>
-                      <a:round/>
-                      <a:headEnd type="none" w="med" len="med"/>
-                      <a:tailEnd type="none" w="med" len="med"/>
-                    </a:lnL>
-                    <a:lnR w="9525" cap="flat" cmpd="sng" algn="ctr">
-                      <a:solidFill>
-                        <a:srgbClr val="D7E1F5"/>
-                      </a:solidFill>
-                      <a:prstDash val="solid"/>
-                      <a:round/>
-                      <a:headEnd type="none" w="med" len="med"/>
-                      <a:tailEnd type="none" w="med" len="med"/>
-                    </a:lnR>
-                    <a:lnT w="9525" cap="flat" cmpd="sng" algn="ctr">
-                      <a:solidFill>
-                        <a:srgbClr val="D7E1F5"/>
-                      </a:solidFill>
-                      <a:prstDash val="solid"/>
-                      <a:round/>
-                      <a:headEnd type="none" w="med" len="med"/>
-                      <a:tailEnd type="none" w="med" len="med"/>
-                    </a:lnT>
-                    <a:lnB w="9525" cap="flat" cmpd="sng" algn="ctr">
-                      <a:solidFill>
-                        <a:srgbClr val="D7E1F5"/>
-                      </a:solidFill>
-                      <a:prstDash val="solid"/>
-                      <a:round/>
-                      <a:headEnd type="none" w="med" len="med"/>
-                      <a:tailEnd type="none" w="med" len="med"/>
-                    </a:lnB>
-                    <a:solidFill>
-                      <a:srgbClr val="F5F8FD"/>
-                    </a:solidFill>
-                  </a:tcPr>
-                </a:tc>
-                <a:tc>
-                  <a:txBody>
-                    <a:bodyPr/>
-                    <a:lstStyle/>
-                    <a:p>
-                      <a:pPr algn="ctr" indent="0" marL="0">
-                        <a:buNone/>
-                      </a:pPr>
-                      <a:r>
-                        <a:rPr lang="en-US" sz="830" dirty="0">
-                          <a:solidFill>
-                            <a:srgbClr val="3A4566"/>
-                          </a:solidFill>
-                          <a:latin typeface="Calibri" pitchFamily="34" charset="0"/>
-                          <a:ea typeface="Calibri" pitchFamily="34" charset="-122"/>
-                          <a:cs typeface="Calibri" pitchFamily="34" charset="-120"/>
-                        </a:rPr>
-                        <a:t>PwC</a:t>
-                      </a:r>
-                      <a:endParaRPr lang="en-US" sz="830" dirty="0">
-                        <a:latin typeface="Calibri" charset="0"/>
-                        <a:ea typeface="Calibri" charset="0"/>
-                        <a:cs typeface="Calibri" charset="0"/>
-                      </a:endParaRPr>
-                    </a:p>
-                  </a:txBody>
-                  <a:tcPr marL="76200" marR="76200" marT="38100" marB="38100" anchor="ctr">
-                    <a:lnL w="9525" cap="flat" cmpd="sng" algn="ctr">
-                      <a:solidFill>
-                        <a:srgbClr val="D7E1F5"/>
-                      </a:solidFill>
-                      <a:prstDash val="solid"/>
-                      <a:round/>
-                      <a:headEnd type="none" w="med" len="med"/>
-                      <a:tailEnd type="none" w="med" len="med"/>
-                    </a:lnL>
-                    <a:lnR w="9525" cap="flat" cmpd="sng" algn="ctr">
-                      <a:solidFill>
-                        <a:srgbClr val="D7E1F5"/>
-                      </a:solidFill>
-                      <a:prstDash val="solid"/>
-                      <a:round/>
-                      <a:headEnd type="none" w="med" len="med"/>
-                      <a:tailEnd type="none" w="med" len="med"/>
-                    </a:lnR>
-                    <a:lnT w="9525" cap="flat" cmpd="sng" algn="ctr">
-                      <a:solidFill>
-                        <a:srgbClr val="D7E1F5"/>
-                      </a:solidFill>
-                      <a:prstDash val="solid"/>
-                      <a:round/>
-                      <a:headEnd type="none" w="med" len="med"/>
-                      <a:tailEnd type="none" w="med" len="med"/>
-                    </a:lnT>
-                    <a:lnB w="9525" cap="flat" cmpd="sng" algn="ctr">
-                      <a:solidFill>
-                        <a:srgbClr val="D7E1F5"/>
-                      </a:solidFill>
-                      <a:prstDash val="solid"/>
-                      <a:round/>
-                      <a:headEnd type="none" w="med" len="med"/>
-                      <a:tailEnd type="none" w="med" len="med"/>
-                    </a:lnB>
-                    <a:solidFill>
-                      <a:srgbClr val="F5F8FD"/>
-                    </a:solidFill>
-                  </a:tcPr>
-                </a:tc>
-                <a:tc>
-                  <a:txBody>
-                    <a:bodyPr/>
-                    <a:lstStyle/>
-                    <a:p>
-                      <a:pPr algn="ctr" indent="0" marL="0">
-                        <a:buNone/>
-                      </a:pPr>
-                      <a:r>
-                        <a:rPr lang="en-US" sz="830" dirty="0">
-                          <a:solidFill>
-                            <a:srgbClr val="3A4566"/>
-                          </a:solidFill>
-                          <a:latin typeface="Calibri" pitchFamily="34" charset="0"/>
-                          <a:ea typeface="Calibri" pitchFamily="34" charset="-122"/>
-                          <a:cs typeface="Calibri" pitchFamily="34" charset="-120"/>
-                        </a:rPr>
-                        <a:t>Not confirmed</a:t>
-                      </a:r>
-                      <a:endParaRPr lang="en-US" sz="830" dirty="0">
-                        <a:latin typeface="Calibri" charset="0"/>
-                        <a:ea typeface="Calibri" charset="0"/>
-                        <a:cs typeface="Calibri" charset="0"/>
-                      </a:endParaRPr>
-                    </a:p>
-                  </a:txBody>
-                  <a:tcPr marL="76200" marR="76200" marT="38100" marB="38100" anchor="ctr">
-                    <a:lnL w="9525" cap="flat" cmpd="sng" algn="ctr">
-                      <a:solidFill>
-                        <a:srgbClr val="D7E1F5"/>
-                      </a:solidFill>
-                      <a:prstDash val="solid"/>
-                      <a:round/>
-                      <a:headEnd type="none" w="med" len="med"/>
-                      <a:tailEnd type="none" w="med" len="med"/>
-                    </a:lnL>
-                    <a:lnR w="9525" cap="flat" cmpd="sng" algn="ctr">
-                      <a:solidFill>
-                        <a:srgbClr val="D7E1F5"/>
-                      </a:solidFill>
-                      <a:prstDash val="solid"/>
-                      <a:round/>
-                      <a:headEnd type="none" w="med" len="med"/>
-                      <a:tailEnd type="none" w="med" len="med"/>
-                    </a:lnR>
-                    <a:lnT w="9525" cap="flat" cmpd="sng" algn="ctr">
-                      <a:solidFill>
-                        <a:srgbClr val="D7E1F5"/>
-                      </a:solidFill>
-                      <a:prstDash val="solid"/>
-                      <a:round/>
-                      <a:headEnd type="none" w="med" len="med"/>
-                      <a:tailEnd type="none" w="med" len="med"/>
-                    </a:lnT>
-                    <a:lnB w="9525" cap="flat" cmpd="sng" algn="ctr">
-                      <a:solidFill>
-                        <a:srgbClr val="D7E1F5"/>
-                      </a:solidFill>
-                      <a:prstDash val="solid"/>
-                      <a:round/>
-                      <a:headEnd type="none" w="med" len="med"/>
-                      <a:tailEnd type="none" w="med" len="med"/>
-                    </a:lnB>
-                    <a:solidFill>
-                      <a:srgbClr val="F5F8FD"/>
-                    </a:solidFill>
-                  </a:tcPr>
-                </a:tc>
-                <a:tc>
-                  <a:txBody>
-                    <a:bodyPr/>
-                    <a:lstStyle/>
-                    <a:p>
-                      <a:pPr algn="ctr" indent="0" marL="0">
-                        <a:buNone/>
-                      </a:pPr>
-                      <a:r>
-                        <a:rPr lang="en-US" sz="830" dirty="0">
-                          <a:solidFill>
-                            <a:srgbClr val="3A4566"/>
-                          </a:solidFill>
-                          <a:latin typeface="Calibri" pitchFamily="34" charset="0"/>
-                          <a:ea typeface="Calibri" pitchFamily="34" charset="-122"/>
-                          <a:cs typeface="Calibri" pitchFamily="34" charset="-120"/>
-                        </a:rPr>
-                        <a:t>EY (secondary)</a:t>
-                      </a:r>
-                      <a:endParaRPr lang="en-US" sz="830" dirty="0">
-                        <a:latin typeface="Calibri" charset="0"/>
-                        <a:ea typeface="Calibri" charset="0"/>
-                        <a:cs typeface="Calibri" charset="0"/>
-                      </a:endParaRPr>
-                    </a:p>
-                  </a:txBody>
-                  <a:tcPr marL="76200" marR="76200" marT="38100" marB="38100" anchor="ctr">
-                    <a:lnL w="9525" cap="flat" cmpd="sng" algn="ctr">
-                      <a:solidFill>
-                        <a:srgbClr val="D7E1F5"/>
-                      </a:solidFill>
-                      <a:prstDash val="solid"/>
-                      <a:round/>
-                      <a:headEnd type="none" w="med" len="med"/>
-                      <a:tailEnd type="none" w="med" len="med"/>
-                    </a:lnL>
-                    <a:lnR w="9525" cap="flat" cmpd="sng" algn="ctr">
-                      <a:solidFill>
-                        <a:srgbClr val="D7E1F5"/>
-                      </a:solidFill>
-                      <a:prstDash val="solid"/>
-                      <a:round/>
-                      <a:headEnd type="none" w="med" len="med"/>
-                      <a:tailEnd type="none" w="med" len="med"/>
-                    </a:lnR>
-                    <a:lnT w="9525" cap="flat" cmpd="sng" algn="ctr">
-                      <a:solidFill>
-                        <a:srgbClr val="D7E1F5"/>
-                      </a:solidFill>
-                      <a:prstDash val="solid"/>
-                      <a:round/>
-                      <a:headEnd type="none" w="med" len="med"/>
-                      <a:tailEnd type="none" w="med" len="med"/>
-                    </a:lnT>
-                    <a:lnB w="9525" cap="flat" cmpd="sng" algn="ctr">
-                      <a:solidFill>
-                        <a:srgbClr val="D7E1F5"/>
-                      </a:solidFill>
-                      <a:prstDash val="solid"/>
-                      <a:round/>
-                      <a:headEnd type="none" w="med" len="med"/>
-                      <a:tailEnd type="none" w="med" len="med"/>
-                    </a:lnB>
-                    <a:solidFill>
-                      <a:srgbClr val="F5F8FD"/>
-                    </a:solidFill>
-                  </a:tcPr>
-                </a:tc>
-                <a:tc>
-                  <a:txBody>
-                    <a:bodyPr/>
-                    <a:lstStyle/>
-                    <a:p>
-                      <a:pPr algn="ctr" indent="0" marL="0">
-                        <a:buNone/>
-                      </a:pPr>
-                      <a:r>
-                        <a:rPr lang="en-US" sz="830" dirty="0">
-                          <a:solidFill>
-                            <a:srgbClr val="3A4566"/>
-                          </a:solidFill>
-                          <a:latin typeface="Calibri" pitchFamily="34" charset="0"/>
-                          <a:ea typeface="Calibri" pitchFamily="34" charset="-122"/>
-                          <a:cs typeface="Calibri" pitchFamily="34" charset="-120"/>
-                        </a:rPr>
-                        <a:t>Not confirmed</a:t>
-                      </a:r>
-                      <a:endParaRPr lang="en-US" sz="830" dirty="0">
-                        <a:latin typeface="Calibri" charset="0"/>
-                        <a:ea typeface="Calibri" charset="0"/>
-                        <a:cs typeface="Calibri" charset="0"/>
-                      </a:endParaRPr>
-                    </a:p>
-                  </a:txBody>
-                  <a:tcPr marL="76200" marR="76200" marT="38100" marB="38100" anchor="ctr">
-                    <a:lnL w="9525" cap="flat" cmpd="sng" algn="ctr">
-                      <a:solidFill>
-                        <a:srgbClr val="D7E1F5"/>
-                      </a:solidFill>
-                      <a:prstDash val="solid"/>
-                      <a:round/>
-                      <a:headEnd type="none" w="med" len="med"/>
-                      <a:tailEnd type="none" w="med" len="med"/>
-                    </a:lnL>
-                    <a:lnR w="9525" cap="flat" cmpd="sng" algn="ctr">
-                      <a:solidFill>
-                        <a:srgbClr val="D7E1F5"/>
-                      </a:solidFill>
-                      <a:prstDash val="solid"/>
-                      <a:round/>
-                      <a:headEnd type="none" w="med" len="med"/>
-                      <a:tailEnd type="none" w="med" len="med"/>
-                    </a:lnR>
-                    <a:lnT w="9525" cap="flat" cmpd="sng" algn="ctr">
-                      <a:solidFill>
-                        <a:srgbClr val="D7E1F5"/>
-                      </a:solidFill>
-                      <a:prstDash val="solid"/>
-                      <a:round/>
-                      <a:headEnd type="none" w="med" len="med"/>
-                      <a:tailEnd type="none" w="med" len="med"/>
-                    </a:lnT>
-                    <a:lnB w="9525" cap="flat" cmpd="sng" algn="ctr">
-                      <a:solidFill>
-                        <a:srgbClr val="D7E1F5"/>
-                      </a:solidFill>
-                      <a:prstDash val="solid"/>
-                      <a:round/>
-                      <a:headEnd type="none" w="med" len="med"/>
-                      <a:tailEnd type="none" w="med" len="med"/>
-                    </a:lnB>
-                    <a:solidFill>
-                      <a:srgbClr val="F5F8FD"/>
-                    </a:solidFill>
-                  </a:tcPr>
-                </a:tc>
-                <a:tc>
-                  <a:txBody>
-                    <a:bodyPr/>
-                    <a:lstStyle/>
-                    <a:p>
-                      <a:pPr algn="ctr" indent="0" marL="0">
-                        <a:buNone/>
-                      </a:pPr>
-                      <a:r>
-                        <a:rPr lang="en-US" sz="830" dirty="0">
-                          <a:solidFill>
-                            <a:srgbClr val="3A4566"/>
-                          </a:solidFill>
-                          <a:latin typeface="Calibri" pitchFamily="34" charset="0"/>
-                          <a:ea typeface="Calibri" pitchFamily="34" charset="-122"/>
-                          <a:cs typeface="Calibri" pitchFamily="34" charset="-120"/>
-                        </a:rPr>
-                        <a:t>Not confirmed</a:t>
-                      </a:r>
-                      <a:endParaRPr lang="en-US" sz="830" dirty="0">
-                        <a:latin typeface="Calibri" charset="0"/>
-                        <a:ea typeface="Calibri" charset="0"/>
-                        <a:cs typeface="Calibri" charset="0"/>
-                      </a:endParaRPr>
-                    </a:p>
-                  </a:txBody>
-                  <a:tcPr marL="76200" marR="76200" marT="38100" marB="38100" anchor="ctr">
-                    <a:lnL w="9525" cap="flat" cmpd="sng" algn="ctr">
-                      <a:solidFill>
-                        <a:srgbClr val="D7E1F5"/>
-                      </a:solidFill>
-                      <a:prstDash val="solid"/>
-                      <a:round/>
-                      <a:headEnd type="none" w="med" len="med"/>
-                      <a:tailEnd type="none" w="med" len="med"/>
-                    </a:lnL>
-                    <a:lnR w="9525" cap="flat" cmpd="sng" algn="ctr">
-                      <a:solidFill>
-                        <a:srgbClr val="D7E1F5"/>
-                      </a:solidFill>
-                      <a:prstDash val="solid"/>
-                      <a:round/>
-                      <a:headEnd type="none" w="med" len="med"/>
-                      <a:tailEnd type="none" w="med" len="med"/>
-                    </a:lnR>
-                    <a:lnT w="9525" cap="flat" cmpd="sng" algn="ctr">
-                      <a:solidFill>
-                        <a:srgbClr val="D7E1F5"/>
-                      </a:solidFill>
-                      <a:prstDash val="solid"/>
-                      <a:round/>
-                      <a:headEnd type="none" w="med" len="med"/>
-                      <a:tailEnd type="none" w="med" len="med"/>
-                    </a:lnT>
-                    <a:lnB w="9525" cap="flat" cmpd="sng" algn="ctr">
-                      <a:solidFill>
-                        <a:srgbClr val="D7E1F5"/>
-                      </a:solidFill>
-                      <a:prstDash val="solid"/>
-                      <a:round/>
-                      <a:headEnd type="none" w="med" len="med"/>
-                      <a:tailEnd type="none" w="med" len="med"/>
-                    </a:lnB>
-                    <a:solidFill>
-                      <a:srgbClr val="F5F8FD"/>
-                    </a:solidFill>
-                  </a:tcPr>
-                </a:tc>
-              </a:tr>
-              <a:tr h="0">
-                <a:tc>
-                  <a:txBody>
-                    <a:bodyPr/>
-                    <a:lstStyle/>
-                    <a:p>
-                      <a:pPr algn="l" indent="0" marL="0">
-                        <a:buNone/>
-                      </a:pPr>
-                      <a:r>
-                        <a:rPr lang="en-US" sz="830" b="1" dirty="0">
-                          <a:solidFill>
-                            <a:srgbClr val="1E2761"/>
-                          </a:solidFill>
-                          <a:latin typeface="Calibri" pitchFamily="34" charset="0"/>
-                          <a:ea typeface="Calibri" pitchFamily="34" charset="-122"/>
-                          <a:cs typeface="Calibri" pitchFamily="34" charset="-120"/>
-                        </a:rPr>
                         <a:t>Primary blockchain</a:t>
                       </a:r>
                       <a:endParaRPr lang="en-US" sz="830" dirty="0">
@@ -21888,7 +22366,7 @@
                       <a:tailEnd type="none" w="med" len="med"/>
                     </a:lnB>
                     <a:solidFill>
-                      <a:srgbClr val="FFFFFF"/>
+                      <a:srgbClr val="F5F8FD"/>
                     </a:solidFill>
                   </a:tcPr>
                 </a:tc>
@@ -21956,7 +22434,7 @@
                       <a:tailEnd type="none" w="med" len="med"/>
                     </a:lnB>
                     <a:solidFill>
-                      <a:srgbClr val="FFFFFF"/>
+                      <a:srgbClr val="F5F8FD"/>
                     </a:solidFill>
                   </a:tcPr>
                 </a:tc>
@@ -22024,7 +22502,7 @@
                       <a:tailEnd type="none" w="med" len="med"/>
                     </a:lnB>
                     <a:solidFill>
-                      <a:srgbClr val="FFFFFF"/>
+                      <a:srgbClr val="F5F8FD"/>
                     </a:solidFill>
                   </a:tcPr>
                 </a:tc>
@@ -22092,7 +22570,7 @@
                       <a:tailEnd type="none" w="med" len="med"/>
                     </a:lnB>
                     <a:solidFill>
-                      <a:srgbClr val="FFFFFF"/>
+                      <a:srgbClr val="F5F8FD"/>
                     </a:solidFill>
                   </a:tcPr>
                 </a:tc>
@@ -22160,7 +22638,7 @@
                       <a:tailEnd type="none" w="med" len="med"/>
                     </a:lnB>
                     <a:solidFill>
-                      <a:srgbClr val="FFFFFF"/>
+                      <a:srgbClr val="F5F8FD"/>
                     </a:solidFill>
                   </a:tcPr>
                 </a:tc>
@@ -22228,7 +22706,7 @@
                       <a:tailEnd type="none" w="med" len="med"/>
                     </a:lnB>
                     <a:solidFill>
-                      <a:srgbClr val="FFFFFF"/>
+                      <a:srgbClr val="F5F8FD"/>
                     </a:solidFill>
                   </a:tcPr>
                 </a:tc>
@@ -22296,7 +22774,7 @@
                       <a:tailEnd type="none" w="med" len="med"/>
                     </a:lnB>
                     <a:solidFill>
-                      <a:srgbClr val="FFFFFF"/>
+                      <a:srgbClr val="F5F8FD"/>
                     </a:solidFill>
                   </a:tcPr>
                 </a:tc>
@@ -22366,7 +22844,7 @@
                       <a:tailEnd type="none" w="med" len="med"/>
                     </a:lnB>
                     <a:solidFill>
-                      <a:srgbClr val="F5F8FD"/>
+                      <a:srgbClr val="FFFFFF"/>
                     </a:solidFill>
                   </a:tcPr>
                 </a:tc>
@@ -22434,7 +22912,7 @@
                       <a:tailEnd type="none" w="med" len="med"/>
                     </a:lnB>
                     <a:solidFill>
-                      <a:srgbClr val="F5F8FD"/>
+                      <a:srgbClr val="FFFFFF"/>
                     </a:solidFill>
                   </a:tcPr>
                 </a:tc>
@@ -22502,7 +22980,7 @@
                       <a:tailEnd type="none" w="med" len="med"/>
                     </a:lnB>
                     <a:solidFill>
-                      <a:srgbClr val="F5F8FD"/>
+                      <a:srgbClr val="FFFFFF"/>
                     </a:solidFill>
                   </a:tcPr>
                 </a:tc>
@@ -22570,7 +23048,7 @@
                       <a:tailEnd type="none" w="med" len="med"/>
                     </a:lnB>
                     <a:solidFill>
-                      <a:srgbClr val="F5F8FD"/>
+                      <a:srgbClr val="FFFFFF"/>
                     </a:solidFill>
                   </a:tcPr>
                 </a:tc>
@@ -22638,7 +23116,7 @@
                       <a:tailEnd type="none" w="med" len="med"/>
                     </a:lnB>
                     <a:solidFill>
-                      <a:srgbClr val="F5F8FD"/>
+                      <a:srgbClr val="FFFFFF"/>
                     </a:solidFill>
                   </a:tcPr>
                 </a:tc>
@@ -22706,7 +23184,7 @@
                       <a:tailEnd type="none" w="med" len="med"/>
                     </a:lnB>
                     <a:solidFill>
-                      <a:srgbClr val="F5F8FD"/>
+                      <a:srgbClr val="FFFFFF"/>
                     </a:solidFill>
                   </a:tcPr>
                 </a:tc>
@@ -22774,7 +23252,7 @@
                       <a:tailEnd type="none" w="med" len="med"/>
                     </a:lnB>
                     <a:solidFill>
-                      <a:srgbClr val="F5F8FD"/>
+                      <a:srgbClr val="FFFFFF"/>
                     </a:solidFill>
                   </a:tcPr>
                 </a:tc>
@@ -22844,7 +23322,7 @@
                       <a:tailEnd type="none" w="med" len="med"/>
                     </a:lnB>
                     <a:solidFill>
-                      <a:srgbClr val="FFFFFF"/>
+                      <a:srgbClr val="F5F8FD"/>
                     </a:solidFill>
                   </a:tcPr>
                 </a:tc>
@@ -22912,7 +23390,7 @@
                       <a:tailEnd type="none" w="med" len="med"/>
                     </a:lnB>
                     <a:solidFill>
-                      <a:srgbClr val="FFFFFF"/>
+                      <a:srgbClr val="F5F8FD"/>
                     </a:solidFill>
                   </a:tcPr>
                 </a:tc>
@@ -22980,7 +23458,7 @@
                       <a:tailEnd type="none" w="med" len="med"/>
                     </a:lnB>
                     <a:solidFill>
-                      <a:srgbClr val="FFFFFF"/>
+                      <a:srgbClr val="F5F8FD"/>
                     </a:solidFill>
                   </a:tcPr>
                 </a:tc>
@@ -23048,7 +23526,7 @@
                       <a:tailEnd type="none" w="med" len="med"/>
                     </a:lnB>
                     <a:solidFill>
-                      <a:srgbClr val="FFFFFF"/>
+                      <a:srgbClr val="F5F8FD"/>
                     </a:solidFill>
                   </a:tcPr>
                 </a:tc>
@@ -23116,7 +23594,7 @@
                       <a:tailEnd type="none" w="med" len="med"/>
                     </a:lnB>
                     <a:solidFill>
-                      <a:srgbClr val="FFFFFF"/>
+                      <a:srgbClr val="F5F8FD"/>
                     </a:solidFill>
                   </a:tcPr>
                 </a:tc>
@@ -23184,7 +23662,7 @@
                       <a:tailEnd type="none" w="med" len="med"/>
                     </a:lnB>
                     <a:solidFill>
-                      <a:srgbClr val="FFFFFF"/>
+                      <a:srgbClr val="F5F8FD"/>
                     </a:solidFill>
                   </a:tcPr>
                 </a:tc>
@@ -23252,7 +23730,7 @@
                       <a:tailEnd type="none" w="med" len="med"/>
                     </a:lnB>
                     <a:solidFill>
-                      <a:srgbClr val="FFFFFF"/>
+                      <a:srgbClr val="F5F8FD"/>
                     </a:solidFill>
                   </a:tcPr>
                 </a:tc>
@@ -23322,7 +23800,7 @@
                       <a:tailEnd type="none" w="med" len="med"/>
                     </a:lnB>
                     <a:solidFill>
-                      <a:srgbClr val="F5F8FD"/>
+                      <a:srgbClr val="FFFFFF"/>
                     </a:solidFill>
                   </a:tcPr>
                 </a:tc>
@@ -23390,7 +23868,7 @@
                       <a:tailEnd type="none" w="med" len="med"/>
                     </a:lnB>
                     <a:solidFill>
-                      <a:srgbClr val="F5F8FD"/>
+                      <a:srgbClr val="FFFFFF"/>
                     </a:solidFill>
                   </a:tcPr>
                 </a:tc>
@@ -23458,7 +23936,7 @@
                       <a:tailEnd type="none" w="med" len="med"/>
                     </a:lnB>
                     <a:solidFill>
-                      <a:srgbClr val="F5F8FD"/>
+                      <a:srgbClr val="FFFFFF"/>
                     </a:solidFill>
                   </a:tcPr>
                 </a:tc>
@@ -23526,7 +24004,7 @@
                       <a:tailEnd type="none" w="med" len="med"/>
                     </a:lnB>
                     <a:solidFill>
-                      <a:srgbClr val="F5F8FD"/>
+                      <a:srgbClr val="FFFFFF"/>
                     </a:solidFill>
                   </a:tcPr>
                 </a:tc>
@@ -23594,7 +24072,7 @@
                       <a:tailEnd type="none" w="med" len="med"/>
                     </a:lnB>
                     <a:solidFill>
-                      <a:srgbClr val="F5F8FD"/>
+                      <a:srgbClr val="FFFFFF"/>
                     </a:solidFill>
                   </a:tcPr>
                 </a:tc>
@@ -23662,7 +24140,7 @@
                       <a:tailEnd type="none" w="med" len="med"/>
                     </a:lnB>
                     <a:solidFill>
-                      <a:srgbClr val="F5F8FD"/>
+                      <a:srgbClr val="FFFFFF"/>
                     </a:solidFill>
                   </a:tcPr>
                 </a:tc>
@@ -23730,7 +24208,7 @@
                       <a:tailEnd type="none" w="med" len="med"/>
                     </a:lnB>
                     <a:solidFill>
-                      <a:srgbClr val="F5F8FD"/>
+                      <a:srgbClr val="FFFFFF"/>
                     </a:solidFill>
                   </a:tcPr>
                 </a:tc>

</xml_diff>

<commit_message>
Add DeFi/lending collateral-usage row to comparison table
Answers whether each fund's token is used as collateral anywhere, sourced
via live research since this wasn't covered in the existing docs (except
BUIDL/BENJI, which already had partial coverage):
- BENJI: limited to Franklin's own fund complex under an SEC no-action
  letter (securities-lending collateral / cash management)
- BUIDL: accepted as collateral on Binance (BNB Chain)
- USTB: a small set of KYC-gated lending pools (Aave)
- USCC: actively deployed on Aave, Kamino, and Morpho, >$120M
- OUSG: Flux Finance, an Ondo-affiliated KYC-gated lending pool
- WTGXX: reserve backing for LotusUSD, a DeFi lending protocol vault

Co-Authored-By: Claude Sonnet 5 <noreply@anthropic.com>
Claude-Session: https://claude.ai/code/session_01XLt1ze3JWdaihuSAsk6TrZ
</commit_message>
<xml_diff>
--- a/docs/presentations/Tokenized_Funds_Comparative_Analysis.pptx
+++ b/docs/presentations/Tokenized_Funds_Comparative_Analysis.pptx
@@ -23275,6 +23275,484 @@
                           <a:ea typeface="Calibri" pitchFamily="34" charset="-122"/>
                           <a:cs typeface="Calibri" pitchFamily="34" charset="-120"/>
                         </a:rPr>
+                        <a:t>Used as DeFi/lending collateral?</a:t>
+                      </a:r>
+                      <a:endParaRPr lang="en-US" sz="830" dirty="0">
+                        <a:latin typeface="Calibri" charset="0"/>
+                        <a:ea typeface="Calibri" charset="0"/>
+                        <a:cs typeface="Calibri" charset="0"/>
+                      </a:endParaRPr>
+                    </a:p>
+                  </a:txBody>
+                  <a:tcPr marL="76200" marR="76200" marT="38100" marB="38100" anchor="ctr">
+                    <a:lnL w="9525" cap="flat" cmpd="sng" algn="ctr">
+                      <a:solidFill>
+                        <a:srgbClr val="D7E1F5"/>
+                      </a:solidFill>
+                      <a:prstDash val="solid"/>
+                      <a:round/>
+                      <a:headEnd type="none" w="med" len="med"/>
+                      <a:tailEnd type="none" w="med" len="med"/>
+                    </a:lnL>
+                    <a:lnR w="9525" cap="flat" cmpd="sng" algn="ctr">
+                      <a:solidFill>
+                        <a:srgbClr val="D7E1F5"/>
+                      </a:solidFill>
+                      <a:prstDash val="solid"/>
+                      <a:round/>
+                      <a:headEnd type="none" w="med" len="med"/>
+                      <a:tailEnd type="none" w="med" len="med"/>
+                    </a:lnR>
+                    <a:lnT w="9525" cap="flat" cmpd="sng" algn="ctr">
+                      <a:solidFill>
+                        <a:srgbClr val="D7E1F5"/>
+                      </a:solidFill>
+                      <a:prstDash val="solid"/>
+                      <a:round/>
+                      <a:headEnd type="none" w="med" len="med"/>
+                      <a:tailEnd type="none" w="med" len="med"/>
+                    </a:lnT>
+                    <a:lnB w="9525" cap="flat" cmpd="sng" algn="ctr">
+                      <a:solidFill>
+                        <a:srgbClr val="D7E1F5"/>
+                      </a:solidFill>
+                      <a:prstDash val="solid"/>
+                      <a:round/>
+                      <a:headEnd type="none" w="med" len="med"/>
+                      <a:tailEnd type="none" w="med" len="med"/>
+                    </a:lnB>
+                    <a:solidFill>
+                      <a:srgbClr val="F5F8FD"/>
+                    </a:solidFill>
+                  </a:tcPr>
+                </a:tc>
+                <a:tc>
+                  <a:txBody>
+                    <a:bodyPr/>
+                    <a:lstStyle/>
+                    <a:p>
+                      <a:pPr algn="ctr" indent="0" marL="0">
+                        <a:buNone/>
+                      </a:pPr>
+                      <a:r>
+                        <a:rPr lang="en-US" sz="830" dirty="0">
+                          <a:solidFill>
+                            <a:srgbClr val="3A4566"/>
+                          </a:solidFill>
+                          <a:latin typeface="Calibri" pitchFamily="34" charset="0"/>
+                          <a:ea typeface="Calibri" pitchFamily="34" charset="-122"/>
+                          <a:cs typeface="Calibri" pitchFamily="34" charset="-120"/>
+                        </a:rPr>
+                        <a:t>Yes — intra-Franklin only</a:t>
+                      </a:r>
+                      <a:endParaRPr lang="en-US" sz="830" dirty="0">
+                        <a:latin typeface="Calibri" charset="0"/>
+                        <a:ea typeface="Calibri" charset="0"/>
+                        <a:cs typeface="Calibri" charset="0"/>
+                      </a:endParaRPr>
+                    </a:p>
+                  </a:txBody>
+                  <a:tcPr marL="76200" marR="76200" marT="38100" marB="38100" anchor="ctr">
+                    <a:lnL w="9525" cap="flat" cmpd="sng" algn="ctr">
+                      <a:solidFill>
+                        <a:srgbClr val="D7E1F5"/>
+                      </a:solidFill>
+                      <a:prstDash val="solid"/>
+                      <a:round/>
+                      <a:headEnd type="none" w="med" len="med"/>
+                      <a:tailEnd type="none" w="med" len="med"/>
+                    </a:lnL>
+                    <a:lnR w="9525" cap="flat" cmpd="sng" algn="ctr">
+                      <a:solidFill>
+                        <a:srgbClr val="D7E1F5"/>
+                      </a:solidFill>
+                      <a:prstDash val="solid"/>
+                      <a:round/>
+                      <a:headEnd type="none" w="med" len="med"/>
+                      <a:tailEnd type="none" w="med" len="med"/>
+                    </a:lnR>
+                    <a:lnT w="9525" cap="flat" cmpd="sng" algn="ctr">
+                      <a:solidFill>
+                        <a:srgbClr val="D7E1F5"/>
+                      </a:solidFill>
+                      <a:prstDash val="solid"/>
+                      <a:round/>
+                      <a:headEnd type="none" w="med" len="med"/>
+                      <a:tailEnd type="none" w="med" len="med"/>
+                    </a:lnT>
+                    <a:lnB w="9525" cap="flat" cmpd="sng" algn="ctr">
+                      <a:solidFill>
+                        <a:srgbClr val="D7E1F5"/>
+                      </a:solidFill>
+                      <a:prstDash val="solid"/>
+                      <a:round/>
+                      <a:headEnd type="none" w="med" len="med"/>
+                      <a:tailEnd type="none" w="med" len="med"/>
+                    </a:lnB>
+                    <a:solidFill>
+                      <a:srgbClr val="F5F8FD"/>
+                    </a:solidFill>
+                  </a:tcPr>
+                </a:tc>
+                <a:tc>
+                  <a:txBody>
+                    <a:bodyPr/>
+                    <a:lstStyle/>
+                    <a:p>
+                      <a:pPr algn="ctr" indent="0" marL="0">
+                        <a:buNone/>
+                      </a:pPr>
+                      <a:r>
+                        <a:rPr lang="en-US" sz="830" dirty="0">
+                          <a:solidFill>
+                            <a:srgbClr val="3A4566"/>
+                          </a:solidFill>
+                          <a:latin typeface="Calibri" pitchFamily="34" charset="0"/>
+                          <a:ea typeface="Calibri" pitchFamily="34" charset="-122"/>
+                          <a:cs typeface="Calibri" pitchFamily="34" charset="-120"/>
+                        </a:rPr>
+                        <a:t>Yes — Binance (BNB Chain)</a:t>
+                      </a:r>
+                      <a:endParaRPr lang="en-US" sz="830" dirty="0">
+                        <a:latin typeface="Calibri" charset="0"/>
+                        <a:ea typeface="Calibri" charset="0"/>
+                        <a:cs typeface="Calibri" charset="0"/>
+                      </a:endParaRPr>
+                    </a:p>
+                  </a:txBody>
+                  <a:tcPr marL="76200" marR="76200" marT="38100" marB="38100" anchor="ctr">
+                    <a:lnL w="9525" cap="flat" cmpd="sng" algn="ctr">
+                      <a:solidFill>
+                        <a:srgbClr val="D7E1F5"/>
+                      </a:solidFill>
+                      <a:prstDash val="solid"/>
+                      <a:round/>
+                      <a:headEnd type="none" w="med" len="med"/>
+                      <a:tailEnd type="none" w="med" len="med"/>
+                    </a:lnL>
+                    <a:lnR w="9525" cap="flat" cmpd="sng" algn="ctr">
+                      <a:solidFill>
+                        <a:srgbClr val="D7E1F5"/>
+                      </a:solidFill>
+                      <a:prstDash val="solid"/>
+                      <a:round/>
+                      <a:headEnd type="none" w="med" len="med"/>
+                      <a:tailEnd type="none" w="med" len="med"/>
+                    </a:lnR>
+                    <a:lnT w="9525" cap="flat" cmpd="sng" algn="ctr">
+                      <a:solidFill>
+                        <a:srgbClr val="D7E1F5"/>
+                      </a:solidFill>
+                      <a:prstDash val="solid"/>
+                      <a:round/>
+                      <a:headEnd type="none" w="med" len="med"/>
+                      <a:tailEnd type="none" w="med" len="med"/>
+                    </a:lnT>
+                    <a:lnB w="9525" cap="flat" cmpd="sng" algn="ctr">
+                      <a:solidFill>
+                        <a:srgbClr val="D7E1F5"/>
+                      </a:solidFill>
+                      <a:prstDash val="solid"/>
+                      <a:round/>
+                      <a:headEnd type="none" w="med" len="med"/>
+                      <a:tailEnd type="none" w="med" len="med"/>
+                    </a:lnB>
+                    <a:solidFill>
+                      <a:srgbClr val="F5F8FD"/>
+                    </a:solidFill>
+                  </a:tcPr>
+                </a:tc>
+                <a:tc>
+                  <a:txBody>
+                    <a:bodyPr/>
+                    <a:lstStyle/>
+                    <a:p>
+                      <a:pPr algn="ctr" indent="0" marL="0">
+                        <a:buNone/>
+                      </a:pPr>
+                      <a:r>
+                        <a:rPr lang="en-US" sz="830" dirty="0">
+                          <a:solidFill>
+                            <a:srgbClr val="3A4566"/>
+                          </a:solidFill>
+                          <a:latin typeface="Calibri" pitchFamily="34" charset="0"/>
+                          <a:ea typeface="Calibri" pitchFamily="34" charset="-122"/>
+                          <a:cs typeface="Calibri" pitchFamily="34" charset="-120"/>
+                        </a:rPr>
+                        <a:t>Yes — limited KYC pools (Aave)</a:t>
+                      </a:r>
+                      <a:endParaRPr lang="en-US" sz="830" dirty="0">
+                        <a:latin typeface="Calibri" charset="0"/>
+                        <a:ea typeface="Calibri" charset="0"/>
+                        <a:cs typeface="Calibri" charset="0"/>
+                      </a:endParaRPr>
+                    </a:p>
+                  </a:txBody>
+                  <a:tcPr marL="76200" marR="76200" marT="38100" marB="38100" anchor="ctr">
+                    <a:lnL w="9525" cap="flat" cmpd="sng" algn="ctr">
+                      <a:solidFill>
+                        <a:srgbClr val="D7E1F5"/>
+                      </a:solidFill>
+                      <a:prstDash val="solid"/>
+                      <a:round/>
+                      <a:headEnd type="none" w="med" len="med"/>
+                      <a:tailEnd type="none" w="med" len="med"/>
+                    </a:lnL>
+                    <a:lnR w="9525" cap="flat" cmpd="sng" algn="ctr">
+                      <a:solidFill>
+                        <a:srgbClr val="D7E1F5"/>
+                      </a:solidFill>
+                      <a:prstDash val="solid"/>
+                      <a:round/>
+                      <a:headEnd type="none" w="med" len="med"/>
+                      <a:tailEnd type="none" w="med" len="med"/>
+                    </a:lnR>
+                    <a:lnT w="9525" cap="flat" cmpd="sng" algn="ctr">
+                      <a:solidFill>
+                        <a:srgbClr val="D7E1F5"/>
+                      </a:solidFill>
+                      <a:prstDash val="solid"/>
+                      <a:round/>
+                      <a:headEnd type="none" w="med" len="med"/>
+                      <a:tailEnd type="none" w="med" len="med"/>
+                    </a:lnT>
+                    <a:lnB w="9525" cap="flat" cmpd="sng" algn="ctr">
+                      <a:solidFill>
+                        <a:srgbClr val="D7E1F5"/>
+                      </a:solidFill>
+                      <a:prstDash val="solid"/>
+                      <a:round/>
+                      <a:headEnd type="none" w="med" len="med"/>
+                      <a:tailEnd type="none" w="med" len="med"/>
+                    </a:lnB>
+                    <a:solidFill>
+                      <a:srgbClr val="F5F8FD"/>
+                    </a:solidFill>
+                  </a:tcPr>
+                </a:tc>
+                <a:tc>
+                  <a:txBody>
+                    <a:bodyPr/>
+                    <a:lstStyle/>
+                    <a:p>
+                      <a:pPr algn="ctr" indent="0" marL="0">
+                        <a:buNone/>
+                      </a:pPr>
+                      <a:r>
+                        <a:rPr lang="en-US" sz="830" dirty="0">
+                          <a:solidFill>
+                            <a:srgbClr val="3A4566"/>
+                          </a:solidFill>
+                          <a:latin typeface="Calibri" pitchFamily="34" charset="0"/>
+                          <a:ea typeface="Calibri" pitchFamily="34" charset="-122"/>
+                          <a:cs typeface="Calibri" pitchFamily="34" charset="-120"/>
+                        </a:rPr>
+                        <a:t>Yes — Aave/Kamino/Morpho, &gt;$120M</a:t>
+                      </a:r>
+                      <a:endParaRPr lang="en-US" sz="830" dirty="0">
+                        <a:latin typeface="Calibri" charset="0"/>
+                        <a:ea typeface="Calibri" charset="0"/>
+                        <a:cs typeface="Calibri" charset="0"/>
+                      </a:endParaRPr>
+                    </a:p>
+                  </a:txBody>
+                  <a:tcPr marL="76200" marR="76200" marT="38100" marB="38100" anchor="ctr">
+                    <a:lnL w="9525" cap="flat" cmpd="sng" algn="ctr">
+                      <a:solidFill>
+                        <a:srgbClr val="D7E1F5"/>
+                      </a:solidFill>
+                      <a:prstDash val="solid"/>
+                      <a:round/>
+                      <a:headEnd type="none" w="med" len="med"/>
+                      <a:tailEnd type="none" w="med" len="med"/>
+                    </a:lnL>
+                    <a:lnR w="9525" cap="flat" cmpd="sng" algn="ctr">
+                      <a:solidFill>
+                        <a:srgbClr val="D7E1F5"/>
+                      </a:solidFill>
+                      <a:prstDash val="solid"/>
+                      <a:round/>
+                      <a:headEnd type="none" w="med" len="med"/>
+                      <a:tailEnd type="none" w="med" len="med"/>
+                    </a:lnR>
+                    <a:lnT w="9525" cap="flat" cmpd="sng" algn="ctr">
+                      <a:solidFill>
+                        <a:srgbClr val="D7E1F5"/>
+                      </a:solidFill>
+                      <a:prstDash val="solid"/>
+                      <a:round/>
+                      <a:headEnd type="none" w="med" len="med"/>
+                      <a:tailEnd type="none" w="med" len="med"/>
+                    </a:lnT>
+                    <a:lnB w="9525" cap="flat" cmpd="sng" algn="ctr">
+                      <a:solidFill>
+                        <a:srgbClr val="D7E1F5"/>
+                      </a:solidFill>
+                      <a:prstDash val="solid"/>
+                      <a:round/>
+                      <a:headEnd type="none" w="med" len="med"/>
+                      <a:tailEnd type="none" w="med" len="med"/>
+                    </a:lnB>
+                    <a:solidFill>
+                      <a:srgbClr val="F5F8FD"/>
+                    </a:solidFill>
+                  </a:tcPr>
+                </a:tc>
+                <a:tc>
+                  <a:txBody>
+                    <a:bodyPr/>
+                    <a:lstStyle/>
+                    <a:p>
+                      <a:pPr algn="ctr" indent="0" marL="0">
+                        <a:buNone/>
+                      </a:pPr>
+                      <a:r>
+                        <a:rPr lang="en-US" sz="830" dirty="0">
+                          <a:solidFill>
+                            <a:srgbClr val="3A4566"/>
+                          </a:solidFill>
+                          <a:latin typeface="Calibri" pitchFamily="34" charset="0"/>
+                          <a:ea typeface="Calibri" pitchFamily="34" charset="-122"/>
+                          <a:cs typeface="Calibri" pitchFamily="34" charset="-120"/>
+                        </a:rPr>
+                        <a:t>Yes — Flux Finance (KYC pool)</a:t>
+                      </a:r>
+                      <a:endParaRPr lang="en-US" sz="830" dirty="0">
+                        <a:latin typeface="Calibri" charset="0"/>
+                        <a:ea typeface="Calibri" charset="0"/>
+                        <a:cs typeface="Calibri" charset="0"/>
+                      </a:endParaRPr>
+                    </a:p>
+                  </a:txBody>
+                  <a:tcPr marL="76200" marR="76200" marT="38100" marB="38100" anchor="ctr">
+                    <a:lnL w="9525" cap="flat" cmpd="sng" algn="ctr">
+                      <a:solidFill>
+                        <a:srgbClr val="D7E1F5"/>
+                      </a:solidFill>
+                      <a:prstDash val="solid"/>
+                      <a:round/>
+                      <a:headEnd type="none" w="med" len="med"/>
+                      <a:tailEnd type="none" w="med" len="med"/>
+                    </a:lnL>
+                    <a:lnR w="9525" cap="flat" cmpd="sng" algn="ctr">
+                      <a:solidFill>
+                        <a:srgbClr val="D7E1F5"/>
+                      </a:solidFill>
+                      <a:prstDash val="solid"/>
+                      <a:round/>
+                      <a:headEnd type="none" w="med" len="med"/>
+                      <a:tailEnd type="none" w="med" len="med"/>
+                    </a:lnR>
+                    <a:lnT w="9525" cap="flat" cmpd="sng" algn="ctr">
+                      <a:solidFill>
+                        <a:srgbClr val="D7E1F5"/>
+                      </a:solidFill>
+                      <a:prstDash val="solid"/>
+                      <a:round/>
+                      <a:headEnd type="none" w="med" len="med"/>
+                      <a:tailEnd type="none" w="med" len="med"/>
+                    </a:lnT>
+                    <a:lnB w="9525" cap="flat" cmpd="sng" algn="ctr">
+                      <a:solidFill>
+                        <a:srgbClr val="D7E1F5"/>
+                      </a:solidFill>
+                      <a:prstDash val="solid"/>
+                      <a:round/>
+                      <a:headEnd type="none" w="med" len="med"/>
+                      <a:tailEnd type="none" w="med" len="med"/>
+                    </a:lnB>
+                    <a:solidFill>
+                      <a:srgbClr val="F5F8FD"/>
+                    </a:solidFill>
+                  </a:tcPr>
+                </a:tc>
+                <a:tc>
+                  <a:txBody>
+                    <a:bodyPr/>
+                    <a:lstStyle/>
+                    <a:p>
+                      <a:pPr algn="ctr" indent="0" marL="0">
+                        <a:buNone/>
+                      </a:pPr>
+                      <a:r>
+                        <a:rPr lang="en-US" sz="830" dirty="0">
+                          <a:solidFill>
+                            <a:srgbClr val="3A4566"/>
+                          </a:solidFill>
+                          <a:latin typeface="Calibri" pitchFamily="34" charset="0"/>
+                          <a:ea typeface="Calibri" pitchFamily="34" charset="-122"/>
+                          <a:cs typeface="Calibri" pitchFamily="34" charset="-120"/>
+                        </a:rPr>
+                        <a:t>Yes — LotusUSD reserve backing</a:t>
+                      </a:r>
+                      <a:endParaRPr lang="en-US" sz="830" dirty="0">
+                        <a:latin typeface="Calibri" charset="0"/>
+                        <a:ea typeface="Calibri" charset="0"/>
+                        <a:cs typeface="Calibri" charset="0"/>
+                      </a:endParaRPr>
+                    </a:p>
+                  </a:txBody>
+                  <a:tcPr marL="76200" marR="76200" marT="38100" marB="38100" anchor="ctr">
+                    <a:lnL w="9525" cap="flat" cmpd="sng" algn="ctr">
+                      <a:solidFill>
+                        <a:srgbClr val="D7E1F5"/>
+                      </a:solidFill>
+                      <a:prstDash val="solid"/>
+                      <a:round/>
+                      <a:headEnd type="none" w="med" len="med"/>
+                      <a:tailEnd type="none" w="med" len="med"/>
+                    </a:lnL>
+                    <a:lnR w="9525" cap="flat" cmpd="sng" algn="ctr">
+                      <a:solidFill>
+                        <a:srgbClr val="D7E1F5"/>
+                      </a:solidFill>
+                      <a:prstDash val="solid"/>
+                      <a:round/>
+                      <a:headEnd type="none" w="med" len="med"/>
+                      <a:tailEnd type="none" w="med" len="med"/>
+                    </a:lnR>
+                    <a:lnT w="9525" cap="flat" cmpd="sng" algn="ctr">
+                      <a:solidFill>
+                        <a:srgbClr val="D7E1F5"/>
+                      </a:solidFill>
+                      <a:prstDash val="solid"/>
+                      <a:round/>
+                      <a:headEnd type="none" w="med" len="med"/>
+                      <a:tailEnd type="none" w="med" len="med"/>
+                    </a:lnT>
+                    <a:lnB w="9525" cap="flat" cmpd="sng" algn="ctr">
+                      <a:solidFill>
+                        <a:srgbClr val="D7E1F5"/>
+                      </a:solidFill>
+                      <a:prstDash val="solid"/>
+                      <a:round/>
+                      <a:headEnd type="none" w="med" len="med"/>
+                      <a:tailEnd type="none" w="med" len="med"/>
+                    </a:lnB>
+                    <a:solidFill>
+                      <a:srgbClr val="F5F8FD"/>
+                    </a:solidFill>
+                  </a:tcPr>
+                </a:tc>
+              </a:tr>
+              <a:tr h="0">
+                <a:tc>
+                  <a:txBody>
+                    <a:bodyPr/>
+                    <a:lstStyle/>
+                    <a:p>
+                      <a:pPr algn="l" indent="0" marL="0">
+                        <a:buNone/>
+                      </a:pPr>
+                      <a:r>
+                        <a:rPr lang="en-US" sz="830" b="1" dirty="0">
+                          <a:solidFill>
+                            <a:srgbClr val="1E2761"/>
+                          </a:solidFill>
+                          <a:latin typeface="Calibri" pitchFamily="34" charset="0"/>
+                          <a:ea typeface="Calibri" pitchFamily="34" charset="-122"/>
+                          <a:cs typeface="Calibri" pitchFamily="34" charset="-120"/>
+                        </a:rPr>
                         <a:t>Settlement rail</a:t>
                       </a:r>
                       <a:endParaRPr lang="en-US" sz="830" dirty="0">
@@ -23322,7 +23800,7 @@
                       <a:tailEnd type="none" w="med" len="med"/>
                     </a:lnB>
                     <a:solidFill>
-                      <a:srgbClr val="F5F8FD"/>
+                      <a:srgbClr val="FFFFFF"/>
                     </a:solidFill>
                   </a:tcPr>
                 </a:tc>
@@ -23390,7 +23868,7 @@
                       <a:tailEnd type="none" w="med" len="med"/>
                     </a:lnB>
                     <a:solidFill>
-                      <a:srgbClr val="F5F8FD"/>
+                      <a:srgbClr val="FFFFFF"/>
                     </a:solidFill>
                   </a:tcPr>
                 </a:tc>
@@ -23458,7 +23936,7 @@
                       <a:tailEnd type="none" w="med" len="med"/>
                     </a:lnB>
                     <a:solidFill>
-                      <a:srgbClr val="F5F8FD"/>
+                      <a:srgbClr val="FFFFFF"/>
                     </a:solidFill>
                   </a:tcPr>
                 </a:tc>
@@ -23526,7 +24004,7 @@
                       <a:tailEnd type="none" w="med" len="med"/>
                     </a:lnB>
                     <a:solidFill>
-                      <a:srgbClr val="F5F8FD"/>
+                      <a:srgbClr val="FFFFFF"/>
                     </a:solidFill>
                   </a:tcPr>
                 </a:tc>
@@ -23594,7 +24072,7 @@
                       <a:tailEnd type="none" w="med" len="med"/>
                     </a:lnB>
                     <a:solidFill>
-                      <a:srgbClr val="F5F8FD"/>
+                      <a:srgbClr val="FFFFFF"/>
                     </a:solidFill>
                   </a:tcPr>
                 </a:tc>
@@ -23662,7 +24140,7 @@
                       <a:tailEnd type="none" w="med" len="med"/>
                     </a:lnB>
                     <a:solidFill>
-                      <a:srgbClr val="F5F8FD"/>
+                      <a:srgbClr val="FFFFFF"/>
                     </a:solidFill>
                   </a:tcPr>
                 </a:tc>
@@ -23730,7 +24208,7 @@
                       <a:tailEnd type="none" w="med" len="med"/>
                     </a:lnB>
                     <a:solidFill>
-                      <a:srgbClr val="F5F8FD"/>
+                      <a:srgbClr val="FFFFFF"/>
                     </a:solidFill>
                   </a:tcPr>
                 </a:tc>
@@ -23800,7 +24278,7 @@
                       <a:tailEnd type="none" w="med" len="med"/>
                     </a:lnB>
                     <a:solidFill>
-                      <a:srgbClr val="FFFFFF"/>
+                      <a:srgbClr val="F5F8FD"/>
                     </a:solidFill>
                   </a:tcPr>
                 </a:tc>
@@ -23868,7 +24346,7 @@
                       <a:tailEnd type="none" w="med" len="med"/>
                     </a:lnB>
                     <a:solidFill>
-                      <a:srgbClr val="FFFFFF"/>
+                      <a:srgbClr val="F5F8FD"/>
                     </a:solidFill>
                   </a:tcPr>
                 </a:tc>
@@ -23936,7 +24414,7 @@
                       <a:tailEnd type="none" w="med" len="med"/>
                     </a:lnB>
                     <a:solidFill>
-                      <a:srgbClr val="FFFFFF"/>
+                      <a:srgbClr val="F5F8FD"/>
                     </a:solidFill>
                   </a:tcPr>
                 </a:tc>
@@ -24004,7 +24482,7 @@
                       <a:tailEnd type="none" w="med" len="med"/>
                     </a:lnB>
                     <a:solidFill>
-                      <a:srgbClr val="FFFFFF"/>
+                      <a:srgbClr val="F5F8FD"/>
                     </a:solidFill>
                   </a:tcPr>
                 </a:tc>
@@ -24072,7 +24550,7 @@
                       <a:tailEnd type="none" w="med" len="med"/>
                     </a:lnB>
                     <a:solidFill>
-                      <a:srgbClr val="FFFFFF"/>
+                      <a:srgbClr val="F5F8FD"/>
                     </a:solidFill>
                   </a:tcPr>
                 </a:tc>
@@ -24140,7 +24618,7 @@
                       <a:tailEnd type="none" w="med" len="med"/>
                     </a:lnB>
                     <a:solidFill>
-                      <a:srgbClr val="FFFFFF"/>
+                      <a:srgbClr val="F5F8FD"/>
                     </a:solidFill>
                   </a:tcPr>
                 </a:tc>
@@ -24208,7 +24686,7 @@
                       <a:tailEnd type="none" w="med" len="med"/>
                     </a:lnB>
                     <a:solidFill>
-                      <a:srgbClr val="FFFFFF"/>
+                      <a:srgbClr val="F5F8FD"/>
                     </a:solidFill>
                   </a:tcPr>
                 </a:tc>

</xml_diff>

<commit_message>
Add collateral-agreement-mechanism row summarizing how pledges work
New row summarizes the two distinct mechanisms found for how collateral
agreements are actually structured: BENJI's intra-fund arrangement runs
off-chain via a traditional UCC Article 8 control agreement (TA as
securities intermediary, tri-party pledge, springing lien). The other
five funds run on-chain — collateral is a deposit into a lending
protocol's smart contract, gated by the same Allowlist that governs
ordinary transfers, with non-transferable receipt tokens substituting for
a Control Agreement's "who can instruct" logic.

Co-Authored-By: Claude Sonnet 5 <noreply@anthropic.com>
Claude-Session: https://claude.ai/code/session_01XLt1ze3JWdaihuSAsk6TrZ
</commit_message>
<xml_diff>
--- a/docs/presentations/Tokenized_Funds_Comparative_Analysis.pptx
+++ b/docs/presentations/Tokenized_Funds_Comparative_Analysis.pptx
@@ -23753,6 +23753,484 @@
                           <a:ea typeface="Calibri" pitchFamily="34" charset="-122"/>
                           <a:cs typeface="Calibri" pitchFamily="34" charset="-120"/>
                         </a:rPr>
+                        <a:t>Collateral agreement mechanism</a:t>
+                      </a:r>
+                      <a:endParaRPr lang="en-US" sz="830" dirty="0">
+                        <a:latin typeface="Calibri" charset="0"/>
+                        <a:ea typeface="Calibri" charset="0"/>
+                        <a:cs typeface="Calibri" charset="0"/>
+                      </a:endParaRPr>
+                    </a:p>
+                  </a:txBody>
+                  <a:tcPr marL="76200" marR="76200" marT="38100" marB="38100" anchor="ctr">
+                    <a:lnL w="9525" cap="flat" cmpd="sng" algn="ctr">
+                      <a:solidFill>
+                        <a:srgbClr val="D7E1F5"/>
+                      </a:solidFill>
+                      <a:prstDash val="solid"/>
+                      <a:round/>
+                      <a:headEnd type="none" w="med" len="med"/>
+                      <a:tailEnd type="none" w="med" len="med"/>
+                    </a:lnL>
+                    <a:lnR w="9525" cap="flat" cmpd="sng" algn="ctr">
+                      <a:solidFill>
+                        <a:srgbClr val="D7E1F5"/>
+                      </a:solidFill>
+                      <a:prstDash val="solid"/>
+                      <a:round/>
+                      <a:headEnd type="none" w="med" len="med"/>
+                      <a:tailEnd type="none" w="med" len="med"/>
+                    </a:lnR>
+                    <a:lnT w="9525" cap="flat" cmpd="sng" algn="ctr">
+                      <a:solidFill>
+                        <a:srgbClr val="D7E1F5"/>
+                      </a:solidFill>
+                      <a:prstDash val="solid"/>
+                      <a:round/>
+                      <a:headEnd type="none" w="med" len="med"/>
+                      <a:tailEnd type="none" w="med" len="med"/>
+                    </a:lnT>
+                    <a:lnB w="9525" cap="flat" cmpd="sng" algn="ctr">
+                      <a:solidFill>
+                        <a:srgbClr val="D7E1F5"/>
+                      </a:solidFill>
+                      <a:prstDash val="solid"/>
+                      <a:round/>
+                      <a:headEnd type="none" w="med" len="med"/>
+                      <a:tailEnd type="none" w="med" len="med"/>
+                    </a:lnB>
+                    <a:solidFill>
+                      <a:srgbClr val="FFFFFF"/>
+                    </a:solidFill>
+                  </a:tcPr>
+                </a:tc>
+                <a:tc>
+                  <a:txBody>
+                    <a:bodyPr/>
+                    <a:lstStyle/>
+                    <a:p>
+                      <a:pPr algn="ctr" indent="0" marL="0">
+                        <a:buNone/>
+                      </a:pPr>
+                      <a:r>
+                        <a:rPr lang="en-US" sz="830" dirty="0">
+                          <a:solidFill>
+                            <a:srgbClr val="3A4566"/>
+                          </a:solidFill>
+                          <a:latin typeface="Calibri" pitchFamily="34" charset="0"/>
+                          <a:ea typeface="Calibri" pitchFamily="34" charset="-122"/>
+                          <a:cs typeface="Calibri" pitchFamily="34" charset="-120"/>
+                        </a:rPr>
+                        <a:t>Off-chain (UCC Art. 8)</a:t>
+                      </a:r>
+                      <a:endParaRPr lang="en-US" sz="830" dirty="0">
+                        <a:latin typeface="Calibri" charset="0"/>
+                        <a:ea typeface="Calibri" charset="0"/>
+                        <a:cs typeface="Calibri" charset="0"/>
+                      </a:endParaRPr>
+                    </a:p>
+                  </a:txBody>
+                  <a:tcPr marL="76200" marR="76200" marT="38100" marB="38100" anchor="ctr">
+                    <a:lnL w="9525" cap="flat" cmpd="sng" algn="ctr">
+                      <a:solidFill>
+                        <a:srgbClr val="D7E1F5"/>
+                      </a:solidFill>
+                      <a:prstDash val="solid"/>
+                      <a:round/>
+                      <a:headEnd type="none" w="med" len="med"/>
+                      <a:tailEnd type="none" w="med" len="med"/>
+                    </a:lnL>
+                    <a:lnR w="9525" cap="flat" cmpd="sng" algn="ctr">
+                      <a:solidFill>
+                        <a:srgbClr val="D7E1F5"/>
+                      </a:solidFill>
+                      <a:prstDash val="solid"/>
+                      <a:round/>
+                      <a:headEnd type="none" w="med" len="med"/>
+                      <a:tailEnd type="none" w="med" len="med"/>
+                    </a:lnR>
+                    <a:lnT w="9525" cap="flat" cmpd="sng" algn="ctr">
+                      <a:solidFill>
+                        <a:srgbClr val="D7E1F5"/>
+                      </a:solidFill>
+                      <a:prstDash val="solid"/>
+                      <a:round/>
+                      <a:headEnd type="none" w="med" len="med"/>
+                      <a:tailEnd type="none" w="med" len="med"/>
+                    </a:lnT>
+                    <a:lnB w="9525" cap="flat" cmpd="sng" algn="ctr">
+                      <a:solidFill>
+                        <a:srgbClr val="D7E1F5"/>
+                      </a:solidFill>
+                      <a:prstDash val="solid"/>
+                      <a:round/>
+                      <a:headEnd type="none" w="med" len="med"/>
+                      <a:tailEnd type="none" w="med" len="med"/>
+                    </a:lnB>
+                    <a:solidFill>
+                      <a:srgbClr val="FFFFFF"/>
+                    </a:solidFill>
+                  </a:tcPr>
+                </a:tc>
+                <a:tc>
+                  <a:txBody>
+                    <a:bodyPr/>
+                    <a:lstStyle/>
+                    <a:p>
+                      <a:pPr algn="ctr" indent="0" marL="0">
+                        <a:buNone/>
+                      </a:pPr>
+                      <a:r>
+                        <a:rPr lang="en-US" sz="830" dirty="0">
+                          <a:solidFill>
+                            <a:srgbClr val="3A4566"/>
+                          </a:solidFill>
+                          <a:latin typeface="Calibri" pitchFamily="34" charset="0"/>
+                          <a:ea typeface="Calibri" pitchFamily="34" charset="-122"/>
+                          <a:cs typeface="Calibri" pitchFamily="34" charset="-120"/>
+                        </a:rPr>
+                        <a:t>On-chain (Allowlist escrow)</a:t>
+                      </a:r>
+                      <a:endParaRPr lang="en-US" sz="830" dirty="0">
+                        <a:latin typeface="Calibri" charset="0"/>
+                        <a:ea typeface="Calibri" charset="0"/>
+                        <a:cs typeface="Calibri" charset="0"/>
+                      </a:endParaRPr>
+                    </a:p>
+                  </a:txBody>
+                  <a:tcPr marL="76200" marR="76200" marT="38100" marB="38100" anchor="ctr">
+                    <a:lnL w="9525" cap="flat" cmpd="sng" algn="ctr">
+                      <a:solidFill>
+                        <a:srgbClr val="D7E1F5"/>
+                      </a:solidFill>
+                      <a:prstDash val="solid"/>
+                      <a:round/>
+                      <a:headEnd type="none" w="med" len="med"/>
+                      <a:tailEnd type="none" w="med" len="med"/>
+                    </a:lnL>
+                    <a:lnR w="9525" cap="flat" cmpd="sng" algn="ctr">
+                      <a:solidFill>
+                        <a:srgbClr val="D7E1F5"/>
+                      </a:solidFill>
+                      <a:prstDash val="solid"/>
+                      <a:round/>
+                      <a:headEnd type="none" w="med" len="med"/>
+                      <a:tailEnd type="none" w="med" len="med"/>
+                    </a:lnR>
+                    <a:lnT w="9525" cap="flat" cmpd="sng" algn="ctr">
+                      <a:solidFill>
+                        <a:srgbClr val="D7E1F5"/>
+                      </a:solidFill>
+                      <a:prstDash val="solid"/>
+                      <a:round/>
+                      <a:headEnd type="none" w="med" len="med"/>
+                      <a:tailEnd type="none" w="med" len="med"/>
+                    </a:lnT>
+                    <a:lnB w="9525" cap="flat" cmpd="sng" algn="ctr">
+                      <a:solidFill>
+                        <a:srgbClr val="D7E1F5"/>
+                      </a:solidFill>
+                      <a:prstDash val="solid"/>
+                      <a:round/>
+                      <a:headEnd type="none" w="med" len="med"/>
+                      <a:tailEnd type="none" w="med" len="med"/>
+                    </a:lnB>
+                    <a:solidFill>
+                      <a:srgbClr val="FFFFFF"/>
+                    </a:solidFill>
+                  </a:tcPr>
+                </a:tc>
+                <a:tc>
+                  <a:txBody>
+                    <a:bodyPr/>
+                    <a:lstStyle/>
+                    <a:p>
+                      <a:pPr algn="ctr" indent="0" marL="0">
+                        <a:buNone/>
+                      </a:pPr>
+                      <a:r>
+                        <a:rPr lang="en-US" sz="830" dirty="0">
+                          <a:solidFill>
+                            <a:srgbClr val="3A4566"/>
+                          </a:solidFill>
+                          <a:latin typeface="Calibri" pitchFamily="34" charset="0"/>
+                          <a:ea typeface="Calibri" pitchFamily="34" charset="-122"/>
+                          <a:cs typeface="Calibri" pitchFamily="34" charset="-120"/>
+                        </a:rPr>
+                        <a:t>On-chain (Allowlist escrow)</a:t>
+                      </a:r>
+                      <a:endParaRPr lang="en-US" sz="830" dirty="0">
+                        <a:latin typeface="Calibri" charset="0"/>
+                        <a:ea typeface="Calibri" charset="0"/>
+                        <a:cs typeface="Calibri" charset="0"/>
+                      </a:endParaRPr>
+                    </a:p>
+                  </a:txBody>
+                  <a:tcPr marL="76200" marR="76200" marT="38100" marB="38100" anchor="ctr">
+                    <a:lnL w="9525" cap="flat" cmpd="sng" algn="ctr">
+                      <a:solidFill>
+                        <a:srgbClr val="D7E1F5"/>
+                      </a:solidFill>
+                      <a:prstDash val="solid"/>
+                      <a:round/>
+                      <a:headEnd type="none" w="med" len="med"/>
+                      <a:tailEnd type="none" w="med" len="med"/>
+                    </a:lnL>
+                    <a:lnR w="9525" cap="flat" cmpd="sng" algn="ctr">
+                      <a:solidFill>
+                        <a:srgbClr val="D7E1F5"/>
+                      </a:solidFill>
+                      <a:prstDash val="solid"/>
+                      <a:round/>
+                      <a:headEnd type="none" w="med" len="med"/>
+                      <a:tailEnd type="none" w="med" len="med"/>
+                    </a:lnR>
+                    <a:lnT w="9525" cap="flat" cmpd="sng" algn="ctr">
+                      <a:solidFill>
+                        <a:srgbClr val="D7E1F5"/>
+                      </a:solidFill>
+                      <a:prstDash val="solid"/>
+                      <a:round/>
+                      <a:headEnd type="none" w="med" len="med"/>
+                      <a:tailEnd type="none" w="med" len="med"/>
+                    </a:lnT>
+                    <a:lnB w="9525" cap="flat" cmpd="sng" algn="ctr">
+                      <a:solidFill>
+                        <a:srgbClr val="D7E1F5"/>
+                      </a:solidFill>
+                      <a:prstDash val="solid"/>
+                      <a:round/>
+                      <a:headEnd type="none" w="med" len="med"/>
+                      <a:tailEnd type="none" w="med" len="med"/>
+                    </a:lnB>
+                    <a:solidFill>
+                      <a:srgbClr val="FFFFFF"/>
+                    </a:solidFill>
+                  </a:tcPr>
+                </a:tc>
+                <a:tc>
+                  <a:txBody>
+                    <a:bodyPr/>
+                    <a:lstStyle/>
+                    <a:p>
+                      <a:pPr algn="ctr" indent="0" marL="0">
+                        <a:buNone/>
+                      </a:pPr>
+                      <a:r>
+                        <a:rPr lang="en-US" sz="830" dirty="0">
+                          <a:solidFill>
+                            <a:srgbClr val="3A4566"/>
+                          </a:solidFill>
+                          <a:latin typeface="Calibri" pitchFamily="34" charset="0"/>
+                          <a:ea typeface="Calibri" pitchFamily="34" charset="-122"/>
+                          <a:cs typeface="Calibri" pitchFamily="34" charset="-120"/>
+                        </a:rPr>
+                        <a:t>On-chain (Allowlist escrow)</a:t>
+                      </a:r>
+                      <a:endParaRPr lang="en-US" sz="830" dirty="0">
+                        <a:latin typeface="Calibri" charset="0"/>
+                        <a:ea typeface="Calibri" charset="0"/>
+                        <a:cs typeface="Calibri" charset="0"/>
+                      </a:endParaRPr>
+                    </a:p>
+                  </a:txBody>
+                  <a:tcPr marL="76200" marR="76200" marT="38100" marB="38100" anchor="ctr">
+                    <a:lnL w="9525" cap="flat" cmpd="sng" algn="ctr">
+                      <a:solidFill>
+                        <a:srgbClr val="D7E1F5"/>
+                      </a:solidFill>
+                      <a:prstDash val="solid"/>
+                      <a:round/>
+                      <a:headEnd type="none" w="med" len="med"/>
+                      <a:tailEnd type="none" w="med" len="med"/>
+                    </a:lnL>
+                    <a:lnR w="9525" cap="flat" cmpd="sng" algn="ctr">
+                      <a:solidFill>
+                        <a:srgbClr val="D7E1F5"/>
+                      </a:solidFill>
+                      <a:prstDash val="solid"/>
+                      <a:round/>
+                      <a:headEnd type="none" w="med" len="med"/>
+                      <a:tailEnd type="none" w="med" len="med"/>
+                    </a:lnR>
+                    <a:lnT w="9525" cap="flat" cmpd="sng" algn="ctr">
+                      <a:solidFill>
+                        <a:srgbClr val="D7E1F5"/>
+                      </a:solidFill>
+                      <a:prstDash val="solid"/>
+                      <a:round/>
+                      <a:headEnd type="none" w="med" len="med"/>
+                      <a:tailEnd type="none" w="med" len="med"/>
+                    </a:lnT>
+                    <a:lnB w="9525" cap="flat" cmpd="sng" algn="ctr">
+                      <a:solidFill>
+                        <a:srgbClr val="D7E1F5"/>
+                      </a:solidFill>
+                      <a:prstDash val="solid"/>
+                      <a:round/>
+                      <a:headEnd type="none" w="med" len="med"/>
+                      <a:tailEnd type="none" w="med" len="med"/>
+                    </a:lnB>
+                    <a:solidFill>
+                      <a:srgbClr val="FFFFFF"/>
+                    </a:solidFill>
+                  </a:tcPr>
+                </a:tc>
+                <a:tc>
+                  <a:txBody>
+                    <a:bodyPr/>
+                    <a:lstStyle/>
+                    <a:p>
+                      <a:pPr algn="ctr" indent="0" marL="0">
+                        <a:buNone/>
+                      </a:pPr>
+                      <a:r>
+                        <a:rPr lang="en-US" sz="830" dirty="0">
+                          <a:solidFill>
+                            <a:srgbClr val="3A4566"/>
+                          </a:solidFill>
+                          <a:latin typeface="Calibri" pitchFamily="34" charset="0"/>
+                          <a:ea typeface="Calibri" pitchFamily="34" charset="-122"/>
+                          <a:cs typeface="Calibri" pitchFamily="34" charset="-120"/>
+                        </a:rPr>
+                        <a:t>On-chain (Allowlist, fTokens)</a:t>
+                      </a:r>
+                      <a:endParaRPr lang="en-US" sz="830" dirty="0">
+                        <a:latin typeface="Calibri" charset="0"/>
+                        <a:ea typeface="Calibri" charset="0"/>
+                        <a:cs typeface="Calibri" charset="0"/>
+                      </a:endParaRPr>
+                    </a:p>
+                  </a:txBody>
+                  <a:tcPr marL="76200" marR="76200" marT="38100" marB="38100" anchor="ctr">
+                    <a:lnL w="9525" cap="flat" cmpd="sng" algn="ctr">
+                      <a:solidFill>
+                        <a:srgbClr val="D7E1F5"/>
+                      </a:solidFill>
+                      <a:prstDash val="solid"/>
+                      <a:round/>
+                      <a:headEnd type="none" w="med" len="med"/>
+                      <a:tailEnd type="none" w="med" len="med"/>
+                    </a:lnL>
+                    <a:lnR w="9525" cap="flat" cmpd="sng" algn="ctr">
+                      <a:solidFill>
+                        <a:srgbClr val="D7E1F5"/>
+                      </a:solidFill>
+                      <a:prstDash val="solid"/>
+                      <a:round/>
+                      <a:headEnd type="none" w="med" len="med"/>
+                      <a:tailEnd type="none" w="med" len="med"/>
+                    </a:lnR>
+                    <a:lnT w="9525" cap="flat" cmpd="sng" algn="ctr">
+                      <a:solidFill>
+                        <a:srgbClr val="D7E1F5"/>
+                      </a:solidFill>
+                      <a:prstDash val="solid"/>
+                      <a:round/>
+                      <a:headEnd type="none" w="med" len="med"/>
+                      <a:tailEnd type="none" w="med" len="med"/>
+                    </a:lnT>
+                    <a:lnB w="9525" cap="flat" cmpd="sng" algn="ctr">
+                      <a:solidFill>
+                        <a:srgbClr val="D7E1F5"/>
+                      </a:solidFill>
+                      <a:prstDash val="solid"/>
+                      <a:round/>
+                      <a:headEnd type="none" w="med" len="med"/>
+                      <a:tailEnd type="none" w="med" len="med"/>
+                    </a:lnB>
+                    <a:solidFill>
+                      <a:srgbClr val="FFFFFF"/>
+                    </a:solidFill>
+                  </a:tcPr>
+                </a:tc>
+                <a:tc>
+                  <a:txBody>
+                    <a:bodyPr/>
+                    <a:lstStyle/>
+                    <a:p>
+                      <a:pPr algn="ctr" indent="0" marL="0">
+                        <a:buNone/>
+                      </a:pPr>
+                      <a:r>
+                        <a:rPr lang="en-US" sz="830" dirty="0">
+                          <a:solidFill>
+                            <a:srgbClr val="3A4566"/>
+                          </a:solidFill>
+                          <a:latin typeface="Calibri" pitchFamily="34" charset="0"/>
+                          <a:ea typeface="Calibri" pitchFamily="34" charset="-122"/>
+                          <a:cs typeface="Calibri" pitchFamily="34" charset="-120"/>
+                        </a:rPr>
+                        <a:t>On-chain (DeFi vault reserve)</a:t>
+                      </a:r>
+                      <a:endParaRPr lang="en-US" sz="830" dirty="0">
+                        <a:latin typeface="Calibri" charset="0"/>
+                        <a:ea typeface="Calibri" charset="0"/>
+                        <a:cs typeface="Calibri" charset="0"/>
+                      </a:endParaRPr>
+                    </a:p>
+                  </a:txBody>
+                  <a:tcPr marL="76200" marR="76200" marT="38100" marB="38100" anchor="ctr">
+                    <a:lnL w="9525" cap="flat" cmpd="sng" algn="ctr">
+                      <a:solidFill>
+                        <a:srgbClr val="D7E1F5"/>
+                      </a:solidFill>
+                      <a:prstDash val="solid"/>
+                      <a:round/>
+                      <a:headEnd type="none" w="med" len="med"/>
+                      <a:tailEnd type="none" w="med" len="med"/>
+                    </a:lnL>
+                    <a:lnR w="9525" cap="flat" cmpd="sng" algn="ctr">
+                      <a:solidFill>
+                        <a:srgbClr val="D7E1F5"/>
+                      </a:solidFill>
+                      <a:prstDash val="solid"/>
+                      <a:round/>
+                      <a:headEnd type="none" w="med" len="med"/>
+                      <a:tailEnd type="none" w="med" len="med"/>
+                    </a:lnR>
+                    <a:lnT w="9525" cap="flat" cmpd="sng" algn="ctr">
+                      <a:solidFill>
+                        <a:srgbClr val="D7E1F5"/>
+                      </a:solidFill>
+                      <a:prstDash val="solid"/>
+                      <a:round/>
+                      <a:headEnd type="none" w="med" len="med"/>
+                      <a:tailEnd type="none" w="med" len="med"/>
+                    </a:lnT>
+                    <a:lnB w="9525" cap="flat" cmpd="sng" algn="ctr">
+                      <a:solidFill>
+                        <a:srgbClr val="D7E1F5"/>
+                      </a:solidFill>
+                      <a:prstDash val="solid"/>
+                      <a:round/>
+                      <a:headEnd type="none" w="med" len="med"/>
+                      <a:tailEnd type="none" w="med" len="med"/>
+                    </a:lnB>
+                    <a:solidFill>
+                      <a:srgbClr val="FFFFFF"/>
+                    </a:solidFill>
+                  </a:tcPr>
+                </a:tc>
+              </a:tr>
+              <a:tr h="0">
+                <a:tc>
+                  <a:txBody>
+                    <a:bodyPr/>
+                    <a:lstStyle/>
+                    <a:p>
+                      <a:pPr algn="l" indent="0" marL="0">
+                        <a:buNone/>
+                      </a:pPr>
+                      <a:r>
+                        <a:rPr lang="en-US" sz="830" b="1" dirty="0">
+                          <a:solidFill>
+                            <a:srgbClr val="1E2761"/>
+                          </a:solidFill>
+                          <a:latin typeface="Calibri" pitchFamily="34" charset="0"/>
+                          <a:ea typeface="Calibri" pitchFamily="34" charset="-122"/>
+                          <a:cs typeface="Calibri" pitchFamily="34" charset="-120"/>
+                        </a:rPr>
                         <a:t>Settlement rail</a:t>
                       </a:r>
                       <a:endParaRPr lang="en-US" sz="830" dirty="0">
@@ -23800,7 +24278,7 @@
                       <a:tailEnd type="none" w="med" len="med"/>
                     </a:lnB>
                     <a:solidFill>
-                      <a:srgbClr val="FFFFFF"/>
+                      <a:srgbClr val="F5F8FD"/>
                     </a:solidFill>
                   </a:tcPr>
                 </a:tc>
@@ -23868,7 +24346,7 @@
                       <a:tailEnd type="none" w="med" len="med"/>
                     </a:lnB>
                     <a:solidFill>
-                      <a:srgbClr val="FFFFFF"/>
+                      <a:srgbClr val="F5F8FD"/>
                     </a:solidFill>
                   </a:tcPr>
                 </a:tc>
@@ -23936,7 +24414,7 @@
                       <a:tailEnd type="none" w="med" len="med"/>
                     </a:lnB>
                     <a:solidFill>
-                      <a:srgbClr val="FFFFFF"/>
+                      <a:srgbClr val="F5F8FD"/>
                     </a:solidFill>
                   </a:tcPr>
                 </a:tc>
@@ -24004,7 +24482,7 @@
                       <a:tailEnd type="none" w="med" len="med"/>
                     </a:lnB>
                     <a:solidFill>
-                      <a:srgbClr val="FFFFFF"/>
+                      <a:srgbClr val="F5F8FD"/>
                     </a:solidFill>
                   </a:tcPr>
                 </a:tc>
@@ -24072,7 +24550,7 @@
                       <a:tailEnd type="none" w="med" len="med"/>
                     </a:lnB>
                     <a:solidFill>
-                      <a:srgbClr val="FFFFFF"/>
+                      <a:srgbClr val="F5F8FD"/>
                     </a:solidFill>
                   </a:tcPr>
                 </a:tc>
@@ -24140,7 +24618,7 @@
                       <a:tailEnd type="none" w="med" len="med"/>
                     </a:lnB>
                     <a:solidFill>
-                      <a:srgbClr val="FFFFFF"/>
+                      <a:srgbClr val="F5F8FD"/>
                     </a:solidFill>
                   </a:tcPr>
                 </a:tc>
@@ -24208,7 +24686,7 @@
                       <a:tailEnd type="none" w="med" len="med"/>
                     </a:lnB>
                     <a:solidFill>
-                      <a:srgbClr val="FFFFFF"/>
+                      <a:srgbClr val="F5F8FD"/>
                     </a:solidFill>
                   </a:tcPr>
                 </a:tc>
@@ -24278,7 +24756,7 @@
                       <a:tailEnd type="none" w="med" len="med"/>
                     </a:lnB>
                     <a:solidFill>
-                      <a:srgbClr val="F5F8FD"/>
+                      <a:srgbClr val="FFFFFF"/>
                     </a:solidFill>
                   </a:tcPr>
                 </a:tc>
@@ -24346,7 +24824,7 @@
                       <a:tailEnd type="none" w="med" len="med"/>
                     </a:lnB>
                     <a:solidFill>
-                      <a:srgbClr val="F5F8FD"/>
+                      <a:srgbClr val="FFFFFF"/>
                     </a:solidFill>
                   </a:tcPr>
                 </a:tc>
@@ -24414,7 +24892,7 @@
                       <a:tailEnd type="none" w="med" len="med"/>
                     </a:lnB>
                     <a:solidFill>
-                      <a:srgbClr val="F5F8FD"/>
+                      <a:srgbClr val="FFFFFF"/>
                     </a:solidFill>
                   </a:tcPr>
                 </a:tc>
@@ -24482,7 +24960,7 @@
                       <a:tailEnd type="none" w="med" len="med"/>
                     </a:lnB>
                     <a:solidFill>
-                      <a:srgbClr val="F5F8FD"/>
+                      <a:srgbClr val="FFFFFF"/>
                     </a:solidFill>
                   </a:tcPr>
                 </a:tc>
@@ -24550,7 +25028,7 @@
                       <a:tailEnd type="none" w="med" len="med"/>
                     </a:lnB>
                     <a:solidFill>
-                      <a:srgbClr val="F5F8FD"/>
+                      <a:srgbClr val="FFFFFF"/>
                     </a:solidFill>
                   </a:tcPr>
                 </a:tc>
@@ -24618,7 +25096,7 @@
                       <a:tailEnd type="none" w="med" len="med"/>
                     </a:lnB>
                     <a:solidFill>
-                      <a:srgbClr val="F5F8FD"/>
+                      <a:srgbClr val="FFFFFF"/>
                     </a:solidFill>
                   </a:tcPr>
                 </a:tc>
@@ -24686,7 +25164,7 @@
                       <a:tailEnd type="none" w="med" len="med"/>
                     </a:lnB>
                     <a:solidFill>
-                      <a:srgbClr val="F5F8FD"/>
+                      <a:srgbClr val="FFFFFF"/>
                     </a:solidFill>
                   </a:tcPr>
                 </a:tc>

</xml_diff>